<commit_message>
Level 1 branding, Course levels menu, book in English and Vietnamese
Co-Authored-By: Claude Opus 5.5 <noreply@anthropic.com>
</commit_message>
<xml_diff>
--- a/en/files/slides/Session_1_EN.pptx
+++ b/en/files/slides/Session_1_EN.pptx
@@ -3059,7 +3059,7 @@
           <a:p>
             <a:r>
               <a:rPr lang="en-US" sz="1400" b="0" dirty="0"/>
-              <a:t>Weekends 1-2 are what we call Level 1 (understand and design); Weekends 3-4 are Level 2 (analyse and publish) - in one course.</a:t>
+              <a:t>This whole course is Level 1: it covers every step from question to publication. Weeks 1-2 build understanding and design skills; Weekends 3-4 apply them to data, writing and publishing.</a:t>
             </a:r>
           </a:p>
           <a:p>
@@ -4220,13 +4220,13 @@
           <a:p>
             <a:r>
               <a:rPr lang="en-US" sz="1400" b="0" dirty="0"/>
-              <a:t>Level 1 concepts come first: reading papers critically, asking a good question, designing a sound study.</a:t>
+              <a:t>This course (Level 1) takes you from a clinical question to a published paper. Level 2 is a hands-on course in R for those who want to run analyses themselves; Level 3 covers advanced, specialised methods.</a:t>
             </a:r>
           </a:p>
           <a:p>
             <a:r>
               <a:rPr lang="en-US" sz="1400" b="0" dirty="0"/>
-              <a:t>Level 2 uses those concepts on a realistic dataset of 600 ICU patients: we describe it, analyse it and write it up. The trainers run the software; you read and interpret the results.</a:t>
+              <a:t>Within Level 1 we use a realistic dataset of 620 ICU patients: we describe it, analyse it and write it up. The trainers run the software; you read and interpret the results.</a:t>
             </a:r>
           </a:p>
           <a:p>
@@ -9470,7 +9470,7 @@
                 <a:latin typeface="Segoe UI"/>
                 <a:cs typeface="Segoe UI"/>
               </a:rPr>
-              <a:t>From Clinical Question to Publication</a:t>
+              <a:t>Level 1  -  From Clinical Question to Publication</a:t>
             </a:r>
           </a:p>
           <a:p>
@@ -22540,7 +22540,7 @@
                 <a:latin typeface="Century Gothic"/>
                 <a:cs typeface="Century Gothic"/>
               </a:rPr>
-              <a:t>First understand and design research - then analyse a dataset and write the paper.</a:t>
+              <a:t>Level 1 is this course; Level 2 is hands-on analysis in R; Level 3 is advanced methods.</a:t>
             </a:r>
           </a:p>
         </p:txBody>

</xml_diff>

<commit_message>
Level 1 schedule: every Saturday for 8 weeks
Co-Authored-By: Claude Opus 5.5 <noreply@anthropic.com>
</commit_message>
<xml_diff>
--- a/en/files/slides/Session_1_EN.pptx
+++ b/en/files/slides/Session_1_EN.pptx
@@ -755,7 +755,7 @@
           <a:p>
             <a:r>
               <a:rPr lang="en-US" sz="1400" b="0" dirty="0"/>
-              <a:t>Key message: over four weekends we walk the whole road of research together - from a question at the bedside to a paper ready to submit.</a:t>
+              <a:t>Key message: over eight Saturdays - one session a week - we walk the whole road of research together - from a question at the bedside to a paper ready to submit.</a:t>
             </a:r>
           </a:p>
           <a:p>
@@ -1040,7 +1040,7 @@
           <a:p>
             <a:r>
               <a:rPr lang="en-US" sz="1400" b="0" dirty="0"/>
-              <a:t>Teaching point: today has one job - every group leaves with ONE clear, answerable research question and an aim with objectives. Tomorrow (Session 2) we search and read the literature for it.</a:t>
+              <a:t>Teaching point: today has one job - every group leaves with ONE clear, answerable research question and an aim with objectives. Next Saturday (Session 2) we search and read the literature for it.</a:t>
             </a:r>
           </a:p>
           <a:p>
@@ -1700,7 +1700,7 @@
           <a:p>
             <a:r>
               <a:rPr lang="en-US" sz="1400" b="0" dirty="0"/>
-              <a:t>This weekend = clinical problem and research question (today), literature search (tomorrow) - the three teal boxes top right.</a:t>
+              <a:t>Weeks 1-2 = clinical problem and research question (today), literature search (next Saturday) - the three teal boxes top right.</a:t>
             </a:r>
           </a:p>
           <a:p>
@@ -2522,7 +2522,7 @@
           <a:p>
             <a:r>
               <a:rPr lang="en-US" sz="1400" b="0" dirty="0"/>
-              <a:t>Eleven stops from question to impact. The colours show which weekend of the course teaches each stop.</a:t>
+              <a:t>Eleven stops from question to impact. The colours show which weeks of the course teach each stop.</a:t>
             </a:r>
           </a:p>
           <a:p>
@@ -2843,7 +2843,7 @@
           <a:p>
             <a:r>
               <a:rPr lang="en-US" sz="1400" b="0" dirty="0"/>
-              <a:t>Teaching point: 'how we find out' is the literature search - that is tomorrow's Session 2.</a:t>
+              <a:t>Teaching point: 'how we find out' is the literature search - that is next Saturday's Session 2.</a:t>
             </a:r>
           </a:p>
           <a:p>
@@ -3053,13 +3053,13 @@
           <a:p>
             <a:r>
               <a:rPr lang="en-US" sz="1400" b="0" dirty="0"/>
-              <a:t>Walk along the road: Weekend 1 the question and the evidence; Weekend 2 design and bias; Weekend 3 data and analysis; Weekend 4 ethics, writing and publishing.</a:t>
+              <a:t>Walk along the road: Weeks 1-2 the question and the evidence; Weeks 3-4 design and bias; Weeks 5-6 data and analysis; Weeks 7-8 ethics, writing and publishing. One session every Saturday, with a full week between sessions for the homework.</a:t>
             </a:r>
           </a:p>
           <a:p>
             <a:r>
               <a:rPr lang="en-US" sz="1400" b="0" dirty="0"/>
-              <a:t>This whole course is Level 1: it covers every step from question to publication. Weeks 1-2 build understanding and design skills; Weekends 3-4 apply them to data, writing and publishing.</a:t>
+              <a:t>This whole course is Level 1: it covers every step from question to publication. Weeks 1-4 build understanding and design skills; Weeks 5-8 apply them to data, writing and publishing.</a:t>
             </a:r>
           </a:p>
           <a:p>
@@ -4745,7 +4745,7 @@
           <a:p>
             <a:r>
               <a:rPr lang="en-US" sz="1400" b="0" dirty="0"/>
-              <a:t>The search, the 5 references, the problem statement and the working title are tomorrow (Proposal builder 2).</a:t>
+              <a:t>The search, the 5 references, the problem statement and the working title are next Saturday (Proposal builder 2).</a:t>
             </a:r>
           </a:p>
           <a:p>
@@ -5054,7 +5054,7 @@
           <a:p>
             <a:r>
               <a:rPr lang="en-US" sz="1400" b="0" dirty="0"/>
-              <a:t>Link forward: tomorrow (Session 2) we search PubMed for each group's question, manage references, and learn to read a paper in 15 minutes.</a:t>
+              <a:t>Link forward: next Saturday (Session 2) we search PubMed for each group's question, manage references, and learn to read a paper in 15 minutes.</a:t>
             </a:r>
           </a:p>
           <a:p>
@@ -5147,7 +5147,7 @@
           <a:p>
             <a:r>
               <a:rPr lang="en-US" sz="1400" b="0" dirty="0"/>
-              <a:t>Read the notes tonight. If many still use vague verbs, open Session 2 with one extra minute on objectives.</a:t>
+              <a:t>Read the notes during the week. If many still use vague verbs, open Session 2 with one extra minute on objectives.</a:t>
             </a:r>
           </a:p>
           <a:p>
@@ -5234,19 +5234,19 @@
           <a:p>
             <a:r>
               <a:rPr lang="en-US" sz="1400" b="0" dirty="0"/>
-              <a:t>Keep it light: about 30 minutes tonight.</a:t>
+              <a:t>Keep it light: about 30 minutes during the week.</a:t>
             </a:r>
           </a:p>
           <a:p>
             <a:r>
               <a:rPr lang="en-US" sz="1400" b="0" dirty="0"/>
-              <a:t>The synonym list makes tomorrow's PubMed search much faster - PubMed searches in English.</a:t>
+              <a:t>The synonym list makes next Saturday's PubMed search much faster - PubMed searches in English.</a:t>
             </a:r>
           </a:p>
           <a:p>
             <a:r>
               <a:rPr lang="en-US" sz="1400" b="0" dirty="0"/>
-              <a:t>The 'local number' becomes paragraph 3 of the problem statement tomorrow.</a:t>
+              <a:t>The 'local number' becomes paragraph 3 of the problem statement next Saturday.</a:t>
             </a:r>
           </a:p>
           <a:p>
@@ -5339,13 +5339,13 @@
           <a:p>
             <a:r>
               <a:rPr lang="en-US" sz="1400" b="0" dirty="0"/>
-              <a:t>Product 1: a research proposal on the group's own question, built one part per weekend and presented in Session 8.</a:t>
+              <a:t>Product 1: a research proposal on the group's own question, built one part every two weeks and presented in Session 8.</a:t>
             </a:r>
           </a:p>
           <a:p>
             <a:r>
               <a:rPr lang="en-US" sz="1400" b="0" dirty="0"/>
-              <a:t>Product 2: a draft manuscript written from the course dataset (FLUID-ICU). Each group answers a different question on the same data. We analyse in Weekend 3, write in Weekend 4, and after the course groups review each other's drafts and reply like real authors.</a:t>
+              <a:t>Product 2: a draft manuscript written from the course dataset (FLUID-ICU). Each group answers a different question on the same data. We analyse in Weeks 5-6, write in Weeks 7-8, and after the course groups review each other's drafts and reply like real authors.</a:t>
             </a:r>
           </a:p>
           <a:p>
@@ -6026,7 +6026,7 @@
           <a:p>
             <a:r>
               <a:rPr lang="en-US" sz="1400" b="0" dirty="0"/>
-              <a:t>Walk across the four cards - one per weekend.</a:t>
+              <a:t>Walk across the four cards - one per two-week block.</a:t>
             </a:r>
           </a:p>
           <a:p>
@@ -6218,7 +6218,7 @@
           <a:p>
             <a:r>
               <a:rPr lang="en-US" sz="1400" b="0" dirty="0"/>
-              <a:t>Part 1 (Weekend 1): the question and the background. Part 2 (Weekend 2): the design. Part 3 (Weekend 3): the data and the analysis plan. Part 4 (Session 7): ethics, feasibility and a publication plan.</a:t>
+              <a:t>Part 1 (Weeks 1-2): the question and the background. Part 2 (Weeks 3-4): the design. Part 3 (Weeks 5-6): the data and the analysis plan. Part 4 (Session 7): ethics, feasibility and a publication plan.</a:t>
             </a:r>
           </a:p>
           <a:p>
@@ -9488,7 +9488,7 @@
                 <a:latin typeface="Segoe UI"/>
                 <a:cs typeface="Segoe UI"/>
               </a:rPr>
-              <a:t>8 sessions  -  4 weekends  -  24 contact hours</a:t>
+              <a:t>8 Saturdays  -  one session per week  -  24 contact hours</a:t>
             </a:r>
           </a:p>
           <a:p>
@@ -10923,7 +10923,7 @@
                 <a:latin typeface="Century Gothic"/>
                 <a:cs typeface="Century Gothic"/>
               </a:rPr>
-              <a:t>Weekend 1 · Saturday</a:t>
+              <a:t>Week 1 · Saturday</a:t>
             </a:r>
           </a:p>
           <a:p>
@@ -11043,7 +11043,7 @@
                 <a:latin typeface="Century Gothic"/>
                 <a:cs typeface="Century Gothic"/>
               </a:rPr>
-              <a:t>Wrap-up: key words, recap, homework for tomorrow</a:t>
+              <a:t>Wrap-up: key words, recap, homework for next Saturday</a:t>
             </a:r>
           </a:p>
         </p:txBody>
@@ -17774,7 +17774,7 @@
                 <a:latin typeface="Century Gothic"/>
                 <a:cs typeface="Century Gothic"/>
               </a:rPr>
-              <a:t>Four weekends, eight sessions</a:t>
+              <a:t>Eight Saturdays, eight sessions</a:t>
             </a:r>
           </a:p>
         </p:txBody>
@@ -26536,7 +26536,7 @@
                 <a:latin typeface="Century Gothic"/>
                 <a:cs typeface="Century Gothic"/>
               </a:rPr>
-              <a:t>Tomorrow: find and read what is already known about your question.</a:t>
+              <a:t>Next Saturday: find and read what is already known about your question.</a:t>
             </a:r>
           </a:p>
         </p:txBody>
@@ -26949,7 +26949,7 @@
                 <a:latin typeface="Century Gothic"/>
                 <a:cs typeface="Century Gothic"/>
               </a:rPr>
-              <a:t>One sticky note per person (we read them before tomorrow)</a:t>
+              <a:t>One sticky note per person (we read them before next Saturday)</a:t>
             </a:r>
           </a:p>
         </p:txBody>
@@ -27117,7 +27117,7 @@
                 <a:latin typeface="Century Gothic"/>
                 <a:cs typeface="Century Gothic"/>
               </a:rPr>
-              <a:t>Homework for tomorrow (Session 2)</a:t>
+              <a:t>Homework for next Saturday (Session 2)</a:t>
             </a:r>
           </a:p>
         </p:txBody>
@@ -27381,7 +27381,7 @@
                 <a:latin typeface="Century Gothic"/>
                 <a:cs typeface="Century Gothic"/>
               </a:rPr>
-              <a:t>Bring tomorrow</a:t>
+              <a:t>Bring next Saturday</a:t>
             </a:r>
           </a:p>
           <a:p>
@@ -27504,7 +27504,7 @@
                 <a:latin typeface="Century Gothic"/>
                 <a:cs typeface="Century Gothic"/>
               </a:rPr>
-              <a:t>PICO question ready for tomorrow's search</a:t>
+              <a:t>PICO question ready for next Saturday's search</a:t>
             </a:r>
           </a:p>
         </p:txBody>
@@ -31559,7 +31559,7 @@
                 <a:latin typeface="Century Gothic"/>
                 <a:cs typeface="Century Gothic"/>
               </a:rPr>
-              <a:t>Same group, same template, one part per weekend, presented in Session 8.</a:t>
+              <a:t>Same group, same template, one part every two weeks, presented in Session 8.</a:t>
             </a:r>
           </a:p>
         </p:txBody>
@@ -31915,7 +31915,7 @@
                 <a:latin typeface="Century Gothic"/>
                 <a:cs typeface="Century Gothic"/>
               </a:rPr>
-              <a:t>Agree the roles below - they can rotate each weekend</a:t>
+              <a:t>Agree the roles below - they can rotate each week</a:t>
             </a:r>
           </a:p>
           <a:p>

</xml_diff>

<commit_message>
Natural-writing style pass across the site
Co-Authored-By: Claude Opus 5.5 <noreply@anthropic.com>
</commit_message>
<xml_diff>
--- a/en/files/slides/Session_1_EN.pptx
+++ b/en/files/slides/Session_1_EN.pptx
@@ -755,13 +755,13 @@
           <a:p>
             <a:r>
               <a:rPr lang="en-US" sz="1400" b="0" dirty="0"/>
-              <a:t>Key message: over eight Saturdays - one session a week - we walk the whole road of research together - from a question at the bedside to a paper ready to submit.</a:t>
+              <a:t>Key message: over eight Saturdays, one session a week, we walk the whole road of research together: from a question at the bedside to a paper ready to submit.</a:t>
             </a:r>
           </a:p>
           <a:p>
             <a:r>
               <a:rPr lang="en-US" sz="1400" b="0" dirty="0"/>
-              <a:t>No statistics software, no formulas to memorise: pictures, examples from your own wards, and a lot of group work. We go slowly - nobody is expected to know anything yet.</a:t>
+              <a:t>No statistics software, no formulas to memorise: pictures, examples from your own wards, and a lot of group work. We go slowly. Nobody is expected to know anything yet.</a:t>
             </a:r>
           </a:p>
           <a:p>
@@ -854,7 +854,7 @@
           <a:p>
             <a:r>
               <a:rPr lang="en-US" sz="1400" b="0" dirty="0"/>
-              <a:t>Language: discussions can be in Vietnamese or English - whatever helps the group think.</a:t>
+              <a:t>Language: discussions can be in Vietnamese or English, whatever helps the group think.</a:t>
             </a:r>
           </a:p>
           <a:p>
@@ -953,7 +953,7 @@
           <a:p>
             <a:r>
               <a:rPr lang="en-US" sz="1400" b="0" dirty="0"/>
-              <a:t>Collect after 15 minutes. Do not give answers today - the same quiz is repeated at the end of Session 8.</a:t>
+              <a:t>Collect after 15 minutes. Do not give answers today. The same quiz is repeated at the end of Session 8.</a:t>
             </a:r>
           </a:p>
         </p:txBody>
@@ -1040,13 +1040,13 @@
           <a:p>
             <a:r>
               <a:rPr lang="en-US" sz="1400" b="0" dirty="0"/>
-              <a:t>Teaching point: today has one job - every group leaves with ONE clear, answerable research question and an aim with objectives. Next Saturday (Session 2) we search and read the literature for it.</a:t>
+              <a:t>Teaching point: today has one job: every group leaves with ONE clear, answerable research question and an aim with objectives. Next Saturday (Session 2) we search and read the literature for it.</a:t>
             </a:r>
           </a:p>
           <a:p>
             <a:r>
               <a:rPr lang="en-US" sz="1400" b="0" dirty="0"/>
-              <a:t>Pace: this audience has little or no research background. Go slowly, use the worked examples, and stop at every 'Check your understanding' slide - they are short on purpose.</a:t>
+              <a:t>Pace: this audience has little or no research background. Go slowly, use the worked examples, and stop at every 'Check your understanding' slide. They are short on purpose.</a:t>
             </a:r>
           </a:p>
           <a:p>
@@ -1058,7 +1058,7 @@
           <a:p>
             <a:r>
               <a:rPr lang="en-US" sz="1400" b="0" dirty="0"/>
-              <a:t>Ask the room: 'Who has ever taken part in a research study - as a researcher, data collector or participant?' Count hands; it tells you where to pitch the session.</a:t>
+              <a:t>Ask the room: 'Who has ever taken part in a research study, as a researcher, data collector or participant?' Count hands; it tells you where to pitch the session.</a:t>
             </a:r>
           </a:p>
           <a:p>
@@ -1274,13 +1274,13 @@
           <a:p>
             <a:r>
               <a:rPr lang="en-US" sz="1400" b="0" dirty="0"/>
-              <a:t>Ask the room: 'Why do we remember the three good outcomes?' Expected answer: recall bias - dramatic and recent cases stick; we forget the failures.</a:t>
+              <a:t>Ask the room: 'Why do we remember the three good outcomes?' Expected answer: recall bias. Dramatic and recent cases stick, and we forget the failures.</a:t>
             </a:r>
           </a:p>
           <a:p>
             <a:r>
               <a:rPr lang="en-US" sz="1400" b="0" dirty="0"/>
-              <a:t>Timing: 4 minutes. Go slowly - this is the idea the whole course rests on.</a:t>
+              <a:t>Timing: 4 minutes. Go slowly: this is the idea the whole course rests on.</a:t>
             </a:r>
           </a:p>
         </p:txBody>
@@ -1373,13 +1373,13 @@
           <a:p>
             <a:r>
               <a:rPr lang="en-US" sz="1400" b="0" dirty="0"/>
-              <a:t>Middle row: groups of 50 - closer to the truth but still scattered. Bottom row: groups of 500 cluster tightly around 40%.</a:t>
+              <a:t>Middle row: groups of 50, closer to the truth but still scattered. Bottom row: groups of 500 cluster tightly around 40%.</a:t>
             </a:r>
           </a:p>
           <a:p>
             <a:r>
               <a:rPr lang="en-US" sz="1400" b="0" dirty="0"/>
-              <a:t>Teaching point: chance alone produces impressive-looking differences in small numbers. This is why research needs enough patients and a comparison group - and why 'my last three patients' can mislead.</a:t>
+              <a:t>Teaching point: chance alone produces impressive-looking differences in small numbers. This is why research needs enough patients and a comparison group, and why 'my last three patients' can mislead.</a:t>
             </a:r>
           </a:p>
           <a:p>
@@ -1391,7 +1391,7 @@
           <a:p>
             <a:r>
               <a:rPr lang="en-US" sz="1400" b="0" dirty="0"/>
-              <a:t>Ask the room: 'One ward lost 0 of 5 patients after a new protocol. Does the protocol work?' Expected answer: we cannot tell - 0 of 5 happens often by chance even when the true risk is 40%.</a:t>
+              <a:t>Ask the room: 'One ward lost 0 of 5 patients after a new protocol. Does the protocol work?' Expected answer: we cannot tell, because 0 of 5 happens often by chance even when the true risk is 40%.</a:t>
             </a:r>
           </a:p>
           <a:p>
@@ -1496,7 +1496,7 @@
           <a:p>
             <a:r>
               <a:rPr lang="en-US" sz="1400" b="0" dirty="0"/>
-              <a:t>Misconception 2: 'only RCTs count'. For prevalence, harm and prognosis, observational designs are often the right (or only ethical) choice. Qualitative research sits outside this pyramid - it answers different questions.</a:t>
+              <a:t>Misconception 2: 'only RCTs count'. For prevalence, harm and prognosis, observational designs are often the right (or only ethical) choice. Qualitative research sits outside this pyramid because it answers different questions.</a:t>
             </a:r>
           </a:p>
           <a:p>
@@ -1508,7 +1508,7 @@
           <a:p>
             <a:r>
               <a:rPr lang="en-US" sz="1400" b="0" dirty="0"/>
-              <a:t>Timing: 4 minutes. Session 3 covers each design in detail - do not teach designs here.</a:t>
+              <a:t>Timing: 4 minutes. Session 3 covers each design in detail, so do not teach designs here.</a:t>
             </a:r>
           </a:p>
         </p:txBody>
@@ -1595,13 +1595,13 @@
           <a:p>
             <a:r>
               <a:rPr lang="en-US" sz="1400" b="0" dirty="0"/>
-              <a:t>C is the real CLASSIC trial (NEJM 2022) - no difference in 90-day mortality. B resembles Paper 2 (Hyun 2023): a positive fluid balance on days 2-3 was associated with higher 28-day mortality.</a:t>
+              <a:t>C is the real CLASSIC trial (NEJM 2022), which found no difference in 90-day mortality. B resembles Paper 2 (Hyun 2023): a positive fluid balance on days 2-3 was associated with higher 28-day mortality.</a:t>
             </a:r>
           </a:p>
           <a:p>
             <a:r>
               <a:rPr lang="en-US" sz="1400" b="0" dirty="0"/>
-              <a:t>Why might a cohort find harm when a trial finds none? Expected answer: in a cohort, sicker patients get more fluid, so fluid looks harmful (confounding by indication) - a preview of Session 4.</a:t>
+              <a:t>Why might a cohort find harm when a trial finds none? Expected answer: in a cohort, sicker patients get more fluid, so fluid looks harmful (confounding by indication). This is a preview of Session 4.</a:t>
             </a:r>
           </a:p>
           <a:p>
@@ -1700,7 +1700,7 @@
           <a:p>
             <a:r>
               <a:rPr lang="en-US" sz="1400" b="0" dirty="0"/>
-              <a:t>Weeks 1-2 = clinical problem and research question (today), literature search (next Saturday) - the three teal boxes top right.</a:t>
+              <a:t>Weeks 1-2 = clinical problem and research question (today), literature search (next Saturday). These are the three teal boxes top right.</a:t>
             </a:r>
           </a:p>
           <a:p>
@@ -1799,13 +1799,13 @@
           <a:p>
             <a:r>
               <a:rPr lang="en-US" sz="1400" b="0" dirty="0"/>
-              <a:t>Top row: what kind of data. Quantitative research counts and measures (mortality, fluid balance). Qualitative research collects words - interviews, focus groups, observation - to understand experiences, reasons and barriers. Mixed methods combine both in one study.</a:t>
+              <a:t>Top row: what kind of data. Quantitative research counts and measures (mortality, fluid balance). Qualitative research collects words (interviews, focus groups, observation) to understand experiences, reasons and barriers. Mixed methods combine both in one study.</a:t>
             </a:r>
           </a:p>
           <a:p>
             <a:r>
               <a:rPr lang="en-US" sz="1400" b="0" dirty="0"/>
-              <a:t>Bottom row: where the data come from. Primary research collects new data for this study (Paper 1, a new trial). Secondary research reuses data that already exist - medical records, registries (Paper 2 used a sepsis registry) or published studies (a systematic review).</a:t>
+              <a:t>Bottom row: where the data come from. Primary research collects new data for this study (Paper 1, a new trial). Secondary research reuses data that already exist: medical records, registries (Paper 2 used a sepsis registry) or published studies (a systematic review).</a:t>
             </a:r>
           </a:p>
           <a:p>
@@ -1928,7 +1928,7 @@
           <a:p>
             <a:r>
               <a:rPr lang="en-US" sz="1400" b="0" dirty="0"/>
-              <a:t>Write the examples on the flip chart - they are candidate topics for the group proposals.</a:t>
+              <a:t>Write the examples on the flip chart. They are candidate topics for the group proposals.</a:t>
             </a:r>
           </a:p>
         </p:txBody>
@@ -2021,7 +2021,7 @@
           <a:p>
             <a:r>
               <a:rPr lang="en-US" sz="1400" b="0" dirty="0"/>
-              <a:t>If people hesitate on C: the data were collected for care, not for this study - reusing them is secondary research. It still needs ethics review.</a:t>
+              <a:t>If people hesitate on C: the data were collected for care, not for this study, so reusing them is secondary research. It still needs ethics review.</a:t>
             </a:r>
           </a:p>
           <a:p>
@@ -2114,13 +2114,13 @@
           <a:p>
             <a:r>
               <a:rPr lang="en-US" sz="1400" b="0" dirty="0"/>
-              <a:t>Teaching point: two simple questions classify almost any study - what kind of data (numbers or words) and where they come from (new or existing).</a:t>
+              <a:t>Teaching point: two simple questions classify almost any study: what kind of data (numbers or words) and where they come from (new or existing).</a:t>
             </a:r>
           </a:p>
           <a:p>
             <a:r>
               <a:rPr lang="en-US" sz="1400" b="0" dirty="0"/>
-              <a:t>Secondary research is often the most feasible for a busy department - but data quality depends on how well the records were kept (Session 5).</a:t>
+              <a:t>Secondary research is often the most feasible for a busy department, but data quality depends on how well the records were kept (Session 5).</a:t>
             </a:r>
           </a:p>
           <a:p>
@@ -2207,19 +2207,19 @@
           <a:p>
             <a:r>
               <a:rPr lang="en-US" sz="1400" b="0" dirty="0"/>
-              <a:t>Research generates new, generalisable knowledge - which option is best? Audit compares our practice with an agreed standard. Quality improvement (QI) changes a local process step by step, usually in Plan-Do-Study-Act (PDSA) cycles.</a:t>
+              <a:t>Research generates new, generalisable knowledge: which option is best? Audit compares our practice with an agreed standard. Quality improvement (QI) changes a local process step by step, usually in Plan-Do-Study-Act (PDSA) cycles.</a:t>
             </a:r>
           </a:p>
           <a:p>
             <a:r>
               <a:rPr lang="en-US" sz="1400" b="0" dirty="0"/>
-              <a:t>Why it matters: research always needs ethics committee approval before it starts. Audit and QI usually need local approval only - but if a project randomises patients, adds a new intervention or risk, or collects data beyond routine care, it is research and needs ethics review.</a:t>
+              <a:t>Why it matters: research always needs ethics committee approval before it starts. Audit and QI usually need local approval only. But if a project randomises patients, adds a new intervention or risk, or collects data beyond routine care, it is research and needs ethics review.</a:t>
             </a:r>
           </a:p>
           <a:p>
             <a:r>
               <a:rPr lang="en-US" sz="1400" b="0" dirty="0"/>
-              <a:t>Publishing does not change what a project was. Journals ask for ethics approval or a formal waiver, so decide - and ask - at the start, not after the data are collected.</a:t>
+              <a:t>Publishing does not change what a project was. Journals ask for ethics approval or a formal waiver, so decide (and ask) at the start, not after the data are collected.</a:t>
             </a:r>
           </a:p>
           <a:p>
@@ -2231,7 +2231,7 @@
           <a:p>
             <a:r>
               <a:rPr lang="en-US" sz="1400" b="0" dirty="0"/>
-              <a:t>Ask the room: 'Checking whether fluid balance is recorded daily as our protocol says - research, audit or QI?' Expected answer: audit.</a:t>
+              <a:t>Ask the room: 'Checking whether fluid balance is recorded daily as our protocol says: research, audit or QI?' Expected answer: audit.</a:t>
             </a:r>
           </a:p>
           <a:p>
@@ -2330,7 +2330,7 @@
           <a:p>
             <a:r>
               <a:rPr lang="en-US" sz="1400" b="0" dirty="0"/>
-              <a:t>Answers (next slide): A audit; B research (ethics committee + registration); C quality improvement; D research (qualitative - ethics committee).</a:t>
+              <a:t>Answers (next slide): A audit; B research (ethics committee + registration); C quality improvement; D research (qualitative, ethics committee).</a:t>
             </a:r>
           </a:p>
           <a:p>
@@ -2528,7 +2528,7 @@
           <a:p>
             <a:r>
               <a:rPr lang="en-US" sz="1400" b="0" dirty="0"/>
-              <a:t>Stops 1-6 are planning and doing: question, design and protocol, registration (trials must be registered BEFORE the first patient - Paper 1 was registered in July 2021, recruitment began in September 2021), ethics approval, data collection, analysis.</a:t>
+              <a:t>Stops 1-6 are planning and doing: question, design and protocol, registration (trials must be registered BEFORE the first patient: Paper 1 was registered in July 2021 and recruitment began in September 2021), ethics approval, data collection, analysis.</a:t>
             </a:r>
           </a:p>
           <a:p>
@@ -2546,19 +2546,19 @@
           <a:p>
             <a:r>
               <a:rPr lang="en-US" sz="1400" b="0" dirty="0"/>
-              <a:t>Misconception: 'publication is the end'. The point is impact - a changed guideline, protocol or practice.</a:t>
+              <a:t>Misconception: 'publication is the end'. The point is impact: a changed guideline, protocol or practice.</a:t>
             </a:r>
           </a:p>
           <a:p>
             <a:r>
               <a:rPr lang="en-US" sz="1400" b="0" dirty="0"/>
-              <a:t>Ask the room: 'At which stop do you think most hospital studies get stuck?' Expected answers: ethics paperwork, data collection, or writing (stop 7) - we will tackle each one.</a:t>
+              <a:t>Ask the room: 'At which stop do you think most hospital studies get stuck?' Expected answers: ethics paperwork, data collection, or writing (stop 7). We will tackle each one.</a:t>
             </a:r>
           </a:p>
           <a:p>
             <a:r>
               <a:rPr lang="en-US" sz="1400" b="0" dirty="0"/>
-              <a:t>Timing: 3 minutes. Segment 1.1 ends at 1:10 - break.</a:t>
+              <a:t>Timing: 3 minutes. Segment 1.1 ends at 1:10, then the break.</a:t>
             </a:r>
           </a:p>
         </p:txBody>
@@ -2651,7 +2651,7 @@
           <a:p>
             <a:r>
               <a:rPr lang="en-US" sz="1400" b="0" dirty="0"/>
-              <a:t>Restart on time - say clearly what time you will begin again.</a:t>
+              <a:t>Restart on time and say clearly what time you will begin again.</a:t>
             </a:r>
           </a:p>
         </p:txBody>
@@ -2744,7 +2744,7 @@
           <a:p>
             <a:r>
               <a:rPr lang="en-US" sz="1400" b="0" dirty="0"/>
-              <a:t>We will build PICO slowly with several examples - ICU and ward - before you practise in pairs.</a:t>
+              <a:t>We will build PICO slowly with several examples (ICU and ward) before you practise in pairs.</a:t>
             </a:r>
           </a:p>
           <a:p>
@@ -2837,19 +2837,19 @@
           <a:p>
             <a:r>
               <a:rPr lang="en-US" sz="1400" b="0" dirty="0"/>
-              <a:t>The orange box is the key decision: before calling something research, check whether the answer already exists. If it does, the job is implementation - a guideline, an audit or a QI project (segment 1.1).</a:t>
+              <a:t>The orange box is the key decision: before calling something research, check whether the answer already exists. If it does, the job is implementation: a guideline, an audit or a QI project (segment 1.1).</a:t>
             </a:r>
           </a:p>
           <a:p>
             <a:r>
               <a:rPr lang="en-US" sz="1400" b="0" dirty="0"/>
-              <a:t>Teaching point: 'how we find out' is the literature search - that is next Saturday's Session 2.</a:t>
+              <a:t>Teaching point: 'how we find out' is the literature search, covered next Saturday in Session 2.</a:t>
             </a:r>
           </a:p>
           <a:p>
             <a:r>
               <a:rPr lang="en-US" sz="1400" b="0" dirty="0"/>
-              <a:t>Ask the room: 'Name one thing in your unit that colleagues do differently.' Expected: sedation targets, fluid volumes, dressing changes, mobilisation timing. Write them on the flip chart - they are candidate topics for the proposals.</a:t>
+              <a:t>Ask the room: 'Name one thing in your unit that colleagues do differently.' Expected: sedation targets, fluid volumes, dressing changes, mobilisation timing. Write them on the flip chart. They are candidate topics for the proposals.</a:t>
             </a:r>
           </a:p>
           <a:p>
@@ -2954,13 +2954,13 @@
           <a:p>
             <a:r>
               <a:rPr lang="en-US" sz="1400" b="0" dirty="0"/>
-              <a:t>Variants: for observational questions I becomes E (exposure), e.g. 'a positive fluid balance' - PECO. Descriptive questions may only need P and O.</a:t>
+              <a:t>Variants: for observational questions I becomes E (exposure), e.g. 'a positive fluid balance' (PECO). Descriptive questions may only need P and O.</a:t>
             </a:r>
           </a:p>
           <a:p>
             <a:r>
               <a:rPr lang="en-US" sz="1400" b="0" dirty="0"/>
-              <a:t>Misconception: 'the comparison is obvious'. Usual care varies between hospitals and over time - it must be described.</a:t>
+              <a:t>Misconception: 'the comparison is obvious'. Usual care varies between hospitals and over time, so it must be described.</a:t>
             </a:r>
           </a:p>
           <a:p>
@@ -3059,7 +3059,7 @@
           <a:p>
             <a:r>
               <a:rPr lang="en-US" sz="1400" b="0" dirty="0"/>
-              <a:t>This whole course is Level 1: it covers every step from question to publication. Weeks 1-4 build understanding and design skills; Weeks 5-8 apply them to data, writing and publishing.</a:t>
+              <a:t>This whole course is Level 1: it covers every step from question to publication. Weeks 1-4 build understanding and design skills. Weeks 5-8 apply them to data, writing and publishing.</a:t>
             </a:r>
           </a:p>
           <a:p>
@@ -3152,25 +3152,25 @@
           <a:p>
             <a:r>
               <a:rPr lang="en-US" sz="1400" b="0" dirty="0"/>
-              <a:t>Row 1 - treatment (PICO): ventilated adults; a twice-daily bed-head checklist vs usual care; ventilator-associated pneumonia by ICU day 28.</a:t>
+              <a:t>Row 1, treatment (PICO): ventilated adults; a twice-daily bed-head checklist vs usual care; ventilator-associated pneumonia by ICU day 28.</a:t>
             </a:r>
           </a:p>
           <a:p>
             <a:r>
               <a:rPr lang="en-US" sz="1400" b="0" dirty="0"/>
-              <a:t>Row 2 - risk factor (PECO): we cannot assign obesity, so I becomes E (exposure). Adults on the medical ward; obese vs not; new pressure injury during admission.</a:t>
+              <a:t>Row 2, risk factor (PECO): we cannot assign obesity, so I becomes E (exposure). Adults on the medical ward; obese vs not; new pressure injury during admission.</a:t>
             </a:r>
           </a:p>
           <a:p>
             <a:r>
               <a:rPr lang="en-US" sz="1400" b="0" dirty="0"/>
-              <a:t>Row 3 - how common? Only P and O (and T): adults 65 and over after hip-fracture surgery; delirium screened with the 4AT in the first 7 days.</a:t>
+              <a:t>Row 3, how common? Only P and O (and T): adults 65 and over after hip-fracture surgery; delirium screened with the 4AT in the first 7 days.</a:t>
             </a:r>
           </a:p>
           <a:p>
             <a:r>
               <a:rPr lang="en-US" sz="1400" b="0" dirty="0"/>
-              <a:t>Teaching point: the boxes you fill already tell you the type of question - and later the design.</a:t>
+              <a:t>Teaching point: the boxes you fill already tell you the type of question, and later the design.</a:t>
             </a:r>
           </a:p>
           <a:p>
@@ -3275,7 +3275,7 @@
           <a:p>
             <a:r>
               <a:rPr lang="en-US" sz="1400" b="0" dirty="0"/>
-              <a:t>Watch for people labelling 'hip fracture' as the outcome - it is part of the population.</a:t>
+              <a:t>Watch for people labelling 'hip fracture' as the outcome. It is part of the population.</a:t>
             </a:r>
           </a:p>
           <a:p>
@@ -3368,7 +3368,7 @@
           <a:p>
             <a:r>
               <a:rPr lang="en-US" sz="1400" b="0" dirty="0"/>
-              <a:t>Teaching point: the outcome must be something that can happen AFTER the intervention starts. Hip fracture has already happened - it defines who is eligible.</a:t>
+              <a:t>Teaching point: the outcome must be something that can happen AFTER the intervention starts. Hip fracture has already happened: it defines who is eligible.</a:t>
             </a:r>
           </a:p>
           <a:p>
@@ -3461,13 +3461,13 @@
           <a:p>
             <a:r>
               <a:rPr lang="en-US" sz="1400" b="0" dirty="0"/>
-              <a:t>Descriptive: what, how many, who - no comparison group needed.</a:t>
+              <a:t>Descriptive: what, how many, who. No comparison group is needed.</a:t>
             </a:r>
           </a:p>
           <a:p>
             <a:r>
               <a:rPr lang="en-US" sz="1400" b="0" dirty="0"/>
-              <a:t>Analytical: is X linked to Y (observational - we watch), or does X cause Y (experimental - we assign X).</a:t>
+              <a:t>Analytical: is X linked to Y (observational: we watch), or does X cause Y (experimental: we assign X).</a:t>
             </a:r>
           </a:p>
           <a:p>
@@ -3485,7 +3485,7 @@
           <a:p>
             <a:r>
               <a:rPr lang="en-US" sz="1400" b="0" dirty="0"/>
-              <a:t>Ask the room: 'Paper 2 (Hyun) - which box?' Expected: analytical, observational (cohort).</a:t>
+              <a:t>Ask the room: 'Paper 2 (Hyun): which box?' Expected: analytical, observational (cohort).</a:t>
             </a:r>
           </a:p>
           <a:p>
@@ -3572,7 +3572,7 @@
           <a:p>
             <a:r>
               <a:rPr lang="en-US" sz="1400" b="0" dirty="0"/>
-              <a:t>Left: the question we ask in the corridor - every word is undefined. Right: the same worry written with PICO(T).</a:t>
+              <a:t>Left: the question we ask in the corridor: every word is undefined. Right: the same worry written with PICO(T).</a:t>
             </a:r>
           </a:p>
           <a:p>
@@ -3689,7 +3689,7 @@
           <a:p>
             <a:r>
               <a:rPr lang="en-US" sz="1400" b="0" dirty="0"/>
-              <a:t>Novel does not mean 'never studied'. Repeating a study in a new setting, or with a better design, can be novel - which is why the literature search matters.</a:t>
+              <a:t>Novel does not mean 'never studied'. Repeating a study in a new setting, or with a better design, can be novel. That is why the literature search matters.</a:t>
             </a:r>
           </a:p>
           <a:p>
@@ -3701,7 +3701,7 @@
           <a:p>
             <a:r>
               <a:rPr lang="en-US" sz="1400" b="0" dirty="0"/>
-              <a:t>Ask the room: 'Which letter does our running example fail?' Let them guess - the next slide answers.</a:t>
+              <a:t>Ask the room: 'Which letter does our running example fail?' Let them guess. The next slide answers.</a:t>
             </a:r>
           </a:p>
           <a:p>
@@ -3812,7 +3812,7 @@
           <a:p>
             <a:r>
               <a:rPr lang="en-US" sz="1400" b="0" dirty="0"/>
-              <a:t>Misconception: 'a failed FINER check means a bad idea'. It means the idea needs reshaping - normal and expected.</a:t>
+              <a:t>Misconception: 'a failed FINER check means a bad idea'. It means the idea needs reshaping, which is normal and expected.</a:t>
             </a:r>
           </a:p>
           <a:p>
@@ -3923,7 +3923,7 @@
           <a:p>
             <a:r>
               <a:rPr lang="en-US" sz="1400" b="0" dirty="0"/>
-              <a:t>Pressure-injury pairs often discover their first question should be descriptive - praise this explicitly.</a:t>
+              <a:t>Pressure-injury pairs often discover their first question should be descriptive. Praise this explicitly.</a:t>
             </a:r>
           </a:p>
           <a:p>
@@ -4121,7 +4121,7 @@
           <a:p>
             <a:r>
               <a:rPr lang="en-US" sz="1400" b="0" dirty="0"/>
-              <a:t>Mark the primary objective - it drives the sample size (Session 6).</a:t>
+              <a:t>Mark the primary objective: it drives the sample size (Session 6).</a:t>
             </a:r>
           </a:p>
           <a:p>
@@ -4220,13 +4220,13 @@
           <a:p>
             <a:r>
               <a:rPr lang="en-US" sz="1400" b="0" dirty="0"/>
-              <a:t>This course (Level 1) takes you from a clinical question to a published paper. Level 2 is a hands-on course in R for those who want to run analyses themselves; Level 3 covers advanced, specialised methods.</a:t>
+              <a:t>This course (Level 1) takes you from a clinical question to a published paper. Level 2 is a hands-on course in R for those who want to run analyses themselves. Level 3 covers advanced, specialised methods.</a:t>
             </a:r>
           </a:p>
           <a:p>
             <a:r>
               <a:rPr lang="en-US" sz="1400" b="0" dirty="0"/>
-              <a:t>Within Level 1 we use a realistic dataset of 620 ICU patients: we describe it, analyse it and write it up. The trainers run the software; you read and interpret the results.</a:t>
+              <a:t>Within Level 1 we use a realistic dataset of 620 ICU patients: we describe it, analyse it and write it up. The trainers run the software. You read and interpret the results.</a:t>
             </a:r>
           </a:p>
           <a:p>
@@ -4430,7 +4430,7 @@
           <a:p>
             <a:r>
               <a:rPr lang="en-US" sz="1400" b="0" dirty="0"/>
-              <a:t>Analogy: a court assumes 'not guilty' (H0) until the evidence is strong enough. 'Not guilty' is not 'innocent' - and 'no significant difference' is not 'no difference'.</a:t>
+              <a:t>Analogy: a court assumes 'not guilty' (H0) until the evidence is strong enough. 'Not guilty' is not 'innocent', and 'no significant difference' is not 'no difference'.</a:t>
             </a:r>
           </a:p>
           <a:p>
@@ -4634,7 +4634,7 @@
           <a:p>
             <a:r>
               <a:rPr lang="en-US" sz="1400" b="0" dirty="0"/>
-              <a:t>Check the chain: the question's O (delirium in 7 days) = the primary objective = the outcome in H0/H1. If any of these differ, the proposal is inconsistent - reviewers spot this immediately.</a:t>
+              <a:t>Check the chain: the question's O (delirium in 7 days) = the primary objective = the outcome in H0/H1. If any of these differ, the proposal is inconsistent, and reviewers spot this immediately.</a:t>
             </a:r>
           </a:p>
           <a:p>
@@ -4838,13 +4838,13 @@
           <a:p>
             <a:r>
               <a:rPr lang="en-US" sz="1400" b="0" dirty="0"/>
-              <a:t>Trainers circulate. Spend the first 7 minutes making sure every group has ONE focused problem - this is where groups get stuck.</a:t>
+              <a:t>Trainers circulate. Spend the first 7 minutes making sure every group has ONE focused problem. This is where groups get stuck.</a:t>
             </a:r>
           </a:p>
           <a:p>
             <a:r>
               <a:rPr lang="en-US" sz="1400" b="0" dirty="0"/>
-              <a:t>Check each group's question against PICO and FINER before they write objectives. A red F is the commonest problem - help them shrink the outcome, shorten the time frame or turn it into a descriptive question or pilot.</a:t>
+              <a:t>Check each group's question against PICO and FINER before they write objectives. A red F is the commonest problem. Help them shrink the outcome, shorten the time frame or turn it into a descriptive question or pilot.</a:t>
             </a:r>
           </a:p>
           <a:p>
@@ -5141,7 +5141,7 @@
           <a:p>
             <a:r>
               <a:rPr lang="en-US" sz="1400" b="0" dirty="0"/>
-              <a:t>Answers: 1 - Feasible: a mortality outcome needs well over a thousand patients. 2 - e.g. 'To estimate the incidence of new stage 2+ pressure injuries among adults on our ward over 6 months'.</a:t>
+              <a:t>Answers: 1. Feasible: a mortality outcome needs well over a thousand patients. 2. For example, 'To estimate the incidence of new stage 2+ pressure injuries among adults on our ward over 6 months'.</a:t>
             </a:r>
           </a:p>
           <a:p>
@@ -5240,7 +5240,7 @@
           <a:p>
             <a:r>
               <a:rPr lang="en-US" sz="1400" b="0" dirty="0"/>
-              <a:t>The synonym list makes next Saturday's PubMed search much faster - PubMed searches in English.</a:t>
+              <a:t>The synonym list makes next Saturday's PubMed search much faster, because PubMed searches in English.</a:t>
             </a:r>
           </a:p>
           <a:p>
@@ -5537,7 +5537,7 @@
           <a:p>
             <a:r>
               <a:rPr lang="en-US" sz="1400" b="0" dirty="0"/>
-              <a:t>Diagnostic questions: the index test is I, the reference standard is C, the outcome is accuracy (sensitivity, specificity - Session 4).</a:t>
+              <a:t>Diagnostic questions: the index test is I, the reference standard is C, the outcome is accuracy (sensitivity and specificity, Session 4).</a:t>
             </a:r>
           </a:p>
           <a:p>
@@ -5654,7 +5654,7 @@
           <a:p>
             <a:r>
               <a:rPr lang="en-US" sz="1400" b="0" dirty="0"/>
-              <a:t>Non-inferiority questions (is a cheaper or simpler option not much worse?) have their own design - Session 3.</a:t>
+              <a:t>Non-inferiority questions (is a cheaper or simpler option not much worse?) have their own design (Session 3).</a:t>
             </a:r>
           </a:p>
           <a:p>
@@ -5747,7 +5747,7 @@
           <a:p>
             <a:r>
               <a:rPr lang="en-US" sz="1400" b="0" dirty="0"/>
-              <a:t>Answers: 1 Feasible (huge, long, expensive; large vitamin D trials also exist - Novel). 2 Ethical (withholding antibiotics in septic shock causes harm - no equipoise). 3 Novel (the answer is already measured: an audit question). 4 Relevant (no plausible mechanism, no impact on practice).</a:t>
+              <a:t>Answers: 1 Feasible (huge, long, expensive; large vitamin D trials also exist, so Novel too). 2 Ethical (withholding antibiotics in septic shock causes harm, so there is no equipoise). 3 Novel (the answer is already measured: an audit question). 4 Relevant (no plausible mechanism, no impact on practice).</a:t>
             </a:r>
           </a:p>
           <a:p>
@@ -5945,7 +5945,7 @@
           <a:p>
             <a:r>
               <a:rPr lang="en-US" sz="1400" b="0" dirty="0"/>
-              <a:t>Copyright slide - leave on screen while participants leave.</a:t>
+              <a:t>Copyright slide. Leave on screen while participants leave.</a:t>
             </a:r>
           </a:p>
         </p:txBody>
@@ -6026,13 +6026,13 @@
           <a:p>
             <a:r>
               <a:rPr lang="en-US" sz="1400" b="0" dirty="0"/>
-              <a:t>Walk across the four cards - one per two-week block.</a:t>
+              <a:t>Walk across the four cards, one per two-week block.</a:t>
             </a:r>
           </a:p>
           <a:p>
             <a:r>
               <a:rPr lang="en-US" sz="1400" b="0" dirty="0"/>
-              <a:t>Key teaching point: the aim is understanding and interpretation, not computation. The trainers run the analyses; you learn to read them and write them up.</a:t>
+              <a:t>Key teaching point: the aim is understanding and interpretation, not computation. The trainers run the analyses. You learn to read them and write them up.</a:t>
             </a:r>
           </a:p>
           <a:p>
@@ -6131,13 +6131,13 @@
           <a:p>
             <a:r>
               <a:rPr lang="en-US" sz="1400" b="0" dirty="0"/>
-              <a:t>Every 20 minutes we stop for a quick check of understanding - if the room is not with us, we slow down. Each session ends with 'extra slides' that we only use if there is time; you can read them at home.</a:t>
+              <a:t>Every 20 minutes we stop for a quick check of understanding. If the room is not with us, we slow down. Each session ends with 'extra slides' that we only use if there is time. You can read them at home.</a:t>
             </a:r>
           </a:p>
           <a:p>
             <a:r>
               <a:rPr lang="en-US" sz="1400" b="0" dirty="0"/>
-              <a:t>Keep the break to 15 minutes - start again on time.</a:t>
+              <a:t>Keep the break to 15 minutes and start again on time.</a:t>
             </a:r>
           </a:p>
         </p:txBody>
@@ -6311,13 +6311,13 @@
           <a:p>
             <a:r>
               <a:rPr lang="en-US" sz="1400" b="0" dirty="0"/>
-              <a:t>Groups should mix doctors, nurses and pharmacists - different perspectives make better proposals.</a:t>
+              <a:t>Groups should mix doctors, nurses and pharmacists. Different perspectives make better proposals.</a:t>
             </a:r>
           </a:p>
           <a:p>
             <a:r>
               <a:rPr lang="en-US" sz="1400" b="0" dirty="0"/>
-              <a:t>Roles keep quieter members involved; suggest rotating the scribe.</a:t>
+              <a:t>Roles keep quieter members involved. Suggest rotating the scribe.</a:t>
             </a:r>
           </a:p>
           <a:p>
@@ -9470,7 +9470,7 @@
                 <a:latin typeface="Segoe UI"/>
                 <a:cs typeface="Segoe UI"/>
               </a:rPr>
-              <a:t>Level 1  -  From Clinical Question to Publication</a:t>
+              <a:t>Level 1: From Clinical Question to Publication</a:t>
             </a:r>
           </a:p>
           <a:p>
@@ -9488,7 +9488,7 @@
                 <a:latin typeface="Segoe UI"/>
                 <a:cs typeface="Segoe UI"/>
               </a:rPr>
-              <a:t>8 Saturdays  -  one session per week  -  24 contact hours</a:t>
+              <a:t>8 Saturdays, one session per week, 24 contact hours</a:t>
             </a:r>
           </a:p>
           <a:p>
@@ -10457,7 +10457,7 @@
                 <a:latin typeface="Century Gothic"/>
                 <a:cs typeface="Century Gothic"/>
               </a:rPr>
-              <a:t>24 multiple-choice questions - one answer each</a:t>
+              <a:t>24 multiple-choice questions, one answer each</a:t>
             </a:r>
           </a:p>
           <a:p>
@@ -12688,7 +12688,7 @@
                 <a:latin typeface="Century Gothic"/>
                 <a:cs typeface="Century Gothic"/>
               </a:rPr>
-              <a:t>Rank them from weakest to strongest - show fingers on the count of 3</a:t>
+              <a:t>Rank them from weakest to strongest, then show fingers on the count of 3</a:t>
             </a:r>
           </a:p>
         </p:txBody>
@@ -13277,7 +13277,7 @@
                 <a:latin typeface="Century Gothic"/>
                 <a:cs typeface="Century Gothic"/>
               </a:rPr>
-              <a:t>Types of research</a:t>
+              <a:t>The question decides the type of research</a:t>
             </a:r>
           </a:p>
         </p:txBody>
@@ -13573,7 +13573,7 @@
                 <a:latin typeface="Century Gothic"/>
                 <a:cs typeface="Century Gothic"/>
               </a:rPr>
-              <a:t>This course helps you ask those questions properly - answer them - and publish the answer.</a:t>
+              <a:t>This course helps you ask those questions properly, answer them and publish the answer.</a:t>
             </a:r>
           </a:p>
         </p:txBody>
@@ -14048,7 +14048,7 @@
                 <a:latin typeface="Century Gothic"/>
                 <a:cs typeface="Century Gothic"/>
               </a:rPr>
-              <a:t>Shout out the answers - the next slide shows them</a:t>
+              <a:t>Shout out the answers. The next slide shows them</a:t>
             </a:r>
           </a:p>
         </p:txBody>
@@ -15528,7 +15528,7 @@
                 <a:latin typeface="Century Gothic"/>
                 <a:cs typeface="Century Gothic"/>
               </a:rPr>
-              <a:t>For each: research, audit or QI - and who must approve it?</a:t>
+              <a:t>For each: research, audit or QI? Who must approve it?</a:t>
             </a:r>
           </a:p>
         </p:txBody>
@@ -16475,7 +16475,7 @@
                 <a:latin typeface="Century Gothic"/>
                 <a:cs typeface="Century Gothic"/>
               </a:rPr>
-              <a:t>This course walks the whole road - your group proposal covers stops 1 to 6.</a:t>
+              <a:t>This course walks the whole road. Your group proposal covers stops 1 to 6.</a:t>
             </a:r>
           </a:p>
         </p:txBody>
@@ -17056,7 +17056,7 @@
                 <a:latin typeface="Century Gothic"/>
                 <a:cs typeface="Century Gothic"/>
               </a:rPr>
-              <a:t>40 minutes: where questions come from, PICO(T) with worked examples, question types, FINER - then a pair task</a:t>
+              <a:t>40 minutes: where questions come from, PICO(T) with worked examples, question types and FINER, then a pair task</a:t>
             </a:r>
           </a:p>
         </p:txBody>
@@ -18545,7 +18545,7 @@
                 <a:latin typeface="Century Gothic"/>
                 <a:cs typeface="Century Gothic"/>
               </a:rPr>
-              <a:t>Five labelled pieces - the answer is on the next slide</a:t>
+              <a:t>Five labelled pieces. The answer is on the next slide</a:t>
             </a:r>
           </a:p>
         </p:txBody>
@@ -19804,7 +19804,7 @@
                 <a:latin typeface="Century Gothic"/>
                 <a:cs typeface="Century Gothic"/>
               </a:rPr>
-              <a:t>Vague vs answerable</a:t>
+              <a:t>From a vague worry to an answerable question</a:t>
             </a:r>
           </a:p>
         </p:txBody>
@@ -21990,7 +21990,7 @@
                 <a:latin typeface="Century Gothic"/>
                 <a:cs typeface="Century Gothic"/>
               </a:rPr>
-              <a:t>20 minutes: aim, objectives, null and alternative hypotheses - and a quick exercise</a:t>
+              <a:t>20 minutes: aim, objectives, null and alternative hypotheses, and a quick exercise</a:t>
             </a:r>
           </a:p>
         </p:txBody>
@@ -22433,7 +22433,7 @@
                 <a:latin typeface="Century Gothic"/>
                 <a:cs typeface="Century Gothic"/>
               </a:rPr>
-              <a:t>Where this course takes you</a:t>
+              <a:t>This course is Level 1 of three</a:t>
             </a:r>
           </a:p>
         </p:txBody>
@@ -22540,7 +22540,7 @@
                 <a:latin typeface="Century Gothic"/>
                 <a:cs typeface="Century Gothic"/>
               </a:rPr>
-              <a:t>Level 1 is this course; Level 2 is hands-on analysis in R; Level 3 is advanced methods.</a:t>
+              <a:t>Level 1 is this course, Level 2 is hands-on analysis in R, Level 3 is advanced methods.</a:t>
             </a:r>
           </a:p>
         </p:txBody>
@@ -23090,7 +23090,7 @@
                 <a:latin typeface="Century Gothic"/>
                 <a:cs typeface="Century Gothic"/>
               </a:rPr>
-              <a:t>We test H0. Data can reject it or fail to reject it - never prove it.</a:t>
+              <a:t>We test H0. Data can reject it or fail to reject it, but never prove it.</a:t>
             </a:r>
           </a:p>
         </p:txBody>
@@ -23477,7 +23477,7 @@
                 <a:latin typeface="Century Gothic"/>
                 <a:cs typeface="Century Gothic"/>
               </a:rPr>
-              <a:t>Write H0 and H1 for the primary objective - or 'descriptive: no hypothesis'</a:t>
+              <a:t>Write H0 and H1 for the primary objective (or 'descriptive: no hypothesis')</a:t>
             </a:r>
           </a:p>
           <a:p>
@@ -23720,7 +23720,7 @@
                 <a:latin typeface="Century Gothic"/>
                 <a:cs typeface="Century Gothic"/>
               </a:rPr>
-              <a:t>Exercise 3 on the sheet - model answers on the next slide</a:t>
+              <a:t>Exercise 3 on the sheet. Model answers on the next slide</a:t>
             </a:r>
           </a:p>
         </p:txBody>
@@ -24671,7 +24671,7 @@
                 <a:latin typeface="Century Gothic"/>
                 <a:cs typeface="Century Gothic"/>
               </a:rPr>
-              <a:t>30 minutes of group work - the start of your research proposal</a:t>
+              <a:t>30 minutes of group work: the start of your research proposal</a:t>
             </a:r>
           </a:p>
         </p:txBody>
@@ -25873,7 +25873,7 @@
                           </a:solidFill>
                           <a:latin typeface="Century Gothic"/>
                         </a:rPr>
-                        <a:t>No difference / a difference - we test H0</a:t>
+                        <a:t>No difference / a difference (we test H0)</a:t>
                       </a:r>
                     </a:p>
                   </a:txBody>
@@ -27895,7 +27895,7 @@
                 <a:latin typeface="Century Gothic"/>
                 <a:cs typeface="Century Gothic"/>
               </a:rPr>
-              <a:t>Extra slides — Session 1</a:t>
+              <a:t>Extra slides: Session 1</a:t>
             </a:r>
           </a:p>
           <a:p>
@@ -28629,7 +28629,7 @@
                 <a:latin typeface="Century Gothic"/>
                 <a:cs typeface="Century Gothic"/>
               </a:rPr>
-              <a:t>The letters change; the idea - be explicit - stays the same.</a:t>
+              <a:t>The letters change, but the idea stays the same: be explicit.</a:t>
             </a:r>
           </a:p>
         </p:txBody>
@@ -31064,7 +31064,7 @@
                 <a:latin typeface="Century Gothic"/>
                 <a:cs typeface="Century Gothic"/>
               </a:rPr>
-              <a:t>Understand and interpret - you will not be asked to calculate.</a:t>
+              <a:t>Understand and interpret: you will not be asked to calculate.</a:t>
             </a:r>
           </a:p>
         </p:txBody>
@@ -31452,7 +31452,7 @@
                 <a:latin typeface="Century Gothic"/>
                 <a:cs typeface="Century Gothic"/>
               </a:rPr>
-              <a:t>The proposal builder</a:t>
+              <a:t>Build the proposal one part at a time</a:t>
             </a:r>
           </a:p>
         </p:txBody>
@@ -31915,7 +31915,7 @@
                 <a:latin typeface="Century Gothic"/>
                 <a:cs typeface="Century Gothic"/>
               </a:rPr>
-              <a:t>Agree the roles below - they can rotate each week</a:t>
+              <a:t>Agree the roles below (they can rotate each week)</a:t>
             </a:r>
           </a:p>
           <a:p>
@@ -32013,7 +32013,7 @@
                 <a:latin typeface="Century Gothic"/>
                 <a:cs typeface="Century Gothic"/>
               </a:rPr>
-              <a:t>Facilitator - keeps everyone talking</a:t>
+              <a:t>Facilitator: keeps everyone talking</a:t>
             </a:r>
           </a:p>
           <a:p>
@@ -32035,7 +32035,7 @@
                 <a:latin typeface="Century Gothic"/>
                 <a:cs typeface="Century Gothic"/>
               </a:rPr>
-              <a:t>Scribe - fills in the template</a:t>
+              <a:t>Scribe: fills in the template</a:t>
             </a:r>
           </a:p>
           <a:p>

</xml_diff>

<commit_message>
Rebuild site: Lecture 1 final comments
</commit_message>
<xml_diff>
--- a/en/files/slides/Session_1_EN.pptx
+++ b/en/files/slides/Session_1_EN.pptx
@@ -64,6 +64,7 @@
     <p:sldId id="306" r:id="rId150"/>
     <p:sldId id="307" r:id="rId151"/>
     <p:sldId id="308" r:id="rId152"/>
+    <p:sldId id="309" r:id="rId153"/>
   </p:sldIdLst>
   <p:sldSz cx="12192000" cy="6858000"/>
   <p:notesSz cx="6858000" cy="9144000"/>
@@ -954,6 +955,12 @@
               <a:t>Timing: 15 minutes. Session 1 teaching starts at 0:35 (20:05).</a:t>
             </a:r>
           </a:p>
+          <a:p>
+            <a:r>
+              <a:rPr lang="en-US" sz="1400" b="0" dirty="0"/>
+              <a:t>The form is created once from Course/Assessment/google_form (steps in its README).</a:t>
+            </a:r>
+          </a:p>
         </p:txBody>
       </p:sp>
       <p:sp>
@@ -1647,6 +1654,12 @@
               <a:t>Timing: 2 minutes.</a:t>
             </a:r>
           </a:p>
+          <a:p>
+            <a:r>
+              <a:rPr lang="en-US" sz="1400" b="0" dirty="0"/>
+              <a:t>Before Session 1, email the two original PDFs (Course/Papers, files named 'original') with the Session 1 exercise sheet.</a:t>
+            </a:r>
+          </a:p>
         </p:txBody>
       </p:sp>
       <p:sp>
@@ -5028,19 +5041,25 @@
           <a:p>
             <a:r>
               <a:rPr lang="en-US" sz="1400" b="0" dirty="0"/>
-              <a:t>Extra. Diagnosis: the new test is I, the reference standard is C, the outcome is accuracy (Session 4).</a:t>
+              <a:t>Backup slide for 'Three more examples: PICO, PECO and P + O' (reviewer request).</a:t>
             </a:r>
           </a:p>
           <a:p>
             <a:r>
               <a:rPr lang="en-US" sz="1400" b="0" dirty="0"/>
-              <a:t>Prognosis: PECO plus a time frame. Qualitative questions often use SPIDER (Cooke and colleagues, 2012).</a:t>
+              <a:t>Use it as a short exercise: participants write one question per row in the chat, or you call on two or three people (microphone on). Then show this slide.</a:t>
             </a:r>
           </a:p>
           <a:p>
             <a:r>
               <a:rPr lang="en-US" sz="1400" b="0" dirty="0"/>
-              <a:t>Timing: 2 minutes if used.</a:t>
+              <a:t>Point out: the treatment question says 'reduce' because the checklist is assigned. The PECO question says 'associated with' because obesity is not assigned. The 'how common' question has no comparison.</a:t>
+            </a:r>
+          </a:p>
+          <a:p>
+            <a:r>
+              <a:rPr lang="en-US" sz="1400" b="0" dirty="0"/>
+              <a:t>Timing: 5 minutes if used.</a:t>
             </a:r>
           </a:p>
         </p:txBody>
@@ -5121,13 +5140,19 @@
           <a:p>
             <a:r>
               <a:rPr lang="en-US" sz="1400" b="0" dirty="0"/>
-              <a:t>Extra. Answers: 1 Feasible (huge and long). 2 Ethical (withholding antibiotics causes harm). 3 Novel (already measured every month). 4 Relevant (no plausible effect on practice).</a:t>
+              <a:t>Extra. Diagnosis: the new test is I, the reference standard is C, the outcome is accuracy (Session 4).</a:t>
             </a:r>
           </a:p>
           <a:p>
             <a:r>
               <a:rPr lang="en-US" sz="1400" b="0" dirty="0"/>
-              <a:t>Timing: 4 minutes if used.</a:t>
+              <a:t>Prognosis: PECO plus a time frame. Qualitative questions often use SPIDER (Cooke and colleagues, 2012).</a:t>
+            </a:r>
+          </a:p>
+          <a:p>
+            <a:r>
+              <a:rPr lang="en-US" sz="1400" b="0" dirty="0"/>
+              <a:t>Timing: 2 minutes if used.</a:t>
             </a:r>
           </a:p>
         </p:txBody>
@@ -5208,13 +5233,13 @@
           <a:p>
             <a:r>
               <a:rPr lang="en-US" sz="1400" b="0" dirty="0"/>
-              <a:t>Extra. This is a PECO (observational) question: nurses cannot easily be randomised to night shifts.</a:t>
+              <a:t>Extra. Answers: 1 Feasible (huge and long). 2 Ethical (withholding antibiotics causes harm). 3 Novel (already measured every month). 4 Relevant (no plausible effect on practice).</a:t>
             </a:r>
           </a:p>
           <a:p>
             <a:r>
               <a:rPr lang="en-US" sz="1400" b="0" dirty="0"/>
-              <a:t>Timing: 3 minutes if used.</a:t>
+              <a:t>Timing: 4 minutes if used.</a:t>
             </a:r>
           </a:p>
         </p:txBody>
@@ -5250,6 +5275,93 @@
 </file>
 
 <file path=ppt/notesSlides/notesSlide53.xml><?xml version="1.0" encoding="utf-8"?>
+<p:notes xmlns:a="http://schemas.openxmlformats.org/drawingml/2006/main" xmlns:r="http://schemas.openxmlformats.org/officeDocument/2006/relationships" xmlns:p="http://schemas.openxmlformats.org/presentationml/2006/main">
+  <p:cSld>
+    <p:spTree>
+      <p:nvGrpSpPr>
+        <p:cNvPr id="1" name=""/>
+        <p:cNvGrpSpPr/>
+        <p:nvPr/>
+      </p:nvGrpSpPr>
+      <p:grpSpPr>
+        <a:xfrm>
+          <a:off x="0" y="0"/>
+          <a:ext cx="0" cy="0"/>
+          <a:chOff x="0" y="0"/>
+          <a:chExt cx="0" cy="0"/>
+        </a:xfrm>
+      </p:grpSpPr>
+      <p:sp>
+        <p:nvSpPr>
+          <p:cNvPr id="2" name="Slide Image Placeholder 1"/>
+          <p:cNvSpPr>
+            <a:spLocks noGrp="1" noRot="1" noChangeAspect="1"/>
+          </p:cNvSpPr>
+          <p:nvPr>
+            <p:ph type="sldImg"/>
+          </p:nvPr>
+        </p:nvSpPr>
+        <p:spPr/>
+      </p:sp>
+      <p:sp>
+        <p:nvSpPr>
+          <p:cNvPr id="3" name="Notes Placeholder 2"/>
+          <p:cNvSpPr>
+            <a:spLocks noGrp="1"/>
+          </p:cNvSpPr>
+          <p:nvPr>
+            <p:ph type="body" idx="1"/>
+          </p:nvPr>
+        </p:nvSpPr>
+        <p:spPr/>
+        <p:txBody>
+          <a:bodyPr/>
+          <a:lstStyle/>
+          <a:p>
+            <a:r>
+              <a:rPr lang="en-US" sz="1400" b="0" dirty="0"/>
+              <a:t>Extra. This is a PECO (observational) question: nurses cannot easily be randomised to night shifts.</a:t>
+            </a:r>
+          </a:p>
+          <a:p>
+            <a:r>
+              <a:rPr lang="en-US" sz="1400" b="0" dirty="0"/>
+              <a:t>Timing: 3 minutes if used.</a:t>
+            </a:r>
+          </a:p>
+        </p:txBody>
+      </p:sp>
+      <p:sp>
+        <p:nvSpPr>
+          <p:cNvPr id="4" name="Slide Number Placeholder 3"/>
+          <p:cNvSpPr>
+            <a:spLocks noGrp="1"/>
+          </p:cNvSpPr>
+          <p:nvPr>
+            <p:ph type="sldNum" sz="quarter" idx="10"/>
+          </p:nvPr>
+        </p:nvSpPr>
+        <p:spPr/>
+        <p:txBody>
+          <a:bodyPr/>
+          <a:lstStyle/>
+          <a:p>
+            <a:fld id="{F7021451-1387-4CA6-816F-3879F97B5CBC}" type="slidenum">
+              <a:rPr lang="en-US"/>
+              <a:t>1</a:t>
+            </a:fld>
+          </a:p>
+        </p:txBody>
+      </p:sp>
+    </p:spTree>
+  </p:cSld>
+  <p:clrMapOvr>
+    <a:masterClrMapping/>
+  </p:clrMapOvr>
+</p:notes>
+</file>
+
+<file path=ppt/notesSlides/notesSlide54.xml><?xml version="1.0" encoding="utf-8"?>
 <p:notes xmlns:a="http://schemas.openxmlformats.org/drawingml/2006/main" xmlns:r="http://schemas.openxmlformats.org/officeDocument/2006/relationships" xmlns:p="http://schemas.openxmlformats.org/presentationml/2006/main">
   <p:cSld>
     <p:spTree>
@@ -19877,7 +19989,7 @@
                 <a:latin typeface="Arial"/>
                 <a:cs typeface="Arial"/>
               </a:rPr>
-              <a:t>Both are open access. Download them from the course website (The two papers page).</a:t>
+              <a:t>Both are open access. You receive the two PDFs by email before Session 1.</a:t>
             </a:r>
           </a:p>
         </p:txBody>
@@ -42784,7 +42896,7 @@
                 <a:latin typeface="Arial"/>
                 <a:cs typeface="Arial"/>
               </a:rPr>
-              <a:t>PICO for other kinds of question</a:t>
+              <a:t>Extra: the three examples as research questions</a:t>
             </a:r>
           </a:p>
         </p:txBody>
@@ -42819,13 +42931,52 @@
       </p:sp>
       <p:sp>
         <p:nvSpPr>
+          <p:cNvPr id="19" name="Intro"/>
+          <p:cNvSpPr txBox="1"/>
+          <p:nvPr/>
+        </p:nvSpPr>
+        <p:spPr>
+          <a:xfrm>
+            <a:off x="457200" y="1100000"/>
+            <a:ext cx="11277600" cy="480000"/>
+          </a:xfrm>
+          <a:prstGeom prst="rect">
+            <a:avLst/>
+          </a:prstGeom>
+          <a:noFill/>
+          <a:ln>
+            <a:noFill/>
+          </a:ln>
+        </p:spPr>
+        <p:txBody>
+          <a:bodyPr wrap="square" lIns="91440" tIns="45720" rIns="91440" bIns="45720" rtlCol="0" anchor="t"/>
+          <a:lstStyle/>
+          <a:p>
+            <a:pPr marL="0" indent="0" algn="l">
+              <a:buNone/>
+            </a:pPr>
+            <a:r>
+              <a:rPr lang="en-US" sz="1700" i="1" dirty="0">
+                <a:solidFill>
+                  <a:srgbClr val="595959"/>
+                </a:solidFill>
+                <a:latin typeface="Arial"/>
+                <a:cs typeface="Arial"/>
+              </a:rPr>
+              <a:t>Backup for 'Three more examples': write the question for each row, then compare.</a:t>
+            </a:r>
+          </a:p>
+        </p:txBody>
+      </p:sp>
+      <p:sp>
+        <p:nvSpPr>
           <p:cNvPr id="70" name="CardHead"/>
           <p:cNvSpPr/>
           <p:nvPr/>
         </p:nvSpPr>
         <p:spPr>
           <a:xfrm>
-            <a:off x="457200" y="1635790"/>
+            <a:off x="457200" y="1959815"/>
             <a:ext cx="3625866" cy="640000"/>
           </a:xfrm>
           <a:prstGeom prst="rect">
@@ -42855,7 +43006,7 @@
                 <a:latin typeface="Arial"/>
                 <a:cs typeface="Arial"/>
               </a:rPr>
-              <a:t>Diagnosis</a:t>
+              <a:t>Treatment (PICO)</a:t>
             </a:r>
           </a:p>
         </p:txBody>
@@ -42868,8 +43019,8 @@
         </p:nvSpPr>
         <p:spPr>
           <a:xfrm>
-            <a:off x="457200" y="2275790"/>
-            <a:ext cx="3625866" cy="2142630"/>
+            <a:off x="457200" y="2599815"/>
+            <a:ext cx="3625866" cy="2050555"/>
           </a:xfrm>
           <a:prstGeom prst="rect">
             <a:avLst/>
@@ -42897,16 +43048,87 @@
               <a:buNone/>
             </a:pPr>
             <a:r>
-              <a:rPr lang="en-US" sz="1400" dirty="0">
+              <a:rPr lang="en-US" sz="1750" dirty="0">
                 <a:solidFill>
                   <a:srgbClr val="000000"/>
                 </a:solidFill>
                 <a:latin typeface="Arial"/>
                 <a:cs typeface="Arial"/>
               </a:rPr>
-              <a:t>P: patients tested</a:t>
-            </a:r>
-          </a:p>
+              <a:t>In ventilated adults in the ICU, does a twice-daily bed-head checklist, compared with usual care, reduce ventilator-associated pneumonia by ICU day 28?</a:t>
+            </a:r>
+          </a:p>
+        </p:txBody>
+      </p:sp>
+      <p:sp>
+        <p:nvSpPr>
+          <p:cNvPr id="72" name="CardHead"/>
+          <p:cNvSpPr/>
+          <p:nvPr/>
+        </p:nvSpPr>
+        <p:spPr>
+          <a:xfrm>
+            <a:off x="4283066" y="1959815"/>
+            <a:ext cx="3625866" cy="640000"/>
+          </a:xfrm>
+          <a:prstGeom prst="rect">
+            <a:avLst/>
+          </a:prstGeom>
+          <a:solidFill>
+            <a:srgbClr val="0B376C"/>
+          </a:solidFill>
+          <a:ln>
+            <a:noFill/>
+          </a:ln>
+        </p:spPr>
+        <p:txBody>
+          <a:bodyPr wrap="square" lIns="91440" tIns="45720" rIns="91440" bIns="45720" rtlCol="0" anchor="ctr">
+            <a:normAutofit/>
+          </a:bodyPr>
+          <a:lstStyle/>
+          <a:p>
+            <a:pPr marL="0" indent="0" algn="ctr">
+              <a:buNone/>
+            </a:pPr>
+            <a:r>
+              <a:rPr lang="en-US" sz="1900" b="1" dirty="0">
+                <a:solidFill>
+                  <a:srgbClr val="FFFFFF"/>
+                </a:solidFill>
+                <a:latin typeface="Arial"/>
+                <a:cs typeface="Arial"/>
+              </a:rPr>
+              <a:t>Risk factor (PECO)</a:t>
+            </a:r>
+          </a:p>
+        </p:txBody>
+      </p:sp>
+      <p:sp>
+        <p:nvSpPr>
+          <p:cNvPr id="73" name="CardBody"/>
+          <p:cNvSpPr/>
+          <p:nvPr/>
+        </p:nvSpPr>
+        <p:spPr>
+          <a:xfrm>
+            <a:off x="4283066" y="2599815"/>
+            <a:ext cx="3625866" cy="2050555"/>
+          </a:xfrm>
+          <a:prstGeom prst="rect">
+            <a:avLst/>
+          </a:prstGeom>
+          <a:solidFill>
+            <a:srgbClr val="EAF2F5"/>
+          </a:solidFill>
+          <a:ln>
+            <a:noFill/>
+          </a:ln>
+        </p:spPr>
+        <p:txBody>
+          <a:bodyPr wrap="square" lIns="137160" tIns="91440" rIns="137160" bIns="91440" rtlCol="0" anchor="ctr">
+            <a:normAutofit/>
+          </a:bodyPr>
+          <a:lstStyle/>
           <a:p>
             <a:pPr marL="0" indent="0" algn="ctr">
               <a:lnSpc>
@@ -42918,16 +43140,87 @@
               <a:buNone/>
             </a:pPr>
             <a:r>
-              <a:rPr lang="en-US" sz="1400" dirty="0">
+              <a:rPr lang="en-US" sz="1750" dirty="0">
                 <a:solidFill>
                   <a:srgbClr val="000000"/>
                 </a:solidFill>
                 <a:latin typeface="Arial"/>
                 <a:cs typeface="Arial"/>
               </a:rPr>
-              <a:t>I: the new test</a:t>
-            </a:r>
-          </a:p>
+              <a:t>In adults on the medical ward, is obesity (BMI 30 or more), compared with a BMI under 30, associated with new pressure injury during the admission?</a:t>
+            </a:r>
+          </a:p>
+        </p:txBody>
+      </p:sp>
+      <p:sp>
+        <p:nvSpPr>
+          <p:cNvPr id="74" name="CardHead"/>
+          <p:cNvSpPr/>
+          <p:nvPr/>
+        </p:nvSpPr>
+        <p:spPr>
+          <a:xfrm>
+            <a:off x="8108932" y="1959815"/>
+            <a:ext cx="3625866" cy="640000"/>
+          </a:xfrm>
+          <a:prstGeom prst="rect">
+            <a:avLst/>
+          </a:prstGeom>
+          <a:solidFill>
+            <a:srgbClr val="5FA39B"/>
+          </a:solidFill>
+          <a:ln>
+            <a:noFill/>
+          </a:ln>
+        </p:spPr>
+        <p:txBody>
+          <a:bodyPr wrap="square" lIns="91440" tIns="45720" rIns="91440" bIns="45720" rtlCol="0" anchor="ctr">
+            <a:normAutofit/>
+          </a:bodyPr>
+          <a:lstStyle/>
+          <a:p>
+            <a:pPr marL="0" indent="0" algn="ctr">
+              <a:buNone/>
+            </a:pPr>
+            <a:r>
+              <a:rPr lang="en-US" sz="1900" b="1" dirty="0">
+                <a:solidFill>
+                  <a:srgbClr val="FFFFFF"/>
+                </a:solidFill>
+                <a:latin typeface="Arial"/>
+                <a:cs typeface="Arial"/>
+              </a:rPr>
+              <a:t>How common? (P + O)</a:t>
+            </a:r>
+          </a:p>
+        </p:txBody>
+      </p:sp>
+      <p:sp>
+        <p:nvSpPr>
+          <p:cNvPr id="75" name="CardBody"/>
+          <p:cNvSpPr/>
+          <p:nvPr/>
+        </p:nvSpPr>
+        <p:spPr>
+          <a:xfrm>
+            <a:off x="8108932" y="2599815"/>
+            <a:ext cx="3625866" cy="2050555"/>
+          </a:xfrm>
+          <a:prstGeom prst="rect">
+            <a:avLst/>
+          </a:prstGeom>
+          <a:solidFill>
+            <a:srgbClr val="EAF2F5"/>
+          </a:solidFill>
+          <a:ln>
+            <a:noFill/>
+          </a:ln>
+        </p:spPr>
+        <p:txBody>
+          <a:bodyPr wrap="square" lIns="137160" tIns="91440" rIns="137160" bIns="91440" rtlCol="0" anchor="ctr">
+            <a:normAutofit/>
+          </a:bodyPr>
+          <a:lstStyle/>
           <a:p>
             <a:pPr marL="0" indent="0" algn="ctr">
               <a:lnSpc>
@@ -42939,408 +43232,14 @@
               <a:buNone/>
             </a:pPr>
             <a:r>
-              <a:rPr lang="en-US" sz="1400" dirty="0">
+              <a:rPr lang="en-US" sz="1750" dirty="0">
                 <a:solidFill>
                   <a:srgbClr val="000000"/>
                 </a:solidFill>
                 <a:latin typeface="Arial"/>
                 <a:cs typeface="Arial"/>
               </a:rPr>
-              <a:t>C: the reference standard</a:t>
-            </a:r>
-          </a:p>
-          <a:p>
-            <a:pPr marL="0" indent="0" algn="ctr">
-              <a:lnSpc>
-                <a:spcPct val="104000"/>
-              </a:lnSpc>
-              <a:spcBef>
-                <a:spcPts val="400"/>
-              </a:spcBef>
-              <a:buNone/>
-            </a:pPr>
-            <a:r>
-              <a:rPr lang="en-US" sz="1400" dirty="0">
-                <a:solidFill>
-                  <a:srgbClr val="000000"/>
-                </a:solidFill>
-                <a:latin typeface="Arial"/>
-                <a:cs typeface="Arial"/>
-              </a:rPr>
-              <a:t>O: accuracy</a:t>
-            </a:r>
-          </a:p>
-          <a:p>
-            <a:pPr marL="0" indent="0" algn="ctr">
-              <a:lnSpc>
-                <a:spcPct val="104000"/>
-              </a:lnSpc>
-              <a:spcBef>
-                <a:spcPts val="400"/>
-              </a:spcBef>
-              <a:buNone/>
-            </a:pPr>
-            <a:r>
-              <a:rPr lang="en-US" sz="1400" i="1" dirty="0">
-                <a:solidFill>
-                  <a:srgbClr val="000000"/>
-                </a:solidFill>
-                <a:latin typeface="Arial"/>
-                <a:cs typeface="Arial"/>
-              </a:rPr>
-              <a:t>Example: in suspected sepsis in the emergency department, how accurate is qSOFA compared with Sepsis-3?</a:t>
-            </a:r>
-          </a:p>
-        </p:txBody>
-      </p:sp>
-      <p:sp>
-        <p:nvSpPr>
-          <p:cNvPr id="72" name="CardHead"/>
-          <p:cNvSpPr/>
-          <p:nvPr/>
-        </p:nvSpPr>
-        <p:spPr>
-          <a:xfrm>
-            <a:off x="4283066" y="1635790"/>
-            <a:ext cx="3625866" cy="640000"/>
-          </a:xfrm>
-          <a:prstGeom prst="rect">
-            <a:avLst/>
-          </a:prstGeom>
-          <a:solidFill>
-            <a:srgbClr val="0B376C"/>
-          </a:solidFill>
-          <a:ln>
-            <a:noFill/>
-          </a:ln>
-        </p:spPr>
-        <p:txBody>
-          <a:bodyPr wrap="square" lIns="91440" tIns="45720" rIns="91440" bIns="45720" rtlCol="0" anchor="ctr">
-            <a:normAutofit/>
-          </a:bodyPr>
-          <a:lstStyle/>
-          <a:p>
-            <a:pPr marL="0" indent="0" algn="ctr">
-              <a:buNone/>
-            </a:pPr>
-            <a:r>
-              <a:rPr lang="en-US" sz="1900" b="1" dirty="0">
-                <a:solidFill>
-                  <a:srgbClr val="FFFFFF"/>
-                </a:solidFill>
-                <a:latin typeface="Arial"/>
-                <a:cs typeface="Arial"/>
-              </a:rPr>
-              <a:t>Prognosis</a:t>
-            </a:r>
-          </a:p>
-        </p:txBody>
-      </p:sp>
-      <p:sp>
-        <p:nvSpPr>
-          <p:cNvPr id="73" name="CardBody"/>
-          <p:cNvSpPr/>
-          <p:nvPr/>
-        </p:nvSpPr>
-        <p:spPr>
-          <a:xfrm>
-            <a:off x="4283066" y="2275790"/>
-            <a:ext cx="3625866" cy="2142630"/>
-          </a:xfrm>
-          <a:prstGeom prst="rect">
-            <a:avLst/>
-          </a:prstGeom>
-          <a:solidFill>
-            <a:srgbClr val="EAF2F5"/>
-          </a:solidFill>
-          <a:ln>
-            <a:noFill/>
-          </a:ln>
-        </p:spPr>
-        <p:txBody>
-          <a:bodyPr wrap="square" lIns="137160" tIns="91440" rIns="137160" bIns="91440" rtlCol="0" anchor="ctr">
-            <a:normAutofit/>
-          </a:bodyPr>
-          <a:lstStyle/>
-          <a:p>
-            <a:pPr marL="0" indent="0" algn="ctr">
-              <a:lnSpc>
-                <a:spcPct val="104000"/>
-              </a:lnSpc>
-              <a:spcBef>
-                <a:spcPts val="400"/>
-              </a:spcBef>
-              <a:buNone/>
-            </a:pPr>
-            <a:r>
-              <a:rPr lang="en-US" sz="1400" dirty="0">
-                <a:solidFill>
-                  <a:srgbClr val="000000"/>
-                </a:solidFill>
-                <a:latin typeface="Arial"/>
-                <a:cs typeface="Arial"/>
-              </a:rPr>
-              <a:t>P: patients with a condition</a:t>
-            </a:r>
-          </a:p>
-          <a:p>
-            <a:pPr marL="0" indent="0" algn="ctr">
-              <a:lnSpc>
-                <a:spcPct val="104000"/>
-              </a:lnSpc>
-              <a:spcBef>
-                <a:spcPts val="400"/>
-              </a:spcBef>
-              <a:buNone/>
-            </a:pPr>
-            <a:r>
-              <a:rPr lang="en-US" sz="1400" dirty="0">
-                <a:solidFill>
-                  <a:srgbClr val="000000"/>
-                </a:solidFill>
-                <a:latin typeface="Arial"/>
-                <a:cs typeface="Arial"/>
-              </a:rPr>
-              <a:t>E: a risk factor</a:t>
-            </a:r>
-          </a:p>
-          <a:p>
-            <a:pPr marL="0" indent="0" algn="ctr">
-              <a:lnSpc>
-                <a:spcPct val="104000"/>
-              </a:lnSpc>
-              <a:spcBef>
-                <a:spcPts val="400"/>
-              </a:spcBef>
-              <a:buNone/>
-            </a:pPr>
-            <a:r>
-              <a:rPr lang="en-US" sz="1400" dirty="0">
-                <a:solidFill>
-                  <a:srgbClr val="000000"/>
-                </a:solidFill>
-                <a:latin typeface="Arial"/>
-                <a:cs typeface="Arial"/>
-              </a:rPr>
-              <a:t>O: what happens</a:t>
-            </a:r>
-          </a:p>
-          <a:p>
-            <a:pPr marL="0" indent="0" algn="ctr">
-              <a:lnSpc>
-                <a:spcPct val="104000"/>
-              </a:lnSpc>
-              <a:spcBef>
-                <a:spcPts val="400"/>
-              </a:spcBef>
-              <a:buNone/>
-            </a:pPr>
-            <a:r>
-              <a:rPr lang="en-US" sz="1400" dirty="0">
-                <a:solidFill>
-                  <a:srgbClr val="000000"/>
-                </a:solidFill>
-                <a:latin typeface="Arial"/>
-                <a:cs typeface="Arial"/>
-              </a:rPr>
-              <a:t>T: by when</a:t>
-            </a:r>
-          </a:p>
-          <a:p>
-            <a:pPr marL="0" indent="0" algn="ctr">
-              <a:lnSpc>
-                <a:spcPct val="104000"/>
-              </a:lnSpc>
-              <a:spcBef>
-                <a:spcPts val="400"/>
-              </a:spcBef>
-              <a:buNone/>
-            </a:pPr>
-            <a:r>
-              <a:rPr lang="en-US" sz="1400" i="1" dirty="0">
-                <a:solidFill>
-                  <a:srgbClr val="000000"/>
-                </a:solidFill>
-                <a:latin typeface="Arial"/>
-                <a:cs typeface="Arial"/>
-              </a:rPr>
-              <a:t>Example: in septic shock, is a lactate above 4 mmol/L on admission linked to death by day 28?</a:t>
-            </a:r>
-          </a:p>
-        </p:txBody>
-      </p:sp>
-      <p:sp>
-        <p:nvSpPr>
-          <p:cNvPr id="74" name="CardHead"/>
-          <p:cNvSpPr/>
-          <p:nvPr/>
-        </p:nvSpPr>
-        <p:spPr>
-          <a:xfrm>
-            <a:off x="8108932" y="1635790"/>
-            <a:ext cx="3625866" cy="640000"/>
-          </a:xfrm>
-          <a:prstGeom prst="rect">
-            <a:avLst/>
-          </a:prstGeom>
-          <a:solidFill>
-            <a:srgbClr val="5FA39B"/>
-          </a:solidFill>
-          <a:ln>
-            <a:noFill/>
-          </a:ln>
-        </p:spPr>
-        <p:txBody>
-          <a:bodyPr wrap="square" lIns="91440" tIns="45720" rIns="91440" bIns="45720" rtlCol="0" anchor="ctr">
-            <a:normAutofit/>
-          </a:bodyPr>
-          <a:lstStyle/>
-          <a:p>
-            <a:pPr marL="0" indent="0" algn="ctr">
-              <a:buNone/>
-            </a:pPr>
-            <a:r>
-              <a:rPr lang="en-US" sz="1900" b="1" dirty="0">
-                <a:solidFill>
-                  <a:srgbClr val="FFFFFF"/>
-                </a:solidFill>
-                <a:latin typeface="Arial"/>
-                <a:cs typeface="Arial"/>
-              </a:rPr>
-              <a:t>Qualitative (SPIDER)</a:t>
-            </a:r>
-          </a:p>
-        </p:txBody>
-      </p:sp>
-      <p:sp>
-        <p:nvSpPr>
-          <p:cNvPr id="75" name="CardBody"/>
-          <p:cNvSpPr/>
-          <p:nvPr/>
-        </p:nvSpPr>
-        <p:spPr>
-          <a:xfrm>
-            <a:off x="8108932" y="2275790"/>
-            <a:ext cx="3625866" cy="2142630"/>
-          </a:xfrm>
-          <a:prstGeom prst="rect">
-            <a:avLst/>
-          </a:prstGeom>
-          <a:solidFill>
-            <a:srgbClr val="EAF2F5"/>
-          </a:solidFill>
-          <a:ln>
-            <a:noFill/>
-          </a:ln>
-        </p:spPr>
-        <p:txBody>
-          <a:bodyPr wrap="square" lIns="137160" tIns="91440" rIns="137160" bIns="91440" rtlCol="0" anchor="ctr">
-            <a:normAutofit/>
-          </a:bodyPr>
-          <a:lstStyle/>
-          <a:p>
-            <a:pPr marL="0" indent="0" algn="ctr">
-              <a:lnSpc>
-                <a:spcPct val="104000"/>
-              </a:lnSpc>
-              <a:spcBef>
-                <a:spcPts val="400"/>
-              </a:spcBef>
-              <a:buNone/>
-            </a:pPr>
-            <a:r>
-              <a:rPr lang="en-US" sz="1400" dirty="0">
-                <a:solidFill>
-                  <a:srgbClr val="000000"/>
-                </a:solidFill>
-                <a:latin typeface="Arial"/>
-                <a:cs typeface="Arial"/>
-              </a:rPr>
-              <a:t>S: Sample</a:t>
-            </a:r>
-          </a:p>
-          <a:p>
-            <a:pPr marL="0" indent="0" algn="ctr">
-              <a:lnSpc>
-                <a:spcPct val="104000"/>
-              </a:lnSpc>
-              <a:spcBef>
-                <a:spcPts val="400"/>
-              </a:spcBef>
-              <a:buNone/>
-            </a:pPr>
-            <a:r>
-              <a:rPr lang="en-US" sz="1400" dirty="0">
-                <a:solidFill>
-                  <a:srgbClr val="000000"/>
-                </a:solidFill>
-                <a:latin typeface="Arial"/>
-                <a:cs typeface="Arial"/>
-              </a:rPr>
-              <a:t>PI: Phenomenon of Interest</a:t>
-            </a:r>
-          </a:p>
-          <a:p>
-            <a:pPr marL="0" indent="0" algn="ctr">
-              <a:lnSpc>
-                <a:spcPct val="104000"/>
-              </a:lnSpc>
-              <a:spcBef>
-                <a:spcPts val="400"/>
-              </a:spcBef>
-              <a:buNone/>
-            </a:pPr>
-            <a:r>
-              <a:rPr lang="en-US" sz="1400" dirty="0">
-                <a:solidFill>
-                  <a:srgbClr val="000000"/>
-                </a:solidFill>
-                <a:latin typeface="Arial"/>
-                <a:cs typeface="Arial"/>
-              </a:rPr>
-              <a:t>D: Design</a:t>
-            </a:r>
-          </a:p>
-          <a:p>
-            <a:pPr marL="0" indent="0" algn="ctr">
-              <a:lnSpc>
-                <a:spcPct val="104000"/>
-              </a:lnSpc>
-              <a:spcBef>
-                <a:spcPts val="400"/>
-              </a:spcBef>
-              <a:buNone/>
-            </a:pPr>
-            <a:r>
-              <a:rPr lang="en-US" sz="1400" dirty="0">
-                <a:solidFill>
-                  <a:srgbClr val="000000"/>
-                </a:solidFill>
-                <a:latin typeface="Arial"/>
-                <a:cs typeface="Arial"/>
-              </a:rPr>
-              <a:t>E: Evaluation, R: Research type</a:t>
-            </a:r>
-          </a:p>
-          <a:p>
-            <a:pPr marL="0" indent="0" algn="ctr">
-              <a:lnSpc>
-                <a:spcPct val="104000"/>
-              </a:lnSpc>
-              <a:spcBef>
-                <a:spcPts val="400"/>
-              </a:spcBef>
-              <a:buNone/>
-            </a:pPr>
-            <a:r>
-              <a:rPr lang="en-US" sz="1400" i="1" dirty="0">
-                <a:solidFill>
-                  <a:srgbClr val="000000"/>
-                </a:solidFill>
-                <a:latin typeface="Arial"/>
-                <a:cs typeface="Arial"/>
-              </a:rPr>
-              <a:t>Example: how do ICU nurses experience stopping IV fluids, in interviews?</a:t>
+              <a:t>In adults aged 65 or over after hip surgery, how common is delirium in the first 7 days?</a:t>
             </a:r>
           </a:p>
         </p:txBody>
@@ -43395,7 +43294,7 @@
                 <a:latin typeface="Arial"/>
                 <a:cs typeface="Arial"/>
               </a:rPr>
-              <a:t>The letters change, but the idea stays the same: be explicit.</a:t>
+              <a:t>Each question names the patients, the comparison (if any), the outcome and the time.</a:t>
             </a:r>
           </a:p>
         </p:txBody>
@@ -43563,7 +43462,7 @@
                 <a:latin typeface="Arial"/>
                 <a:cs typeface="Arial"/>
               </a:rPr>
-              <a:t>More practice: which FINER letter fails?</a:t>
+              <a:t>PICO for other kinds of question</a:t>
             </a:r>
           </a:p>
         </p:txBody>
@@ -43598,181 +43497,542 @@
       </p:sp>
       <p:sp>
         <p:nvSpPr>
-          <p:cNvPr id="50" name="Banner"/>
-          <p:cNvSpPr/>
-          <p:nvPr/>
-        </p:nvSpPr>
-        <p:spPr>
-          <a:xfrm>
-            <a:off x="457200" y="1120000"/>
-            <a:ext cx="11277600" cy="470000"/>
+          <p:cNvPr id="70" name="CardHead"/>
+          <p:cNvSpPr/>
+          <p:nvPr/>
+        </p:nvSpPr>
+        <p:spPr>
+          <a:xfrm>
+            <a:off x="457200" y="1635790"/>
+            <a:ext cx="3625866" cy="640000"/>
           </a:xfrm>
           <a:prstGeom prst="rect">
             <a:avLst/>
           </a:prstGeom>
           <a:solidFill>
-            <a:srgbClr val="6C3483"/>
+            <a:srgbClr val="0D7377"/>
           </a:solidFill>
           <a:ln>
             <a:noFill/>
           </a:ln>
         </p:spPr>
         <p:txBody>
-          <a:bodyPr wrap="square" lIns="182880" tIns="45720" rIns="182880" bIns="45720" rtlCol="0" anchor="ctr">
+          <a:bodyPr wrap="square" lIns="91440" tIns="45720" rIns="91440" bIns="45720" rtlCol="0" anchor="ctr">
             <a:normAutofit/>
           </a:bodyPr>
           <a:lstStyle/>
           <a:p>
-            <a:pPr marL="0" indent="0" algn="l">
-              <a:buNone/>
-            </a:pPr>
-            <a:r>
-              <a:rPr lang="en-US" sz="1500" b="1" dirty="0">
+            <a:pPr marL="0" indent="0" algn="ctr">
+              <a:buNone/>
+            </a:pPr>
+            <a:r>
+              <a:rPr lang="en-US" sz="1900" b="1" dirty="0">
                 <a:solidFill>
                   <a:srgbClr val="FFFFFF"/>
                 </a:solidFill>
                 <a:latin typeface="Arial"/>
                 <a:cs typeface="Arial"/>
               </a:rPr>
-              <a:t>QUICK QUIZ   |   4 min</a:t>
-            </a:r>
-          </a:p>
-        </p:txBody>
-      </p:sp>
-      <p:sp>
-        <p:nvSpPr>
-          <p:cNvPr id="51" name="Steps"/>
-          <p:cNvSpPr txBox="1"/>
-          <p:nvPr/>
-        </p:nvSpPr>
-        <p:spPr>
-          <a:xfrm>
-            <a:off x="457200" y="1720000"/>
-            <a:ext cx="11277600" cy="3510000"/>
+              <a:t>Diagnosis</a:t>
+            </a:r>
+          </a:p>
+        </p:txBody>
+      </p:sp>
+      <p:sp>
+        <p:nvSpPr>
+          <p:cNvPr id="71" name="CardBody"/>
+          <p:cNvSpPr/>
+          <p:nvPr/>
+        </p:nvSpPr>
+        <p:spPr>
+          <a:xfrm>
+            <a:off x="457200" y="2275790"/>
+            <a:ext cx="3625866" cy="2142630"/>
           </a:xfrm>
           <a:prstGeom prst="rect">
             <a:avLst/>
           </a:prstGeom>
-          <a:noFill/>
-          <a:ln>
-            <a:noFill/>
-          </a:ln>
-        </p:spPr>
-        <p:txBody>
-          <a:bodyPr wrap="square" lIns="91440" tIns="45720" rIns="91440" bIns="45720" rtlCol="0" anchor="t"/>
-          <a:lstStyle/>
-          <a:p>
-            <a:pPr marL="380000" indent="-380000" algn="l">
+          <a:solidFill>
+            <a:srgbClr val="EAF2F5"/>
+          </a:solidFill>
+          <a:ln>
+            <a:noFill/>
+          </a:ln>
+        </p:spPr>
+        <p:txBody>
+          <a:bodyPr wrap="square" lIns="137160" tIns="91440" rIns="137160" bIns="91440" rtlCol="0" anchor="ctr">
+            <a:normAutofit/>
+          </a:bodyPr>
+          <a:lstStyle/>
+          <a:p>
+            <a:pPr marL="0" indent="0" algn="ctr">
               <a:lnSpc>
                 <a:spcPct val="104000"/>
               </a:lnSpc>
               <a:spcBef>
-                <a:spcPts val="450"/>
+                <a:spcPts val="400"/>
               </a:spcBef>
-              <a:buClr>
-                <a:srgbClr val="6C3483"/>
-              </a:buClr>
-              <a:buFont typeface="Arial"/>
-              <a:buChar char="•"/>
-            </a:pPr>
-            <a:r>
-              <a:rPr lang="en-US" sz="1650" dirty="0">
+              <a:buNone/>
+            </a:pPr>
+            <a:r>
+              <a:rPr lang="en-US" sz="1400" dirty="0">
                 <a:solidFill>
                   <a:srgbClr val="000000"/>
                 </a:solidFill>
                 <a:latin typeface="Arial"/>
                 <a:cs typeface="Arial"/>
               </a:rPr>
-              <a:t>All hospitalised adults in the country: does vitamin D reduce mortality over 10 years?</a:t>
-            </a:r>
-          </a:p>
-          <a:p>
-            <a:pPr marL="380000" indent="-380000" algn="l">
+              <a:t>P: patients tested</a:t>
+            </a:r>
+          </a:p>
+          <a:p>
+            <a:pPr marL="0" indent="0" algn="ctr">
               <a:lnSpc>
                 <a:spcPct val="104000"/>
               </a:lnSpc>
               <a:spcBef>
-                <a:spcPts val="450"/>
+                <a:spcPts val="400"/>
               </a:spcBef>
-              <a:buClr>
-                <a:srgbClr val="6C3483"/>
-              </a:buClr>
-              <a:buFont typeface="Arial"/>
-              <a:buChar char="•"/>
-            </a:pPr>
-            <a:r>
-              <a:rPr lang="en-US" sz="1650" dirty="0">
+              <a:buNone/>
+            </a:pPr>
+            <a:r>
+              <a:rPr lang="en-US" sz="1400" dirty="0">
                 <a:solidFill>
                   <a:srgbClr val="000000"/>
                 </a:solidFill>
                 <a:latin typeface="Arial"/>
                 <a:cs typeface="Arial"/>
               </a:rPr>
-              <a:t>Septic shock: does withholding antibiotics for 24 h reduce resistance?</a:t>
-            </a:r>
-          </a:p>
-          <a:p>
-            <a:pPr marL="380000" indent="-380000" algn="l">
+              <a:t>I: the new test</a:t>
+            </a:r>
+          </a:p>
+          <a:p>
+            <a:pPr marL="0" indent="0" algn="ctr">
               <a:lnSpc>
                 <a:spcPct val="104000"/>
               </a:lnSpc>
               <a:spcBef>
-                <a:spcPts val="450"/>
+                <a:spcPts val="400"/>
               </a:spcBef>
-              <a:buClr>
-                <a:srgbClr val="6C3483"/>
-              </a:buClr>
-              <a:buFont typeface="Arial"/>
-              <a:buChar char="•"/>
-            </a:pPr>
-            <a:r>
-              <a:rPr lang="en-US" sz="1650" dirty="0">
+              <a:buNone/>
+            </a:pPr>
+            <a:r>
+              <a:rPr lang="en-US" sz="1400" dirty="0">
                 <a:solidFill>
                   <a:srgbClr val="000000"/>
                 </a:solidFill>
                 <a:latin typeface="Arial"/>
                 <a:cs typeface="Arial"/>
               </a:rPr>
-              <a:t>Do our ICU nurses wash their hands? (audited monthly for 5 years)</a:t>
-            </a:r>
-          </a:p>
-          <a:p>
-            <a:pPr marL="380000" indent="-380000" algn="l">
+              <a:t>C: the reference standard</a:t>
+            </a:r>
+          </a:p>
+          <a:p>
+            <a:pPr marL="0" indent="0" algn="ctr">
               <a:lnSpc>
                 <a:spcPct val="104000"/>
               </a:lnSpc>
               <a:spcBef>
-                <a:spcPts val="450"/>
+                <a:spcPts val="400"/>
               </a:spcBef>
-              <a:buClr>
-                <a:srgbClr val="6C3483"/>
-              </a:buClr>
-              <a:buFont typeface="Arial"/>
-              <a:buChar char="•"/>
-            </a:pPr>
-            <a:r>
-              <a:rPr lang="en-US" sz="1650" dirty="0">
+              <a:buNone/>
+            </a:pPr>
+            <a:r>
+              <a:rPr lang="en-US" sz="1400" dirty="0">
                 <a:solidFill>
                   <a:srgbClr val="000000"/>
                 </a:solidFill>
                 <a:latin typeface="Arial"/>
                 <a:cs typeface="Arial"/>
               </a:rPr>
-              <a:t>Pneumonia: does the colour of the drug chart affect 28-day mortality?</a:t>
-            </a:r>
-          </a:p>
-        </p:txBody>
-      </p:sp>
-      <p:sp>
-        <p:nvSpPr>
-          <p:cNvPr id="53" name="Deliverable"/>
-          <p:cNvSpPr/>
-          <p:nvPr/>
-        </p:nvSpPr>
-        <p:spPr>
-          <a:xfrm>
-            <a:off x="457200" y="5350000"/>
-            <a:ext cx="11277600" cy="600000"/>
+              <a:t>O: accuracy</a:t>
+            </a:r>
+          </a:p>
+          <a:p>
+            <a:pPr marL="0" indent="0" algn="ctr">
+              <a:lnSpc>
+                <a:spcPct val="104000"/>
+              </a:lnSpc>
+              <a:spcBef>
+                <a:spcPts val="400"/>
+              </a:spcBef>
+              <a:buNone/>
+            </a:pPr>
+            <a:r>
+              <a:rPr lang="en-US" sz="1400" i="1" dirty="0">
+                <a:solidFill>
+                  <a:srgbClr val="000000"/>
+                </a:solidFill>
+                <a:latin typeface="Arial"/>
+                <a:cs typeface="Arial"/>
+              </a:rPr>
+              <a:t>Example: in suspected sepsis in the emergency department, how accurate is qSOFA compared with Sepsis-3?</a:t>
+            </a:r>
+          </a:p>
+        </p:txBody>
+      </p:sp>
+      <p:sp>
+        <p:nvSpPr>
+          <p:cNvPr id="72" name="CardHead"/>
+          <p:cNvSpPr/>
+          <p:nvPr/>
+        </p:nvSpPr>
+        <p:spPr>
+          <a:xfrm>
+            <a:off x="4283066" y="1635790"/>
+            <a:ext cx="3625866" cy="640000"/>
+          </a:xfrm>
+          <a:prstGeom prst="rect">
+            <a:avLst/>
+          </a:prstGeom>
+          <a:solidFill>
+            <a:srgbClr val="0B376C"/>
+          </a:solidFill>
+          <a:ln>
+            <a:noFill/>
+          </a:ln>
+        </p:spPr>
+        <p:txBody>
+          <a:bodyPr wrap="square" lIns="91440" tIns="45720" rIns="91440" bIns="45720" rtlCol="0" anchor="ctr">
+            <a:normAutofit/>
+          </a:bodyPr>
+          <a:lstStyle/>
+          <a:p>
+            <a:pPr marL="0" indent="0" algn="ctr">
+              <a:buNone/>
+            </a:pPr>
+            <a:r>
+              <a:rPr lang="en-US" sz="1900" b="1" dirty="0">
+                <a:solidFill>
+                  <a:srgbClr val="FFFFFF"/>
+                </a:solidFill>
+                <a:latin typeface="Arial"/>
+                <a:cs typeface="Arial"/>
+              </a:rPr>
+              <a:t>Prognosis</a:t>
+            </a:r>
+          </a:p>
+        </p:txBody>
+      </p:sp>
+      <p:sp>
+        <p:nvSpPr>
+          <p:cNvPr id="73" name="CardBody"/>
+          <p:cNvSpPr/>
+          <p:nvPr/>
+        </p:nvSpPr>
+        <p:spPr>
+          <a:xfrm>
+            <a:off x="4283066" y="2275790"/>
+            <a:ext cx="3625866" cy="2142630"/>
+          </a:xfrm>
+          <a:prstGeom prst="rect">
+            <a:avLst/>
+          </a:prstGeom>
+          <a:solidFill>
+            <a:srgbClr val="EAF2F5"/>
+          </a:solidFill>
+          <a:ln>
+            <a:noFill/>
+          </a:ln>
+        </p:spPr>
+        <p:txBody>
+          <a:bodyPr wrap="square" lIns="137160" tIns="91440" rIns="137160" bIns="91440" rtlCol="0" anchor="ctr">
+            <a:normAutofit/>
+          </a:bodyPr>
+          <a:lstStyle/>
+          <a:p>
+            <a:pPr marL="0" indent="0" algn="ctr">
+              <a:lnSpc>
+                <a:spcPct val="104000"/>
+              </a:lnSpc>
+              <a:spcBef>
+                <a:spcPts val="400"/>
+              </a:spcBef>
+              <a:buNone/>
+            </a:pPr>
+            <a:r>
+              <a:rPr lang="en-US" sz="1400" dirty="0">
+                <a:solidFill>
+                  <a:srgbClr val="000000"/>
+                </a:solidFill>
+                <a:latin typeface="Arial"/>
+                <a:cs typeface="Arial"/>
+              </a:rPr>
+              <a:t>P: patients with a condition</a:t>
+            </a:r>
+          </a:p>
+          <a:p>
+            <a:pPr marL="0" indent="0" algn="ctr">
+              <a:lnSpc>
+                <a:spcPct val="104000"/>
+              </a:lnSpc>
+              <a:spcBef>
+                <a:spcPts val="400"/>
+              </a:spcBef>
+              <a:buNone/>
+            </a:pPr>
+            <a:r>
+              <a:rPr lang="en-US" sz="1400" dirty="0">
+                <a:solidFill>
+                  <a:srgbClr val="000000"/>
+                </a:solidFill>
+                <a:latin typeface="Arial"/>
+                <a:cs typeface="Arial"/>
+              </a:rPr>
+              <a:t>E: a risk factor</a:t>
+            </a:r>
+          </a:p>
+          <a:p>
+            <a:pPr marL="0" indent="0" algn="ctr">
+              <a:lnSpc>
+                <a:spcPct val="104000"/>
+              </a:lnSpc>
+              <a:spcBef>
+                <a:spcPts val="400"/>
+              </a:spcBef>
+              <a:buNone/>
+            </a:pPr>
+            <a:r>
+              <a:rPr lang="en-US" sz="1400" dirty="0">
+                <a:solidFill>
+                  <a:srgbClr val="000000"/>
+                </a:solidFill>
+                <a:latin typeface="Arial"/>
+                <a:cs typeface="Arial"/>
+              </a:rPr>
+              <a:t>O: what happens</a:t>
+            </a:r>
+          </a:p>
+          <a:p>
+            <a:pPr marL="0" indent="0" algn="ctr">
+              <a:lnSpc>
+                <a:spcPct val="104000"/>
+              </a:lnSpc>
+              <a:spcBef>
+                <a:spcPts val="400"/>
+              </a:spcBef>
+              <a:buNone/>
+            </a:pPr>
+            <a:r>
+              <a:rPr lang="en-US" sz="1400" dirty="0">
+                <a:solidFill>
+                  <a:srgbClr val="000000"/>
+                </a:solidFill>
+                <a:latin typeface="Arial"/>
+                <a:cs typeface="Arial"/>
+              </a:rPr>
+              <a:t>T: by when</a:t>
+            </a:r>
+          </a:p>
+          <a:p>
+            <a:pPr marL="0" indent="0" algn="ctr">
+              <a:lnSpc>
+                <a:spcPct val="104000"/>
+              </a:lnSpc>
+              <a:spcBef>
+                <a:spcPts val="400"/>
+              </a:spcBef>
+              <a:buNone/>
+            </a:pPr>
+            <a:r>
+              <a:rPr lang="en-US" sz="1400" i="1" dirty="0">
+                <a:solidFill>
+                  <a:srgbClr val="000000"/>
+                </a:solidFill>
+                <a:latin typeface="Arial"/>
+                <a:cs typeface="Arial"/>
+              </a:rPr>
+              <a:t>Example: in septic shock, is a lactate above 4 mmol/L on admission linked to death by day 28?</a:t>
+            </a:r>
+          </a:p>
+        </p:txBody>
+      </p:sp>
+      <p:sp>
+        <p:nvSpPr>
+          <p:cNvPr id="74" name="CardHead"/>
+          <p:cNvSpPr/>
+          <p:nvPr/>
+        </p:nvSpPr>
+        <p:spPr>
+          <a:xfrm>
+            <a:off x="8108932" y="1635790"/>
+            <a:ext cx="3625866" cy="640000"/>
+          </a:xfrm>
+          <a:prstGeom prst="rect">
+            <a:avLst/>
+          </a:prstGeom>
+          <a:solidFill>
+            <a:srgbClr val="5FA39B"/>
+          </a:solidFill>
+          <a:ln>
+            <a:noFill/>
+          </a:ln>
+        </p:spPr>
+        <p:txBody>
+          <a:bodyPr wrap="square" lIns="91440" tIns="45720" rIns="91440" bIns="45720" rtlCol="0" anchor="ctr">
+            <a:normAutofit/>
+          </a:bodyPr>
+          <a:lstStyle/>
+          <a:p>
+            <a:pPr marL="0" indent="0" algn="ctr">
+              <a:buNone/>
+            </a:pPr>
+            <a:r>
+              <a:rPr lang="en-US" sz="1900" b="1" dirty="0">
+                <a:solidFill>
+                  <a:srgbClr val="FFFFFF"/>
+                </a:solidFill>
+                <a:latin typeface="Arial"/>
+                <a:cs typeface="Arial"/>
+              </a:rPr>
+              <a:t>Qualitative (SPIDER)</a:t>
+            </a:r>
+          </a:p>
+        </p:txBody>
+      </p:sp>
+      <p:sp>
+        <p:nvSpPr>
+          <p:cNvPr id="75" name="CardBody"/>
+          <p:cNvSpPr/>
+          <p:nvPr/>
+        </p:nvSpPr>
+        <p:spPr>
+          <a:xfrm>
+            <a:off x="8108932" y="2275790"/>
+            <a:ext cx="3625866" cy="2142630"/>
+          </a:xfrm>
+          <a:prstGeom prst="rect">
+            <a:avLst/>
+          </a:prstGeom>
+          <a:solidFill>
+            <a:srgbClr val="EAF2F5"/>
+          </a:solidFill>
+          <a:ln>
+            <a:noFill/>
+          </a:ln>
+        </p:spPr>
+        <p:txBody>
+          <a:bodyPr wrap="square" lIns="137160" tIns="91440" rIns="137160" bIns="91440" rtlCol="0" anchor="ctr">
+            <a:normAutofit/>
+          </a:bodyPr>
+          <a:lstStyle/>
+          <a:p>
+            <a:pPr marL="0" indent="0" algn="ctr">
+              <a:lnSpc>
+                <a:spcPct val="104000"/>
+              </a:lnSpc>
+              <a:spcBef>
+                <a:spcPts val="400"/>
+              </a:spcBef>
+              <a:buNone/>
+            </a:pPr>
+            <a:r>
+              <a:rPr lang="en-US" sz="1400" dirty="0">
+                <a:solidFill>
+                  <a:srgbClr val="000000"/>
+                </a:solidFill>
+                <a:latin typeface="Arial"/>
+                <a:cs typeface="Arial"/>
+              </a:rPr>
+              <a:t>S: Sample</a:t>
+            </a:r>
+          </a:p>
+          <a:p>
+            <a:pPr marL="0" indent="0" algn="ctr">
+              <a:lnSpc>
+                <a:spcPct val="104000"/>
+              </a:lnSpc>
+              <a:spcBef>
+                <a:spcPts val="400"/>
+              </a:spcBef>
+              <a:buNone/>
+            </a:pPr>
+            <a:r>
+              <a:rPr lang="en-US" sz="1400" dirty="0">
+                <a:solidFill>
+                  <a:srgbClr val="000000"/>
+                </a:solidFill>
+                <a:latin typeface="Arial"/>
+                <a:cs typeface="Arial"/>
+              </a:rPr>
+              <a:t>PI: Phenomenon of Interest</a:t>
+            </a:r>
+          </a:p>
+          <a:p>
+            <a:pPr marL="0" indent="0" algn="ctr">
+              <a:lnSpc>
+                <a:spcPct val="104000"/>
+              </a:lnSpc>
+              <a:spcBef>
+                <a:spcPts val="400"/>
+              </a:spcBef>
+              <a:buNone/>
+            </a:pPr>
+            <a:r>
+              <a:rPr lang="en-US" sz="1400" dirty="0">
+                <a:solidFill>
+                  <a:srgbClr val="000000"/>
+                </a:solidFill>
+                <a:latin typeface="Arial"/>
+                <a:cs typeface="Arial"/>
+              </a:rPr>
+              <a:t>D: Design</a:t>
+            </a:r>
+          </a:p>
+          <a:p>
+            <a:pPr marL="0" indent="0" algn="ctr">
+              <a:lnSpc>
+                <a:spcPct val="104000"/>
+              </a:lnSpc>
+              <a:spcBef>
+                <a:spcPts val="400"/>
+              </a:spcBef>
+              <a:buNone/>
+            </a:pPr>
+            <a:r>
+              <a:rPr lang="en-US" sz="1400" dirty="0">
+                <a:solidFill>
+                  <a:srgbClr val="000000"/>
+                </a:solidFill>
+                <a:latin typeface="Arial"/>
+                <a:cs typeface="Arial"/>
+              </a:rPr>
+              <a:t>E: Evaluation, R: Research type</a:t>
+            </a:r>
+          </a:p>
+          <a:p>
+            <a:pPr marL="0" indent="0" algn="ctr">
+              <a:lnSpc>
+                <a:spcPct val="104000"/>
+              </a:lnSpc>
+              <a:spcBef>
+                <a:spcPts val="400"/>
+              </a:spcBef>
+              <a:buNone/>
+            </a:pPr>
+            <a:r>
+              <a:rPr lang="en-US" sz="1400" i="1" dirty="0">
+                <a:solidFill>
+                  <a:srgbClr val="000000"/>
+                </a:solidFill>
+                <a:latin typeface="Arial"/>
+                <a:cs typeface="Arial"/>
+              </a:rPr>
+              <a:t>Example: how do ICU nurses experience stopping IV fluids, in interviews?</a:t>
+            </a:r>
+          </a:p>
+        </p:txBody>
+      </p:sp>
+      <p:sp>
+        <p:nvSpPr>
+          <p:cNvPr id="60" name="Takeaway"/>
+          <p:cNvSpPr/>
+          <p:nvPr/>
+        </p:nvSpPr>
+        <p:spPr>
+          <a:xfrm>
+            <a:off x="457200" y="5390000"/>
+            <a:ext cx="11277600" cy="560000"/>
           </a:xfrm>
           <a:prstGeom prst="roundRect">
             <a:avLst>
@@ -43780,12 +44040,10 @@
             </a:avLst>
           </a:prstGeom>
           <a:solidFill>
-            <a:srgbClr val="FFFFFF"/>
+            <a:srgbClr val="0D7377"/>
           </a:solidFill>
-          <a:ln w="15875">
-            <a:solidFill>
-              <a:srgbClr val="6C3483"/>
-            </a:solidFill>
+          <a:ln>
+            <a:noFill/>
           </a:ln>
         </p:spPr>
         <p:txBody>
@@ -43800,22 +44058,22 @@
             <a:r>
               <a:rPr lang="en-US" sz="1300" b="1" dirty="0">
                 <a:solidFill>
-                  <a:srgbClr val="6C3483"/>
-                </a:solidFill>
-                <a:latin typeface="Arial"/>
-                <a:cs typeface="Arial"/>
-              </a:rPr>
-              <a:t>OUTPUT   </a:t>
-            </a:r>
-            <a:r>
-              <a:rPr lang="en-US" sz="1500" dirty="0">
-                <a:solidFill>
-                  <a:srgbClr val="000000"/>
-                </a:solidFill>
-                <a:latin typeface="Arial"/>
-                <a:cs typeface="Arial"/>
-              </a:rPr>
-              <a:t>One letter per question, in the poll</a:t>
+                  <a:srgbClr val="FFFFFF"/>
+                </a:solidFill>
+                <a:latin typeface="Arial"/>
+                <a:cs typeface="Arial"/>
+              </a:rPr>
+              <a:t>KEY MESSAGE   </a:t>
+            </a:r>
+            <a:r>
+              <a:rPr lang="en-US" sz="1550" dirty="0">
+                <a:solidFill>
+                  <a:srgbClr val="FFFFFF"/>
+                </a:solidFill>
+                <a:latin typeface="Arial"/>
+                <a:cs typeface="Arial"/>
+              </a:rPr>
+              <a:t>The letters change, but the idea stays the same: be explicit.</a:t>
             </a:r>
           </a:p>
         </p:txBody>
@@ -43983,7 +44241,7 @@
                 <a:latin typeface="Arial"/>
                 <a:cs typeface="Arial"/>
               </a:rPr>
-              <a:t>Vague vs answerable: another example from the ward</a:t>
+              <a:t>More practice: which FINER letter fails?</a:t>
             </a:r>
           </a:p>
         </p:txBody>
@@ -44018,366 +44276,181 @@
       </p:sp>
       <p:sp>
         <p:nvSpPr>
-          <p:cNvPr id="70" name="CardHead"/>
-          <p:cNvSpPr/>
-          <p:nvPr/>
-        </p:nvSpPr>
-        <p:spPr>
-          <a:xfrm>
-            <a:off x="457200" y="1535249"/>
-            <a:ext cx="5538800" cy="640000"/>
+          <p:cNvPr id="50" name="Banner"/>
+          <p:cNvSpPr/>
+          <p:nvPr/>
+        </p:nvSpPr>
+        <p:spPr>
+          <a:xfrm>
+            <a:off x="457200" y="1120000"/>
+            <a:ext cx="11277600" cy="470000"/>
           </a:xfrm>
           <a:prstGeom prst="rect">
             <a:avLst/>
           </a:prstGeom>
           <a:solidFill>
-            <a:srgbClr val="B23B2E"/>
+            <a:srgbClr val="6C3483"/>
           </a:solidFill>
           <a:ln>
             <a:noFill/>
           </a:ln>
         </p:spPr>
         <p:txBody>
-          <a:bodyPr wrap="square" lIns="91440" tIns="45720" rIns="91440" bIns="45720" rtlCol="0" anchor="ctr">
+          <a:bodyPr wrap="square" lIns="182880" tIns="45720" rIns="182880" bIns="45720" rtlCol="0" anchor="ctr">
             <a:normAutofit/>
           </a:bodyPr>
           <a:lstStyle/>
           <a:p>
-            <a:pPr marL="0" indent="0" algn="ctr">
-              <a:buNone/>
-            </a:pPr>
-            <a:r>
-              <a:rPr lang="en-US" sz="1900" b="1" dirty="0">
+            <a:pPr marL="0" indent="0" algn="l">
+              <a:buNone/>
+            </a:pPr>
+            <a:r>
+              <a:rPr lang="en-US" sz="1500" b="1" dirty="0">
                 <a:solidFill>
                   <a:srgbClr val="FFFFFF"/>
                 </a:solidFill>
                 <a:latin typeface="Arial"/>
                 <a:cs typeface="Arial"/>
               </a:rPr>
-              <a:t>Vague</a:t>
-            </a:r>
-          </a:p>
-        </p:txBody>
-      </p:sp>
-      <p:sp>
-        <p:nvSpPr>
-          <p:cNvPr id="71" name="CardBody"/>
-          <p:cNvSpPr/>
-          <p:nvPr/>
-        </p:nvSpPr>
-        <p:spPr>
-          <a:xfrm>
-            <a:off x="457200" y="2175249"/>
-            <a:ext cx="5538800" cy="2444253"/>
+              <a:t>QUICK QUIZ   |   4 min</a:t>
+            </a:r>
+          </a:p>
+        </p:txBody>
+      </p:sp>
+      <p:sp>
+        <p:nvSpPr>
+          <p:cNvPr id="51" name="Steps"/>
+          <p:cNvSpPr txBox="1"/>
+          <p:nvPr/>
+        </p:nvSpPr>
+        <p:spPr>
+          <a:xfrm>
+            <a:off x="457200" y="1720000"/>
+            <a:ext cx="11277600" cy="3510000"/>
           </a:xfrm>
           <a:prstGeom prst="rect">
             <a:avLst/>
           </a:prstGeom>
-          <a:solidFill>
-            <a:srgbClr val="EAF2F5"/>
-          </a:solidFill>
-          <a:ln>
-            <a:noFill/>
-          </a:ln>
-        </p:spPr>
-        <p:txBody>
-          <a:bodyPr wrap="square" lIns="137160" tIns="91440" rIns="137160" bIns="91440" rtlCol="0" anchor="ctr">
-            <a:normAutofit/>
-          </a:bodyPr>
-          <a:lstStyle/>
-          <a:p>
-            <a:pPr marL="0" indent="0" algn="ctr">
+          <a:noFill/>
+          <a:ln>
+            <a:noFill/>
+          </a:ln>
+        </p:spPr>
+        <p:txBody>
+          <a:bodyPr wrap="square" lIns="91440" tIns="45720" rIns="91440" bIns="45720" rtlCol="0" anchor="t"/>
+          <a:lstStyle/>
+          <a:p>
+            <a:pPr marL="380000" indent="-380000" algn="l">
               <a:lnSpc>
                 <a:spcPct val="104000"/>
               </a:lnSpc>
               <a:spcBef>
-                <a:spcPts val="400"/>
+                <a:spcPts val="450"/>
               </a:spcBef>
-              <a:buNone/>
-            </a:pPr>
-            <a:r>
-              <a:rPr lang="en-US" sz="1950" b="1" dirty="0">
+              <a:buClr>
+                <a:srgbClr val="6C3483"/>
+              </a:buClr>
+              <a:buFont typeface="Arial"/>
+              <a:buChar char="•"/>
+            </a:pPr>
+            <a:r>
+              <a:rPr lang="en-US" sz="1650" dirty="0">
                 <a:solidFill>
                   <a:srgbClr val="000000"/>
                 </a:solidFill>
                 <a:latin typeface="Arial"/>
                 <a:cs typeface="Arial"/>
               </a:rPr>
-              <a:t>"Do night shifts cause medication errors?"</a:t>
-            </a:r>
-          </a:p>
-          <a:p>
-            <a:pPr marL="0" indent="0" algn="ctr">
+              <a:t>All hospitalised adults in the country: does vitamin D reduce mortality over 10 years?</a:t>
+            </a:r>
+          </a:p>
+          <a:p>
+            <a:pPr marL="380000" indent="-380000" algn="l">
               <a:lnSpc>
                 <a:spcPct val="104000"/>
               </a:lnSpc>
               <a:spcBef>
-                <a:spcPts val="400"/>
+                <a:spcPts val="450"/>
               </a:spcBef>
-              <a:buNone/>
-            </a:pPr>
-            <a:r>
-              <a:rPr lang="en-US" sz="1950" dirty="0">
+              <a:buClr>
+                <a:srgbClr val="6C3483"/>
+              </a:buClr>
+              <a:buFont typeface="Arial"/>
+              <a:buChar char="•"/>
+            </a:pPr>
+            <a:r>
+              <a:rPr lang="en-US" sz="1650" dirty="0">
                 <a:solidFill>
                   <a:srgbClr val="000000"/>
                 </a:solidFill>
                 <a:latin typeface="Arial"/>
                 <a:cs typeface="Arial"/>
               </a:rPr>
-              <a:t>Which staff?</a:t>
-            </a:r>
-          </a:p>
-          <a:p>
-            <a:pPr marL="0" indent="0" algn="ctr">
+              <a:t>Septic shock: does withholding antibiotics for 24 h reduce resistance?</a:t>
+            </a:r>
+          </a:p>
+          <a:p>
+            <a:pPr marL="380000" indent="-380000" algn="l">
               <a:lnSpc>
                 <a:spcPct val="104000"/>
               </a:lnSpc>
               <a:spcBef>
-                <a:spcPts val="400"/>
+                <a:spcPts val="450"/>
               </a:spcBef>
-              <a:buNone/>
-            </a:pPr>
-            <a:r>
-              <a:rPr lang="en-US" sz="1950" dirty="0">
+              <a:buClr>
+                <a:srgbClr val="6C3483"/>
+              </a:buClr>
+              <a:buFont typeface="Arial"/>
+              <a:buChar char="•"/>
+            </a:pPr>
+            <a:r>
+              <a:rPr lang="en-US" sz="1650" dirty="0">
                 <a:solidFill>
                   <a:srgbClr val="000000"/>
                 </a:solidFill>
                 <a:latin typeface="Arial"/>
                 <a:cs typeface="Arial"/>
               </a:rPr>
-              <a:t>Compared with what?</a:t>
-            </a:r>
-          </a:p>
-          <a:p>
-            <a:pPr marL="0" indent="0" algn="ctr">
+              <a:t>Do our ICU nurses wash their hands? (audited monthly for 5 years)</a:t>
+            </a:r>
+          </a:p>
+          <a:p>
+            <a:pPr marL="380000" indent="-380000" algn="l">
               <a:lnSpc>
                 <a:spcPct val="104000"/>
               </a:lnSpc>
               <a:spcBef>
-                <a:spcPts val="400"/>
+                <a:spcPts val="450"/>
               </a:spcBef>
-              <a:buNone/>
-            </a:pPr>
-            <a:r>
-              <a:rPr lang="en-US" sz="1950" dirty="0">
+              <a:buClr>
+                <a:srgbClr val="6C3483"/>
+              </a:buClr>
+              <a:buFont typeface="Arial"/>
+              <a:buChar char="•"/>
+            </a:pPr>
+            <a:r>
+              <a:rPr lang="en-US" sz="1650" dirty="0">
                 <a:solidFill>
                   <a:srgbClr val="000000"/>
                 </a:solidFill>
                 <a:latin typeface="Arial"/>
                 <a:cs typeface="Arial"/>
               </a:rPr>
-              <a:t>Which errors, counted how?</a:t>
-            </a:r>
-          </a:p>
-          <a:p>
-            <a:pPr marL="0" indent="0" algn="ctr">
-              <a:lnSpc>
-                <a:spcPct val="104000"/>
-              </a:lnSpc>
-              <a:spcBef>
-                <a:spcPts val="400"/>
-              </a:spcBef>
-              <a:buNone/>
-            </a:pPr>
-            <a:r>
-              <a:rPr lang="en-US" sz="1950" dirty="0">
-                <a:solidFill>
-                  <a:srgbClr val="000000"/>
-                </a:solidFill>
-                <a:latin typeface="Arial"/>
-                <a:cs typeface="Arial"/>
-              </a:rPr>
-              <a:t>Over what period?</a:t>
-            </a:r>
-          </a:p>
-        </p:txBody>
-      </p:sp>
-      <p:sp>
-        <p:nvSpPr>
-          <p:cNvPr id="72" name="CardHead"/>
-          <p:cNvSpPr/>
-          <p:nvPr/>
-        </p:nvSpPr>
-        <p:spPr>
-          <a:xfrm>
-            <a:off x="6196000" y="1535249"/>
-            <a:ext cx="5538800" cy="640000"/>
-          </a:xfrm>
-          <a:prstGeom prst="rect">
-            <a:avLst/>
-          </a:prstGeom>
-          <a:solidFill>
-            <a:srgbClr val="2E8B57"/>
-          </a:solidFill>
-          <a:ln>
-            <a:noFill/>
-          </a:ln>
-        </p:spPr>
-        <p:txBody>
-          <a:bodyPr wrap="square" lIns="91440" tIns="45720" rIns="91440" bIns="45720" rtlCol="0" anchor="ctr">
-            <a:normAutofit/>
-          </a:bodyPr>
-          <a:lstStyle/>
-          <a:p>
-            <a:pPr marL="0" indent="0" algn="ctr">
-              <a:buNone/>
-            </a:pPr>
-            <a:r>
-              <a:rPr lang="en-US" sz="1900" b="1" dirty="0">
-                <a:solidFill>
-                  <a:srgbClr val="FFFFFF"/>
-                </a:solidFill>
-                <a:latin typeface="Arial"/>
-                <a:cs typeface="Arial"/>
-              </a:rPr>
-              <a:t>Answerable, with PECO</a:t>
-            </a:r>
-          </a:p>
-        </p:txBody>
-      </p:sp>
-      <p:sp>
-        <p:nvSpPr>
-          <p:cNvPr id="73" name="CardBody"/>
-          <p:cNvSpPr/>
-          <p:nvPr/>
-        </p:nvSpPr>
-        <p:spPr>
-          <a:xfrm>
-            <a:off x="6196000" y="2175249"/>
-            <a:ext cx="5538800" cy="2444253"/>
-          </a:xfrm>
-          <a:prstGeom prst="rect">
-            <a:avLst/>
-          </a:prstGeom>
-          <a:solidFill>
-            <a:srgbClr val="EAF2F5"/>
-          </a:solidFill>
-          <a:ln>
-            <a:noFill/>
-          </a:ln>
-        </p:spPr>
-        <p:txBody>
-          <a:bodyPr wrap="square" lIns="137160" tIns="91440" rIns="137160" bIns="91440" rtlCol="0" anchor="ctr">
-            <a:normAutofit/>
-          </a:bodyPr>
-          <a:lstStyle/>
-          <a:p>
-            <a:pPr marL="0" indent="0" algn="ctr">
-              <a:lnSpc>
-                <a:spcPct val="104000"/>
-              </a:lnSpc>
-              <a:spcBef>
-                <a:spcPts val="400"/>
-              </a:spcBef>
-              <a:buNone/>
-            </a:pPr>
-            <a:r>
-              <a:rPr lang="en-US" sz="1950" dirty="0">
-                <a:solidFill>
-                  <a:srgbClr val="000000"/>
-                </a:solidFill>
-                <a:latin typeface="Arial"/>
-                <a:cs typeface="Arial"/>
-              </a:rPr>
-              <a:t>P: In ward nurses,</a:t>
-            </a:r>
-          </a:p>
-          <a:p>
-            <a:pPr marL="0" indent="0" algn="ctr">
-              <a:lnSpc>
-                <a:spcPct val="104000"/>
-              </a:lnSpc>
-              <a:spcBef>
-                <a:spcPts val="400"/>
-              </a:spcBef>
-              <a:buNone/>
-            </a:pPr>
-            <a:r>
-              <a:rPr lang="en-US" sz="1950" dirty="0">
-                <a:solidFill>
-                  <a:srgbClr val="000000"/>
-                </a:solidFill>
-                <a:latin typeface="Arial"/>
-                <a:cs typeface="Arial"/>
-              </a:rPr>
-              <a:t>E: are night shifts,</a:t>
-            </a:r>
-          </a:p>
-          <a:p>
-            <a:pPr marL="0" indent="0" algn="ctr">
-              <a:lnSpc>
-                <a:spcPct val="104000"/>
-              </a:lnSpc>
-              <a:spcBef>
-                <a:spcPts val="400"/>
-              </a:spcBef>
-              <a:buNone/>
-            </a:pPr>
-            <a:r>
-              <a:rPr lang="en-US" sz="1950" dirty="0">
-                <a:solidFill>
-                  <a:srgbClr val="000000"/>
-                </a:solidFill>
-                <a:latin typeface="Arial"/>
-                <a:cs typeface="Arial"/>
-              </a:rPr>
-              <a:t>C: compared with day shifts,</a:t>
-            </a:r>
-          </a:p>
-          <a:p>
-            <a:pPr marL="0" indent="0" algn="ctr">
-              <a:lnSpc>
-                <a:spcPct val="104000"/>
-              </a:lnSpc>
-              <a:spcBef>
-                <a:spcPts val="400"/>
-              </a:spcBef>
-              <a:buNone/>
-            </a:pPr>
-            <a:r>
-              <a:rPr lang="en-US" sz="1950" dirty="0">
-                <a:solidFill>
-                  <a:srgbClr val="000000"/>
-                </a:solidFill>
-                <a:latin typeface="Arial"/>
-                <a:cs typeface="Arial"/>
-              </a:rPr>
-              <a:t>O: linked to more errors per 1,000 doses</a:t>
-            </a:r>
-          </a:p>
-          <a:p>
-            <a:pPr marL="0" indent="0" algn="ctr">
-              <a:lnSpc>
-                <a:spcPct val="104000"/>
-              </a:lnSpc>
-              <a:spcBef>
-                <a:spcPts val="400"/>
-              </a:spcBef>
-              <a:buNone/>
-            </a:pPr>
-            <a:r>
-              <a:rPr lang="en-US" sz="1950" dirty="0">
-                <a:solidFill>
-                  <a:srgbClr val="000000"/>
-                </a:solidFill>
-                <a:latin typeface="Arial"/>
-                <a:cs typeface="Arial"/>
-              </a:rPr>
-              <a:t>T: over 6 months?</a:t>
-            </a:r>
-          </a:p>
-        </p:txBody>
-      </p:sp>
-      <p:sp>
-        <p:nvSpPr>
-          <p:cNvPr id="60" name="Takeaway"/>
-          <p:cNvSpPr/>
-          <p:nvPr/>
-        </p:nvSpPr>
-        <p:spPr>
-          <a:xfrm>
-            <a:off x="457200" y="5390000"/>
-            <a:ext cx="11277600" cy="560000"/>
+              <a:t>Pneumonia: does the colour of the drug chart affect 28-day mortality?</a:t>
+            </a:r>
+          </a:p>
+        </p:txBody>
+      </p:sp>
+      <p:sp>
+        <p:nvSpPr>
+          <p:cNvPr id="53" name="Deliverable"/>
+          <p:cNvSpPr/>
+          <p:nvPr/>
+        </p:nvSpPr>
+        <p:spPr>
+          <a:xfrm>
+            <a:off x="457200" y="5350000"/>
+            <a:ext cx="11277600" cy="600000"/>
           </a:xfrm>
           <a:prstGeom prst="roundRect">
             <a:avLst>
@@ -44385,10 +44458,12 @@
             </a:avLst>
           </a:prstGeom>
           <a:solidFill>
-            <a:srgbClr val="0D7377"/>
+            <a:srgbClr val="FFFFFF"/>
           </a:solidFill>
-          <a:ln>
-            <a:noFill/>
+          <a:ln w="15875">
+            <a:solidFill>
+              <a:srgbClr val="6C3483"/>
+            </a:solidFill>
           </a:ln>
         </p:spPr>
         <p:txBody>
@@ -44403,22 +44478,22 @@
             <a:r>
               <a:rPr lang="en-US" sz="1300" b="1" dirty="0">
                 <a:solidFill>
-                  <a:srgbClr val="FFFFFF"/>
-                </a:solidFill>
-                <a:latin typeface="Arial"/>
-                <a:cs typeface="Arial"/>
-              </a:rPr>
-              <a:t>KEY MESSAGE   </a:t>
-            </a:r>
-            <a:r>
-              <a:rPr lang="en-US" sz="1550" dirty="0">
-                <a:solidFill>
-                  <a:srgbClr val="FFFFFF"/>
-                </a:solidFill>
-                <a:latin typeface="Arial"/>
-                <a:cs typeface="Arial"/>
-              </a:rPr>
-              <a:t>Practise on your own ward: take a corridor question and fill the boxes.</a:t>
+                  <a:srgbClr val="6C3483"/>
+                </a:solidFill>
+                <a:latin typeface="Arial"/>
+                <a:cs typeface="Arial"/>
+              </a:rPr>
+              <a:t>OUTPUT   </a:t>
+            </a:r>
+            <a:r>
+              <a:rPr lang="en-US" sz="1500" dirty="0">
+                <a:solidFill>
+                  <a:srgbClr val="000000"/>
+                </a:solidFill>
+                <a:latin typeface="Arial"/>
+                <a:cs typeface="Arial"/>
+              </a:rPr>
+              <a:t>One letter per question, in the poll</a:t>
             </a:r>
           </a:p>
         </p:txBody>
@@ -44528,6 +44603,609 @@
 </file>
 
 <file path=ppt/slides/slide53.xml><?xml version="1.0" encoding="utf-8"?>
+<p:sld xmlns:a="http://schemas.openxmlformats.org/drawingml/2006/main" xmlns:r="http://schemas.openxmlformats.org/officeDocument/2006/relationships" xmlns:p="http://schemas.openxmlformats.org/presentationml/2006/main">
+  <p:cSld>
+    <p:bg>
+      <p:bgPr>
+        <a:solidFill>
+          <a:schemeClr val="bg1"/>
+        </a:solidFill>
+        <a:effectLst/>
+      </p:bgPr>
+    </p:bg>
+    <p:spTree>
+      <p:nvGrpSpPr>
+        <p:cNvPr id="1" name=""/>
+        <p:cNvGrpSpPr/>
+        <p:nvPr/>
+      </p:nvGrpSpPr>
+      <p:grpSpPr>
+        <a:xfrm>
+          <a:off x="0" y="0"/>
+          <a:ext cx="0" cy="0"/>
+          <a:chOff x="0" y="0"/>
+          <a:chExt cx="0" cy="0"/>
+        </a:xfrm>
+      </p:grpSpPr>
+      <p:sp>
+        <p:nvSpPr>
+          <p:cNvPr id="10" name="Title"/>
+          <p:cNvSpPr txBox="1"/>
+          <p:nvPr/>
+        </p:nvSpPr>
+        <p:spPr>
+          <a:xfrm>
+            <a:off x="457200" y="160000"/>
+            <a:ext cx="11277600" cy="750000"/>
+          </a:xfrm>
+          <a:prstGeom prst="rect">
+            <a:avLst/>
+          </a:prstGeom>
+          <a:noFill/>
+          <a:ln>
+            <a:noFill/>
+          </a:ln>
+        </p:spPr>
+        <p:txBody>
+          <a:bodyPr wrap="square" lIns="91440" tIns="45720" rIns="91440" bIns="45720" rtlCol="0" anchor="ctr"/>
+          <a:lstStyle/>
+          <a:p>
+            <a:pPr marL="0" indent="0" algn="l">
+              <a:buNone/>
+            </a:pPr>
+            <a:r>
+              <a:rPr lang="en-US" sz="2800" b="1" dirty="0">
+                <a:solidFill>
+                  <a:srgbClr val="0D7377"/>
+                </a:solidFill>
+                <a:latin typeface="Arial"/>
+                <a:cs typeface="Arial"/>
+              </a:rPr>
+              <a:t>Vague vs answerable: another example from the ward</a:t>
+            </a:r>
+          </a:p>
+        </p:txBody>
+      </p:sp>
+      <p:sp>
+        <p:nvSpPr>
+          <p:cNvPr id="11" name="Rule"/>
+          <p:cNvSpPr/>
+          <p:nvPr/>
+        </p:nvSpPr>
+        <p:spPr>
+          <a:xfrm>
+            <a:off x="457200" y="940000"/>
+            <a:ext cx="11277600" cy="0"/>
+          </a:xfrm>
+          <a:prstGeom prst="line">
+            <a:avLst/>
+          </a:prstGeom>
+          <a:ln w="19050">
+            <a:solidFill>
+              <a:srgbClr val="0D7377"/>
+            </a:solidFill>
+          </a:ln>
+        </p:spPr>
+        <p:txBody>
+          <a:bodyPr/>
+          <a:lstStyle/>
+          <a:p>
+            <a:endParaRPr/>
+          </a:p>
+        </p:txBody>
+      </p:sp>
+      <p:sp>
+        <p:nvSpPr>
+          <p:cNvPr id="70" name="CardHead"/>
+          <p:cNvSpPr/>
+          <p:nvPr/>
+        </p:nvSpPr>
+        <p:spPr>
+          <a:xfrm>
+            <a:off x="457200" y="1535249"/>
+            <a:ext cx="5538800" cy="640000"/>
+          </a:xfrm>
+          <a:prstGeom prst="rect">
+            <a:avLst/>
+          </a:prstGeom>
+          <a:solidFill>
+            <a:srgbClr val="B23B2E"/>
+          </a:solidFill>
+          <a:ln>
+            <a:noFill/>
+          </a:ln>
+        </p:spPr>
+        <p:txBody>
+          <a:bodyPr wrap="square" lIns="91440" tIns="45720" rIns="91440" bIns="45720" rtlCol="0" anchor="ctr">
+            <a:normAutofit/>
+          </a:bodyPr>
+          <a:lstStyle/>
+          <a:p>
+            <a:pPr marL="0" indent="0" algn="ctr">
+              <a:buNone/>
+            </a:pPr>
+            <a:r>
+              <a:rPr lang="en-US" sz="1900" b="1" dirty="0">
+                <a:solidFill>
+                  <a:srgbClr val="FFFFFF"/>
+                </a:solidFill>
+                <a:latin typeface="Arial"/>
+                <a:cs typeface="Arial"/>
+              </a:rPr>
+              <a:t>Vague</a:t>
+            </a:r>
+          </a:p>
+        </p:txBody>
+      </p:sp>
+      <p:sp>
+        <p:nvSpPr>
+          <p:cNvPr id="71" name="CardBody"/>
+          <p:cNvSpPr/>
+          <p:nvPr/>
+        </p:nvSpPr>
+        <p:spPr>
+          <a:xfrm>
+            <a:off x="457200" y="2175249"/>
+            <a:ext cx="5538800" cy="2444253"/>
+          </a:xfrm>
+          <a:prstGeom prst="rect">
+            <a:avLst/>
+          </a:prstGeom>
+          <a:solidFill>
+            <a:srgbClr val="EAF2F5"/>
+          </a:solidFill>
+          <a:ln>
+            <a:noFill/>
+          </a:ln>
+        </p:spPr>
+        <p:txBody>
+          <a:bodyPr wrap="square" lIns="137160" tIns="91440" rIns="137160" bIns="91440" rtlCol="0" anchor="ctr">
+            <a:normAutofit/>
+          </a:bodyPr>
+          <a:lstStyle/>
+          <a:p>
+            <a:pPr marL="0" indent="0" algn="ctr">
+              <a:lnSpc>
+                <a:spcPct val="104000"/>
+              </a:lnSpc>
+              <a:spcBef>
+                <a:spcPts val="400"/>
+              </a:spcBef>
+              <a:buNone/>
+            </a:pPr>
+            <a:r>
+              <a:rPr lang="en-US" sz="1950" b="1" dirty="0">
+                <a:solidFill>
+                  <a:srgbClr val="000000"/>
+                </a:solidFill>
+                <a:latin typeface="Arial"/>
+                <a:cs typeface="Arial"/>
+              </a:rPr>
+              <a:t>"Do night shifts cause medication errors?"</a:t>
+            </a:r>
+          </a:p>
+          <a:p>
+            <a:pPr marL="0" indent="0" algn="ctr">
+              <a:lnSpc>
+                <a:spcPct val="104000"/>
+              </a:lnSpc>
+              <a:spcBef>
+                <a:spcPts val="400"/>
+              </a:spcBef>
+              <a:buNone/>
+            </a:pPr>
+            <a:r>
+              <a:rPr lang="en-US" sz="1950" dirty="0">
+                <a:solidFill>
+                  <a:srgbClr val="000000"/>
+                </a:solidFill>
+                <a:latin typeface="Arial"/>
+                <a:cs typeface="Arial"/>
+              </a:rPr>
+              <a:t>Which staff?</a:t>
+            </a:r>
+          </a:p>
+          <a:p>
+            <a:pPr marL="0" indent="0" algn="ctr">
+              <a:lnSpc>
+                <a:spcPct val="104000"/>
+              </a:lnSpc>
+              <a:spcBef>
+                <a:spcPts val="400"/>
+              </a:spcBef>
+              <a:buNone/>
+            </a:pPr>
+            <a:r>
+              <a:rPr lang="en-US" sz="1950" dirty="0">
+                <a:solidFill>
+                  <a:srgbClr val="000000"/>
+                </a:solidFill>
+                <a:latin typeface="Arial"/>
+                <a:cs typeface="Arial"/>
+              </a:rPr>
+              <a:t>Compared with what?</a:t>
+            </a:r>
+          </a:p>
+          <a:p>
+            <a:pPr marL="0" indent="0" algn="ctr">
+              <a:lnSpc>
+                <a:spcPct val="104000"/>
+              </a:lnSpc>
+              <a:spcBef>
+                <a:spcPts val="400"/>
+              </a:spcBef>
+              <a:buNone/>
+            </a:pPr>
+            <a:r>
+              <a:rPr lang="en-US" sz="1950" dirty="0">
+                <a:solidFill>
+                  <a:srgbClr val="000000"/>
+                </a:solidFill>
+                <a:latin typeface="Arial"/>
+                <a:cs typeface="Arial"/>
+              </a:rPr>
+              <a:t>Which errors, counted how?</a:t>
+            </a:r>
+          </a:p>
+          <a:p>
+            <a:pPr marL="0" indent="0" algn="ctr">
+              <a:lnSpc>
+                <a:spcPct val="104000"/>
+              </a:lnSpc>
+              <a:spcBef>
+                <a:spcPts val="400"/>
+              </a:spcBef>
+              <a:buNone/>
+            </a:pPr>
+            <a:r>
+              <a:rPr lang="en-US" sz="1950" dirty="0">
+                <a:solidFill>
+                  <a:srgbClr val="000000"/>
+                </a:solidFill>
+                <a:latin typeface="Arial"/>
+                <a:cs typeface="Arial"/>
+              </a:rPr>
+              <a:t>Over what period?</a:t>
+            </a:r>
+          </a:p>
+        </p:txBody>
+      </p:sp>
+      <p:sp>
+        <p:nvSpPr>
+          <p:cNvPr id="72" name="CardHead"/>
+          <p:cNvSpPr/>
+          <p:nvPr/>
+        </p:nvSpPr>
+        <p:spPr>
+          <a:xfrm>
+            <a:off x="6196000" y="1535249"/>
+            <a:ext cx="5538800" cy="640000"/>
+          </a:xfrm>
+          <a:prstGeom prst="rect">
+            <a:avLst/>
+          </a:prstGeom>
+          <a:solidFill>
+            <a:srgbClr val="2E8B57"/>
+          </a:solidFill>
+          <a:ln>
+            <a:noFill/>
+          </a:ln>
+        </p:spPr>
+        <p:txBody>
+          <a:bodyPr wrap="square" lIns="91440" tIns="45720" rIns="91440" bIns="45720" rtlCol="0" anchor="ctr">
+            <a:normAutofit/>
+          </a:bodyPr>
+          <a:lstStyle/>
+          <a:p>
+            <a:pPr marL="0" indent="0" algn="ctr">
+              <a:buNone/>
+            </a:pPr>
+            <a:r>
+              <a:rPr lang="en-US" sz="1900" b="1" dirty="0">
+                <a:solidFill>
+                  <a:srgbClr val="FFFFFF"/>
+                </a:solidFill>
+                <a:latin typeface="Arial"/>
+                <a:cs typeface="Arial"/>
+              </a:rPr>
+              <a:t>Answerable, with PECO</a:t>
+            </a:r>
+          </a:p>
+        </p:txBody>
+      </p:sp>
+      <p:sp>
+        <p:nvSpPr>
+          <p:cNvPr id="73" name="CardBody"/>
+          <p:cNvSpPr/>
+          <p:nvPr/>
+        </p:nvSpPr>
+        <p:spPr>
+          <a:xfrm>
+            <a:off x="6196000" y="2175249"/>
+            <a:ext cx="5538800" cy="2444253"/>
+          </a:xfrm>
+          <a:prstGeom prst="rect">
+            <a:avLst/>
+          </a:prstGeom>
+          <a:solidFill>
+            <a:srgbClr val="EAF2F5"/>
+          </a:solidFill>
+          <a:ln>
+            <a:noFill/>
+          </a:ln>
+        </p:spPr>
+        <p:txBody>
+          <a:bodyPr wrap="square" lIns="137160" tIns="91440" rIns="137160" bIns="91440" rtlCol="0" anchor="ctr">
+            <a:normAutofit/>
+          </a:bodyPr>
+          <a:lstStyle/>
+          <a:p>
+            <a:pPr marL="0" indent="0" algn="ctr">
+              <a:lnSpc>
+                <a:spcPct val="104000"/>
+              </a:lnSpc>
+              <a:spcBef>
+                <a:spcPts val="400"/>
+              </a:spcBef>
+              <a:buNone/>
+            </a:pPr>
+            <a:r>
+              <a:rPr lang="en-US" sz="1950" dirty="0">
+                <a:solidFill>
+                  <a:srgbClr val="000000"/>
+                </a:solidFill>
+                <a:latin typeface="Arial"/>
+                <a:cs typeface="Arial"/>
+              </a:rPr>
+              <a:t>P: In ward nurses,</a:t>
+            </a:r>
+          </a:p>
+          <a:p>
+            <a:pPr marL="0" indent="0" algn="ctr">
+              <a:lnSpc>
+                <a:spcPct val="104000"/>
+              </a:lnSpc>
+              <a:spcBef>
+                <a:spcPts val="400"/>
+              </a:spcBef>
+              <a:buNone/>
+            </a:pPr>
+            <a:r>
+              <a:rPr lang="en-US" sz="1950" dirty="0">
+                <a:solidFill>
+                  <a:srgbClr val="000000"/>
+                </a:solidFill>
+                <a:latin typeface="Arial"/>
+                <a:cs typeface="Arial"/>
+              </a:rPr>
+              <a:t>E: are night shifts,</a:t>
+            </a:r>
+          </a:p>
+          <a:p>
+            <a:pPr marL="0" indent="0" algn="ctr">
+              <a:lnSpc>
+                <a:spcPct val="104000"/>
+              </a:lnSpc>
+              <a:spcBef>
+                <a:spcPts val="400"/>
+              </a:spcBef>
+              <a:buNone/>
+            </a:pPr>
+            <a:r>
+              <a:rPr lang="en-US" sz="1950" dirty="0">
+                <a:solidFill>
+                  <a:srgbClr val="000000"/>
+                </a:solidFill>
+                <a:latin typeface="Arial"/>
+                <a:cs typeface="Arial"/>
+              </a:rPr>
+              <a:t>C: compared with day shifts,</a:t>
+            </a:r>
+          </a:p>
+          <a:p>
+            <a:pPr marL="0" indent="0" algn="ctr">
+              <a:lnSpc>
+                <a:spcPct val="104000"/>
+              </a:lnSpc>
+              <a:spcBef>
+                <a:spcPts val="400"/>
+              </a:spcBef>
+              <a:buNone/>
+            </a:pPr>
+            <a:r>
+              <a:rPr lang="en-US" sz="1950" dirty="0">
+                <a:solidFill>
+                  <a:srgbClr val="000000"/>
+                </a:solidFill>
+                <a:latin typeface="Arial"/>
+                <a:cs typeface="Arial"/>
+              </a:rPr>
+              <a:t>O: linked to more errors per 1,000 doses</a:t>
+            </a:r>
+          </a:p>
+          <a:p>
+            <a:pPr marL="0" indent="0" algn="ctr">
+              <a:lnSpc>
+                <a:spcPct val="104000"/>
+              </a:lnSpc>
+              <a:spcBef>
+                <a:spcPts val="400"/>
+              </a:spcBef>
+              <a:buNone/>
+            </a:pPr>
+            <a:r>
+              <a:rPr lang="en-US" sz="1950" dirty="0">
+                <a:solidFill>
+                  <a:srgbClr val="000000"/>
+                </a:solidFill>
+                <a:latin typeface="Arial"/>
+                <a:cs typeface="Arial"/>
+              </a:rPr>
+              <a:t>T: over 6 months?</a:t>
+            </a:r>
+          </a:p>
+        </p:txBody>
+      </p:sp>
+      <p:sp>
+        <p:nvSpPr>
+          <p:cNvPr id="60" name="Takeaway"/>
+          <p:cNvSpPr/>
+          <p:nvPr/>
+        </p:nvSpPr>
+        <p:spPr>
+          <a:xfrm>
+            <a:off x="457200" y="5390000"/>
+            <a:ext cx="11277600" cy="560000"/>
+          </a:xfrm>
+          <a:prstGeom prst="roundRect">
+            <a:avLst>
+              <a:gd name="adj" fmla="val 12000"/>
+            </a:avLst>
+          </a:prstGeom>
+          <a:solidFill>
+            <a:srgbClr val="0D7377"/>
+          </a:solidFill>
+          <a:ln>
+            <a:noFill/>
+          </a:ln>
+        </p:spPr>
+        <p:txBody>
+          <a:bodyPr wrap="square" lIns="182880" tIns="45720" rIns="182880" bIns="45720" rtlCol="0" anchor="ctr">
+            <a:normAutofit/>
+          </a:bodyPr>
+          <a:lstStyle/>
+          <a:p>
+            <a:pPr marL="0" indent="0" algn="ctr">
+              <a:buNone/>
+            </a:pPr>
+            <a:r>
+              <a:rPr lang="en-US" sz="1300" b="1" dirty="0">
+                <a:solidFill>
+                  <a:srgbClr val="FFFFFF"/>
+                </a:solidFill>
+                <a:latin typeface="Arial"/>
+                <a:cs typeface="Arial"/>
+              </a:rPr>
+              <a:t>KEY MESSAGE   </a:t>
+            </a:r>
+            <a:r>
+              <a:rPr lang="en-US" sz="1550" dirty="0">
+                <a:solidFill>
+                  <a:srgbClr val="FFFFFF"/>
+                </a:solidFill>
+                <a:latin typeface="Arial"/>
+                <a:cs typeface="Arial"/>
+              </a:rPr>
+              <a:t>Practise on your own ward: take a corridor question and fill the boxes.</a:t>
+            </a:r>
+          </a:p>
+        </p:txBody>
+      </p:sp>
+      <p:sp>
+        <p:nvSpPr>
+          <p:cNvPr id="901" name="Footer"/>
+          <p:cNvSpPr txBox="1"/>
+          <p:nvPr/>
+        </p:nvSpPr>
+        <p:spPr>
+          <a:xfrm>
+            <a:off x="4599946" y="6458701"/>
+            <a:ext cx="2845651" cy="276999"/>
+          </a:xfrm>
+          <a:prstGeom prst="rect">
+            <a:avLst/>
+          </a:prstGeom>
+          <a:noFill/>
+          <a:ln>
+            <a:noFill/>
+          </a:ln>
+        </p:spPr>
+        <p:txBody>
+          <a:bodyPr wrap="none" lIns="91440" tIns="45720" rIns="91440" bIns="45720" rtlCol="0" anchor="t"/>
+          <a:lstStyle/>
+          <a:p>
+            <a:r>
+              <a:rPr lang="en-US" sz="1200" dirty="0">
+                <a:solidFill>
+                  <a:schemeClr val="accent5">
+                    <a:lumMod val="50000"/>
+                  </a:schemeClr>
+                </a:solidFill>
+                <a:latin typeface="Arial"/>
+              </a:rPr>
+              <a:t>Neudata | #ClearDataClearImpact</a:t>
+            </a:r>
+          </a:p>
+        </p:txBody>
+      </p:sp>
+      <p:pic>
+        <p:nvPicPr>
+          <p:cNvPr id="902" name="Logo"/>
+          <p:cNvPicPr>
+            <a:picLocks noChangeAspect="1"/>
+          </p:cNvPicPr>
+          <p:nvPr/>
+        </p:nvPicPr>
+        <p:blipFill>
+          <a:blip r:embed="rId3"/>
+          <a:stretch>
+            <a:fillRect/>
+          </a:stretch>
+        </p:blipFill>
+        <p:spPr>
+          <a:xfrm>
+            <a:off x="138853" y="6122125"/>
+            <a:ext cx="716763" cy="683623"/>
+          </a:xfrm>
+          <a:prstGeom prst="rect">
+            <a:avLst/>
+          </a:prstGeom>
+        </p:spPr>
+      </p:pic>
+      <p:sp>
+        <p:nvSpPr>
+          <p:cNvPr id="903" name="Slide Number"/>
+          <p:cNvSpPr>
+            <a:spLocks noGrp="1"/>
+          </p:cNvSpPr>
+          <p:nvPr>
+            <p:ph type="sldNum" sz="quarter" idx="12"/>
+          </p:nvPr>
+        </p:nvSpPr>
+        <p:spPr>
+          <a:xfrm>
+            <a:off x="11330000" y="6470000"/>
+            <a:ext cx="620000" cy="320000"/>
+          </a:xfrm>
+        </p:spPr>
+        <p:txBody>
+          <a:bodyPr/>
+          <a:lstStyle/>
+          <a:p>
+            <a:pPr algn="r"/>
+            <a:fld id="{C1FF6DA9-008F-8B48-92A6-B652298478BF}" type="slidenum">
+              <a:rPr lang="en-US" sz="1050" smtClean="0">
+                <a:solidFill>
+                  <a:schemeClr val="accent5">
+                    <a:lumMod val="50000"/>
+                  </a:schemeClr>
+                </a:solidFill>
+              </a:rPr>
+              <a:t>2</a:t>
+            </a:fld>
+            <a:endParaRPr lang="en-US"/>
+          </a:p>
+        </p:txBody>
+      </p:sp>
+    </p:spTree>
+  </p:cSld>
+  <p:clrMapOvr>
+    <a:masterClrMapping/>
+  </p:clrMapOvr>
+</p:sld>
+</file>
+
+<file path=ppt/slides/slide54.xml><?xml version="1.0" encoding="utf-8"?>
 <p:sld xmlns:a="http://schemas.openxmlformats.org/drawingml/2006/main" xmlns:r="http://schemas.openxmlformats.org/officeDocument/2006/relationships" xmlns:p="http://schemas.openxmlformats.org/presentationml/2006/main">
   <p:cSld>
     <p:bg>

</xml_diff>

<commit_message>
Rebuild site: round 5 (proposal brief pre-course, manuscript brief at Session 6, Results-section product)
</commit_message>
<xml_diff>
--- a/en/files/slides/Session_1_EN.pptx
+++ b/en/files/slides/Session_1_EN.pptx
@@ -742,19 +742,13 @@
           <a:p>
             <a:r>
               <a:rPr lang="en-US" sz="1400" b="0" dirty="0"/>
-              <a:t>Title slide (0:00, 19:30). Welcome everyone and introduce the trainers in one sentence each.</a:t>
+              <a:t>Welcome. Each trainer introduces themselves in one sentence.</a:t>
             </a:r>
           </a:p>
           <a:p>
             <a:r>
               <a:rPr lang="en-US" sz="1400" b="0" dirty="0"/>
-              <a:t>Over eight Saturdays we walk the whole road from a bedside question to a paper ready to submit. No software and no formulas: pictures, examples and short tasks done together.</a:t>
-            </a:r>
-          </a:p>
-          <a:p>
-            <a:r>
-              <a:rPr lang="en-US" sz="1400" b="0" dirty="0"/>
-              <a:t>Ask everyone to rename themselves with their full name and to find the chat, the poll and 'raise hand'.</a:t>
+              <a:t>Ask everyone to show their full name and to find the chat, the poll and 'raise hand'.</a:t>
             </a:r>
           </a:p>
           <a:p>
@@ -841,13 +835,7 @@
           <a:p>
             <a:r>
               <a:rPr lang="en-US" sz="1400" b="0" dirty="0"/>
-              <a:t>This is a safe place to say 'I do not understand'. A private chat message to the trainer is fine.</a:t>
-            </a:r>
-          </a:p>
-          <a:p>
-            <a:r>
-              <a:rPr lang="en-US" sz="1400" b="0" dirty="0"/>
-              <a:t>Chat in Vietnamese or English, whichever helps you think. No patient names or identifiable details.</a:t>
+              <a:t>Private chat messages to the trainer are fine. Chat in Vietnamese or English.</a:t>
             </a:r>
           </a:p>
           <a:p>
@@ -934,31 +922,19 @@
           <a:p>
             <a:r>
               <a:rPr lang="en-US" sz="1400" b="0" dirty="0"/>
-              <a:t>Paste the Google Form link in the chat. The form asks for the full name, so the Session 1 and Session 8 answers can be matched.</a:t>
+              <a:t>Paste the Google Form link in the chat. No scores or answers are shown. The answers are shared after Session 8.</a:t>
             </a:r>
           </a:p>
           <a:p>
             <a:r>
               <a:rPr lang="en-US" sz="1400" b="0" dirty="0"/>
-              <a:t>Participants see no score or answers after submitting. The trainers see the results at once in the form's Responses tab and the linked results sheet.</a:t>
+              <a:t>Close the form after 15 minutes. Teaching starts at 20:05.</a:t>
             </a:r>
           </a:p>
           <a:p>
             <a:r>
               <a:rPr lang="en-US" sz="1400" b="0" dirty="0"/>
-              <a:t>Close the form after 15 minutes. Do not give the answers today: they are shared after the second attempt in Session 8.</a:t>
-            </a:r>
-          </a:p>
-          <a:p>
-            <a:r>
-              <a:rPr lang="en-US" sz="1400" b="0" dirty="0"/>
-              <a:t>Timing: 15 minutes. Session 1 teaching starts at 0:35 (20:05).</a:t>
-            </a:r>
-          </a:p>
-          <a:p>
-            <a:r>
-              <a:rPr lang="en-US" sz="1400" b="0" dirty="0"/>
-              <a:t>The form is created once from Course/Assessment/google_form (steps in its README).</a:t>
+              <a:t>Timing: 15 minutes.</a:t>
             </a:r>
           </a:p>
         </p:txBody>
@@ -1039,25 +1015,13 @@
           <a:p>
             <a:r>
               <a:rPr lang="en-US" sz="1400" b="0" dirty="0"/>
-              <a:t>Session 1 opening (0:35, 20:05), right after the pre-course quiz.</a:t>
+              <a:t>Start at 20:05, right after the quiz. Goal: everyone leaves with a draft question, aim and objectives.</a:t>
             </a:r>
           </a:p>
           <a:p>
             <a:r>
               <a:rPr lang="en-US" sz="1400" b="0" dirty="0"/>
-              <a:t>Today's goal: everyone leaves with the start of their own research question, aim and objectives.</a:t>
-            </a:r>
-          </a:p>
-          <a:p>
-            <a:r>
-              <a:rPr lang="en-US" sz="1400" b="0" dirty="0"/>
-              <a:t>The class has little research background and it is evening after work: go slowly and stop at every check.</a:t>
-            </a:r>
-          </a:p>
-          <a:p>
-            <a:r>
-              <a:rPr lang="en-US" sz="1400" b="0" dirty="0"/>
-              <a:t>Timing: 1 minute. Point at the agenda, do not read it.</a:t>
+              <a:t>Point at the agenda, do not read it. Timing: 1 minute.</a:t>
             </a:r>
           </a:p>
         </p:txBody>
@@ -1138,19 +1102,13 @@
           <a:p>
             <a:r>
               <a:rPr lang="en-US" sz="1400" b="0" dirty="0"/>
-              <a:t>Segment 1.1 (0:35-1:10, 20:05-20:40).</a:t>
+              <a:t>1.1 runs 20:05-20:40. Ask two or three people. Expected: we remember striking cases, colleagues disagree, practice changes.</a:t>
             </a:r>
           </a:p>
           <a:p>
             <a:r>
               <a:rPr lang="en-US" sz="1400" b="0" dirty="0"/>
-              <a:t>Ask two or three people to answer, microphone on. Expected: experience favours memorable cases, colleagues disagree, practice changes.</a:t>
-            </a:r>
-          </a:p>
-          <a:p>
-            <a:r>
-              <a:rPr lang="en-US" sz="1400" b="0" dirty="0"/>
-              <a:t>Point: experience is good for raising questions, weak for answering them.</a:t>
+              <a:t>Point: experience raises questions but cannot answer them.</a:t>
             </a:r>
           </a:p>
           <a:p>
@@ -1237,25 +1195,19 @@
           <a:p>
             <a:r>
               <a:rPr lang="en-US" sz="1400" b="0" dirty="0"/>
-              <a:t>Left: one clinician, three patients, no comparison group. Right: 50 patients per group, every death counted.</a:t>
+              <a:t>The numbers are illustrative. CLASSIC (NEJM 2022, 1,554 patients) found the same 90-day mortality with restrictive and standard fluids (42.3% vs 42.1%).</a:t>
             </a:r>
           </a:p>
           <a:p>
             <a:r>
               <a:rPr lang="en-US" sz="1400" b="0" dirty="0"/>
-              <a:t>The numbers are illustrative, but the pattern is real: the large CLASSIC trial (NEJM 2022, 1,554 patients) found the same 90-day mortality with restrictive and standard fluids (42.3% vs 42.1%).</a:t>
+              <a:t>Ask: 'Why do we remember the three good outcomes?' Expected: recall bias.</a:t>
             </a:r>
           </a:p>
           <a:p>
             <a:r>
               <a:rPr lang="en-US" sz="1400" b="0" dirty="0"/>
-              <a:t>Ask: 'Why do we remember the three good outcomes?' Expected: recall bias. Dramatic cases stick, failures are forgotten.</a:t>
-            </a:r>
-          </a:p>
-          <a:p>
-            <a:r>
-              <a:rPr lang="en-US" sz="1400" b="0" dirty="0"/>
-              <a:t>Timing: 4 minutes. The whole course rests on this idea.</a:t>
+              <a:t>Timing: 4 minutes.</a:t>
             </a:r>
           </a:p>
         </p:txBody>
@@ -1336,19 +1288,19 @@
           <a:p>
             <a:r>
               <a:rPr lang="en-US" sz="1400" b="0" dirty="0"/>
-              <a:t>A simulation: the true risk of death is 40%. Top row: 20 wards with 5 patients each, from 0% to 80% deaths by chance alone. Groups of 500 cluster around 40%.</a:t>
+              <a:t>True risk of death is 40%. Wards of 5 range from 0% to 80% by chance. Groups of 500 cluster around 40%.</a:t>
             </a:r>
           </a:p>
           <a:p>
             <a:r>
               <a:rPr lang="en-US" sz="1400" b="0" dirty="0"/>
-              <a:t>Poll (yes / no / cannot tell): 'One ward lost 0 of 5 patients after a new protocol. Does it work?' Answer: cannot tell. 0 of 5 happens often by chance.</a:t>
+              <a:t>Poll: 'One ward lost 0 of 5 after a new protocol. Does it work?' Answer: cannot tell.</a:t>
             </a:r>
           </a:p>
           <a:p>
             <a:r>
               <a:rPr lang="en-US" sz="1400" b="0" dirty="0"/>
-              <a:t>Timing: 4 minutes. Sample size returns in Session 6.</a:t>
+              <a:t>Timing: 4 minutes.</a:t>
             </a:r>
           </a:p>
         </p:txBody>
@@ -1429,25 +1381,19 @@
           <a:p>
             <a:r>
               <a:rPr lang="en-US" sz="1400" b="0" dirty="0"/>
-              <a:t>Build from the bottom: expert opinion, case series, case-control, cohort, randomised trials, and systematic reviews that combine studies.</a:t>
+              <a:t>Build from the bottom. Higher designs protect better against bias for treatment questions, but a poor trial can still mislead.</a:t>
             </a:r>
           </a:p>
           <a:p>
             <a:r>
               <a:rPr lang="en-US" sz="1400" b="0" dirty="0"/>
-              <a:t>Higher designs protect better against bias for 'does treatment X work?' questions. A small or badly run trial can still mislead.</a:t>
+              <a:t>Do not teach designs here (Session 3).</a:t>
             </a:r>
           </a:p>
           <a:p>
             <a:r>
               <a:rPr lang="en-US" sz="1400" b="0" dirty="0"/>
-              <a:t>For how common, harm and prognosis questions, observational designs are often the right choice.</a:t>
-            </a:r>
-          </a:p>
-          <a:p>
-            <a:r>
-              <a:rPr lang="en-US" sz="1400" b="0" dirty="0"/>
-              <a:t>Timing: 4 minutes. Session 3 covers each design: do not teach designs here.</a:t>
+              <a:t>Timing: 4 minutes.</a:t>
             </a:r>
           </a:p>
         </p:txBody>
@@ -1528,13 +1474,7 @@
           <a:p>
             <a:r>
               <a:rPr lang="en-US" sz="1400" b="0" dirty="0"/>
-              <a:t>Give 1 minute, then share the results. Answer: A, B, C, D.</a:t>
-            </a:r>
-          </a:p>
-          <a:p>
-            <a:r>
-              <a:rPr lang="en-US" sz="1400" b="0" dirty="0"/>
-              <a:t>C is the real CLASSIC trial, which found no difference in 90-day mortality.</a:t>
+              <a:t>Answer: A, B, C, D. C is the real CLASSIC trial.</a:t>
             </a:r>
           </a:p>
           <a:p>
@@ -1627,37 +1567,25 @@
           <a:p>
             <a:r>
               <a:rPr lang="en-US" sz="1400" b="0" dirty="0"/>
-              <a:t>We refer to these two papers in every session.</a:t>
+              <a:t>Paper 1: a pilot trial (a small trial that tests whether a larger one is possible). Paper 2: a matched cohort, like option B in the quiz.</a:t>
             </a:r>
           </a:p>
           <a:p>
             <a:r>
               <a:rPr lang="en-US" sz="1400" b="0" dirty="0"/>
-              <a:t>Paper 1: a pilot trial in three French ICUs. A pilot is a small trial that tests whether a larger one is possible. It restricted 'non-resuscitative' fluids (maintenance fluids and fluids used to dilute drugs).</a:t>
+              <a:t>Do not read them now. Session 2 reads Paper 1's abstract.</a:t>
             </a:r>
           </a:p>
           <a:p>
             <a:r>
               <a:rPr lang="en-US" sz="1400" b="0" dirty="0"/>
-              <a:t>Paper 2: a matched cohort from the Korean Sepsis Alliance registry, like option B in the quiz.</a:t>
-            </a:r>
-          </a:p>
-          <a:p>
-            <a:r>
-              <a:rPr lang="en-US" sz="1400" b="0" dirty="0"/>
-              <a:t>Do not read them now. In Session 2 we read Paper 1's abstract together.</a:t>
+              <a:t>Email the two original PDFs with the Session 1 exercise sheet before Session 1.</a:t>
             </a:r>
           </a:p>
           <a:p>
             <a:r>
               <a:rPr lang="en-US" sz="1400" b="0" dirty="0"/>
               <a:t>Timing: 2 minutes.</a:t>
-            </a:r>
-          </a:p>
-          <a:p>
-            <a:r>
-              <a:rPr lang="en-US" sz="1400" b="0" dirty="0"/>
-              <a:t>Before Session 1, email the two original PDFs (Course/Papers, files named 'original') with the Session 1 exercise sheet.</a:t>
             </a:r>
           </a:p>
         </p:txBody>
@@ -1738,13 +1666,13 @@
           <a:p>
             <a:r>
               <a:rPr lang="en-US" sz="1400" b="0" dirty="0"/>
-              <a:t>One sentence per box. Weeks 1-2 cover the three teal boxes: problem, question, search.</a:t>
+              <a:t>One sentence per box. Weeks 1-2 cover the three teal boxes.</a:t>
             </a:r>
           </a:p>
           <a:p>
             <a:r>
               <a:rPr lang="en-US" sz="1400" b="0" dirty="0"/>
-              <a:t>Misconception: 'research = collecting data'. Data come after the question, design and ethics approval.</a:t>
+              <a:t>Point: data come after the question, the design and ethics approval.</a:t>
             </a:r>
           </a:p>
           <a:p>
@@ -1831,7 +1759,7 @@
           <a:p>
             <a:r>
               <a:rPr lang="en-US" sz="1400" b="0" dirty="0"/>
-              <a:t>Ask: 'Think of one thing in your department that colleagues do differently, where nobody knows which way is best. Type it in the chat.' Read two or three answers aloud.</a:t>
+              <a:t>Ask: 'What does your department do in different ways, where nobody knows which is best? Type it in the chat.' Read two or three aloud.</a:t>
             </a:r>
           </a:p>
           <a:p>
@@ -1924,19 +1852,13 @@
           <a:p>
             <a:r>
               <a:rPr lang="en-US" sz="1400" b="0" dirty="0"/>
-              <a:t>First three rows: what kind of data. Last two rows: where the data come from.</a:t>
+              <a:t>Point: qualitative research has its own rigorous methods.</a:t>
             </a:r>
           </a:p>
           <a:p>
             <a:r>
               <a:rPr lang="en-US" sz="1400" b="0" dirty="0"/>
-              <a:t>Misconception: 'qualitative research is just opinion'. It has its own rigorous methods.</a:t>
-            </a:r>
-          </a:p>
-          <a:p>
-            <a:r>
-              <a:rPr lang="en-US" sz="1400" b="0" dirty="0"/>
-              <a:t>Timing: 3 minutes. Qualitative designs return in Session 3.</a:t>
+              <a:t>Timing: 3 minutes.</a:t>
             </a:r>
           </a:p>
         </p:txBody>
@@ -2017,13 +1939,13 @@
           <a:p>
             <a:r>
               <a:rPr lang="en-US" sz="1400" b="0" dirty="0"/>
-              <a:t>Call on two or three people for short answers. The answers are on the next slide.</a:t>
+              <a:t>Call on two or three people. Answers are on the next slide.</a:t>
             </a:r>
           </a:p>
           <a:p>
             <a:r>
               <a:rPr lang="en-US" sz="1400" b="0" dirty="0"/>
-              <a:t>If people hesitate on C: the records were made for care, not for this study, so using them is secondary research.</a:t>
+              <a:t>If C causes doubt: the records were made for care, so using them is secondary research.</a:t>
             </a:r>
           </a:p>
           <a:p>
@@ -2110,13 +2032,7 @@
           <a:p>
             <a:r>
               <a:rPr lang="en-US" sz="1400" b="0" dirty="0"/>
-              <a:t>Two questions classify almost any study: what kind of data, and where they come from.</a:t>
-            </a:r>
-          </a:p>
-          <a:p>
-            <a:r>
-              <a:rPr lang="en-US" sz="1400" b="0" dirty="0"/>
-              <a:t>Secondary research is often the most feasible for a busy department, if the records are good (Session 5).</a:t>
+              <a:t>Secondary research is often the most feasible for a busy department, if the records are good.</a:t>
             </a:r>
           </a:p>
           <a:p>
@@ -2203,13 +2119,7 @@
           <a:p>
             <a:r>
               <a:rPr lang="en-US" sz="1400" b="0" dirty="0"/>
-              <a:t>Eleven stops. The colours show the weeks that teach each stop.</a:t>
-            </a:r>
-          </a:p>
-          <a:p>
-            <a:r>
-              <a:rPr lang="en-US" sz="1400" b="0" dirty="0"/>
-              <a:t>Stops 1-6 plan and do the study. Stops 7-11 publish it. Trials are registered before the first patient is enrolled. The road often takes one to three years, and many studies stall at stop 7.</a:t>
+              <a:t>Stops 1-6 plan and do the study. Stops 7-11 publish it.</a:t>
             </a:r>
           </a:p>
           <a:p>
@@ -2221,7 +2131,7 @@
           <a:p>
             <a:r>
               <a:rPr lang="en-US" sz="1400" b="0" dirty="0"/>
-              <a:t>Timing: 3 minutes, then 3 minutes for questions. Segment 1.1 ends at 1:10 (20:40).</a:t>
+              <a:t>Timing: 3 minutes + 3 minutes for questions. 1.1 ends at 20:40.</a:t>
             </a:r>
           </a:p>
         </p:txBody>
@@ -2302,7 +2212,7 @@
           <a:p>
             <a:r>
               <a:rPr lang="en-US" sz="1400" b="0" dirty="0"/>
-              <a:t>Break (1:10-1:25, 20:40-20:55). Post the restart time in the chat, and the link to the Session 1 exercise sheet: Exercise 1 is used after the break. Restart on time.</a:t>
+              <a:t>Break 20:40-20:55. Post the restart time and the link to the Session 1 exercise sheet in the chat.</a:t>
             </a:r>
           </a:p>
         </p:txBody>
@@ -2383,19 +2293,7 @@
           <a:p>
             <a:r>
               <a:rPr lang="en-US" sz="1400" b="0" dirty="0"/>
-              <a:t>Segment 1.2 (1:25-2:05, 20:55-21:35).</a:t>
-            </a:r>
-          </a:p>
-          <a:p>
-            <a:r>
-              <a:rPr lang="en-US" sz="1400" b="0" dirty="0"/>
-              <a:t>A vague worry ('are fluids bad?') must become a precise question before anything else can happen.</a:t>
-            </a:r>
-          </a:p>
-          <a:p>
-            <a:r>
-              <a:rPr lang="en-US" sz="1400" b="0" dirty="0"/>
-              <a:t>Timing: 30 seconds.</a:t>
+              <a:t>1.2 runs 20:55-21:35. Timing: 30 seconds.</a:t>
             </a:r>
           </a:p>
         </p:txBody>
@@ -2476,19 +2374,7 @@
           <a:p>
             <a:r>
               <a:rPr lang="en-US" sz="1400" b="0" dirty="0"/>
-              <a:t>Six common sources of questions, all from daily work.</a:t>
-            </a:r>
-          </a:p>
-          <a:p>
-            <a:r>
-              <a:rPr lang="en-US" sz="1400" b="0" dirty="0"/>
-              <a:t>Before calling something research, check whether the answer already exists. If it does, the job is to apply it.</a:t>
-            </a:r>
-          </a:p>
-          <a:p>
-            <a:r>
-              <a:rPr lang="en-US" sz="1400" b="0" dirty="0"/>
-              <a:t>Point back to the questions the class typed in the chat at the start.</a:t>
+              <a:t>Point back to the questions typed in the chat at the start.</a:t>
             </a:r>
           </a:p>
           <a:p>
@@ -2575,13 +2461,7 @@
           <a:p>
             <a:r>
               <a:rPr lang="en-US" sz="1400" b="0" dirty="0"/>
-              <a:t>PICO = Population, Intervention, Comparison, Outcome. T (Time) says when the outcome is measured.</a:t>
-            </a:r>
-          </a:p>
-          <a:p>
-            <a:r>
-              <a:rPr lang="en-US" sz="1400" b="0" dirty="0"/>
-              <a:t>Each letter forces a decision: which patients, restrictive how, compared with what, which outcome and when?</a:t>
+              <a:t>Each letter forces a decision.</a:t>
             </a:r>
           </a:p>
           <a:p>
@@ -2674,19 +2554,13 @@
           <a:p>
             <a:r>
               <a:rPr lang="en-US" sz="1400" b="0" dirty="0"/>
-              <a:t>Three examples from other wards. PECO is PICO with E (Exposure) in place of I: something patients have that the researcher does not assign, such as obesity or a positive fluid balance.</a:t>
+              <a:t>Row 3 asks how common something is, so it needs only P and O (and T).</a:t>
             </a:r>
           </a:p>
           <a:p>
             <a:r>
               <a:rPr lang="en-US" sz="1400" b="0" dirty="0"/>
-              <a:t>Row 3 only needs P and O (and T): it asks how common something is.</a:t>
-            </a:r>
-          </a:p>
-          <a:p>
-            <a:r>
-              <a:rPr lang="en-US" sz="1400" b="0" dirty="0"/>
-              <a:t>Ask: 'Make a PECO question about fluids.' Expected: in adults with sepsis, is a positive fluid balance by day 3, compared with a neutral or negative balance, associated with death by day 28? This is Paper 2's question.</a:t>
+              <a:t>Ask: 'Make a PECO question about fluids.' Expected: in adults with sepsis, is a positive fluid balance by day 3, compared with a neutral or negative balance, associated with death by day 28? (Paper 2's question.)</a:t>
             </a:r>
           </a:p>
           <a:p>
@@ -2773,13 +2647,13 @@
           <a:p>
             <a:r>
               <a:rPr lang="en-US" sz="1400" b="0" dirty="0"/>
-              <a:t>Read the question slowly. Give 1 minute for the poll. Answer: C. D is the time (T), A is part of P, B is I.</a:t>
+              <a:t>Read the question slowly. 1 minute for the poll. Answer: C. D is T, A is part of P, B is I.</a:t>
             </a:r>
           </a:p>
           <a:p>
             <a:r>
               <a:rPr lang="en-US" sz="1400" b="0" dirty="0"/>
-              <a:t>Watch for 'septic shock' chosen as the outcome: it has already happened, so it defines who is eligible.</a:t>
+              <a:t>Watch for 'septic shock' chosen as O: it defines who is eligible.</a:t>
             </a:r>
           </a:p>
           <a:p>
@@ -2866,13 +2740,19 @@
           <a:p>
             <a:r>
               <a:rPr lang="en-US" sz="1400" b="0" dirty="0"/>
-              <a:t>Weeks 1-2: the question and the evidence. Weeks 3-4: design and bias. Weeks 5-6: data and analysis. Weeks 7-8: ethics, writing and publishing. One session every Saturday, with a week between sessions for homework.</a:t>
+              <a:t>Two sessions per block, one week between sessions.</a:t>
             </a:r>
           </a:p>
           <a:p>
             <a:r>
               <a:rPr lang="en-US" sz="1400" b="0" dirty="0"/>
-              <a:t>One running example travels with us: fluids in septic shock and 28-day mortality. From Session 5 it continues in the course study, FLUID-ICU.</a:t>
+              <a:t>One running example throughout: fluids in septic shock and 28-day mortality. From Session 5 it continues in the course study, FLUID-ICU.</a:t>
+            </a:r>
+          </a:p>
+          <a:p>
+            <a:r>
+              <a:rPr lang="en-US" sz="1400" b="0" dirty="0"/>
+              <a:t>What is expected: Proposal_Brief, sent before Session 1 with Presentation_Guide and Proposal_Rubric. The manuscript brief is shared in Session 6.</a:t>
             </a:r>
           </a:p>
           <a:p>
@@ -2959,13 +2839,7 @@
           <a:p>
             <a:r>
               <a:rPr lang="en-US" sz="1400" b="0" dirty="0"/>
-              <a:t>The outcome must be something that can happen after the intervention starts.</a:t>
-            </a:r>
-          </a:p>
-          <a:p>
-            <a:r>
-              <a:rPr lang="en-US" sz="1400" b="0" dirty="0"/>
-              <a:t>Paper 1's outcome is fluid balance, not death, so it cannot answer our 28-day mortality question.</a:t>
+              <a:t>Paper 1's outcome is fluid balance, so it cannot answer our mortality question.</a:t>
             </a:r>
           </a:p>
           <a:p>
@@ -3052,7 +2926,7 @@
           <a:p>
             <a:r>
               <a:rPr lang="en-US" sz="1400" b="0" dirty="0"/>
-              <a:t>The verbs give it away: 'how many' is descriptive, 'is associated with' is observational, 'does it reduce' implies a trial.</a:t>
+              <a:t>The verbs give it away: 'how many', 'is associated with', 'does it reduce'.</a:t>
             </a:r>
           </a:p>
           <a:p>
@@ -3145,12 +3019,6 @@
           <a:p>
             <a:r>
               <a:rPr lang="en-US" sz="1400" b="0" dirty="0"/>
-              <a:t>Left: the corridor question, every word undefined. Right: the same worry written with PICO(T).</a:t>
-            </a:r>
-          </a:p>
-          <a:p>
-            <a:r>
-              <a:rPr lang="en-US" sz="1400" b="0" dirty="0"/>
               <a:t>Ask: 'Make this answerable: Is albumin better?' Expected: in adults with septic shock, does albumin plus crystalloid, compared with crystalloid alone, reduce 28-day mortality?</a:t>
             </a:r>
           </a:p>
@@ -3238,19 +3106,7 @@
           <a:p>
             <a:r>
               <a:rPr lang="en-US" sz="1400" b="0" dirty="0"/>
-              <a:t>FINER = Feasible, Interesting, Novel, Ethical, Relevant (Hulley, Designing Clinical Research).</a:t>
-            </a:r>
-          </a:p>
-          <a:p>
-            <a:r>
-              <a:rPr lang="en-US" sz="1400" b="0" dirty="0"/>
-              <a:t>Feasible fails most often in hospital research: too few patients, or an outcome that is too rare.</a:t>
-            </a:r>
-          </a:p>
-          <a:p>
-            <a:r>
-              <a:rPr lang="en-US" sz="1400" b="0" dirty="0"/>
-              <a:t>Novel does not mean 'never studied': a new setting or a better design can be novel.</a:t>
+              <a:t>Feasible fails most often in hospital research. Novel can be a new setting or a better design.</a:t>
             </a:r>
           </a:p>
           <a:p>
@@ -3343,19 +3199,13 @@
           <a:p>
             <a:r>
               <a:rPr lang="en-US" sz="1400" b="0" dirty="0"/>
-              <a:t>F is red: a difference of a few percentage points in mortality needs well over a thousand patients. The CLASSIC (2022) and CLOVERS (2023) trials each randomised more than 1,500.</a:t>
+              <a:t>F is red: CLASSIC (2022) and CLOVERS (2023) each needed more than 1,500 patients.</a:t>
             </a:r>
           </a:p>
           <a:p>
             <a:r>
               <a:rPr lang="en-US" sz="1400" b="0" dirty="0"/>
-              <a:t>N is amber: those large trials found no difference in mortality. E is amber: consent in septic shock is hard (Session 7).</a:t>
-            </a:r>
-          </a:p>
-          <a:p>
-            <a:r>
-              <a:rPr lang="en-US" sz="1400" b="0" dirty="0"/>
-              <a:t>To make it smaller: change the outcome, run a pilot trial as Paper 1 did, or ask a descriptive question. The next slide does exactly this.</a:t>
+              <a:t>To make it smaller: change the outcome, run a pilot, or ask a descriptive question.</a:t>
             </a:r>
           </a:p>
           <a:p>
@@ -3442,37 +3292,31 @@
           <a:p>
             <a:r>
               <a:rPr lang="en-US" sz="1400" b="0" dirty="0"/>
-              <a:t>Share a blank Exercise 1 and type the answers as people give them, one person per letter.</a:t>
+              <a:t>Type the answers on a blank Exercise 1 as people give them, one person per letter.</a:t>
             </a:r>
           </a:p>
           <a:p>
             <a:r>
               <a:rPr lang="en-US" sz="1400" b="0" dirty="0"/>
-              <a:t>Most classes choose A or C. If the vote is split, take A: it is the pilot that Paper 1 ran, and the quick exercise in 1.3 uses it.</a:t>
+              <a:t>If the vote is split, take A (the pilot Paper 1 ran, used again in 1.3). B is a PECO question and the main FLUID-ICU question.</a:t>
             </a:r>
           </a:p>
           <a:p>
             <a:r>
               <a:rPr lang="en-US" sz="1400" b="0" dirty="0"/>
-              <a:t>Version B is a PECO question (fluid balance is an exposure). It is the main question of the FLUID-ICU course study.</a:t>
+              <a:t>Watch for: no comparison, no time point, two outcomes.</a:t>
             </a:r>
           </a:p>
           <a:p>
             <a:r>
               <a:rPr lang="en-US" sz="1400" b="0" dirty="0"/>
-              <a:t>Common problems: no comparison, an outcome without a time point, two outcomes in one question.</a:t>
+              <a:t>Key: s1_solutions, Exercise 1.</a:t>
             </a:r>
           </a:p>
           <a:p>
             <a:r>
               <a:rPr lang="en-US" sz="1400" b="0" dirty="0"/>
-              <a:t>Model answers: Course/Solutions/s1_solutions.md, Exercise 1.</a:t>
-            </a:r>
-          </a:p>
-          <a:p>
-            <a:r>
-              <a:rPr lang="en-US" sz="1400" b="0" dirty="0"/>
-              <a:t>Timing: 8 minutes work + 3 minutes summary. Segment 1.3 starts at 2:05 (21:35).</a:t>
+              <a:t>Timing: 8 minutes + 3 minutes summary. 1.3 starts at 21:35.</a:t>
             </a:r>
           </a:p>
         </p:txBody>
@@ -3553,19 +3397,7 @@
           <a:p>
             <a:r>
               <a:rPr lang="en-US" sz="1400" b="0" dirty="0"/>
-              <a:t>Segment 1.3 (2:05-2:25, 21:35-21:55).</a:t>
-            </a:r>
-          </a:p>
-          <a:p>
-            <a:r>
-              <a:rPr lang="en-US" sz="1400" b="0" dirty="0"/>
-              <a:t>The aim, objectives and hypothesis are the question written as a plan. Ethics committees read them first.</a:t>
-            </a:r>
-          </a:p>
-          <a:p>
-            <a:r>
-              <a:rPr lang="en-US" sz="1400" b="0" dirty="0"/>
-              <a:t>Timing: 30 seconds.</a:t>
+              <a:t>1.3 runs 21:35-21:55. Timing: 30 seconds.</a:t>
             </a:r>
           </a:p>
         </p:txBody>
@@ -3646,13 +3478,7 @@
           <a:p>
             <a:r>
               <a:rPr lang="en-US" sz="1400" b="0" dirty="0"/>
-              <a:t>The aim is the broad purpose ('To compare...', 'To describe...'). The objectives are specific, measurable steps.</a:t>
-            </a:r>
-          </a:p>
-          <a:p>
-            <a:r>
-              <a:rPr lang="en-US" sz="1400" b="0" dirty="0"/>
-              <a:t>Mark the primary objective: it decides the sample size (Session 6).</a:t>
+              <a:t>The primary objective decides the sample size (Session 6).</a:t>
             </a:r>
           </a:p>
           <a:p>
@@ -3739,12 +3565,6 @@
           <a:p>
             <a:r>
               <a:rPr lang="en-US" sz="1400" b="0" dirty="0"/>
-              <a:t>'To understand' can never be finished or checked. 'To compare fluid balance at day 5' names the outcome, the time and the comparison.</a:t>
-            </a:r>
-          </a:p>
-          <a:p>
-            <a:r>
-              <a:rPr lang="en-US" sz="1400" b="0" dirty="0"/>
               <a:t>Ask: 'Rewrite: to study fluid balance in our ICU.' Expected: to estimate the proportion of adults with septic shock in our ICU who have a positive fluid balance on day 3.</a:t>
             </a:r>
           </a:p>
@@ -3832,25 +3652,19 @@
           <a:p>
             <a:r>
               <a:rPr lang="en-US" sz="1400" b="0" dirty="0"/>
-              <a:t>H0, the null hypothesis: no difference. H1, the alternative: a difference, in either direction.</a:t>
+              <a:t>Analogy: a court assumes 'not guilty' (H0) until the evidence is strong. 'Not guilty' is not 'innocent'.</a:t>
             </a:r>
           </a:p>
           <a:p>
             <a:r>
               <a:rPr lang="en-US" sz="1400" b="0" dirty="0"/>
-              <a:t>Analogy: a court assumes 'not guilty' (H0) until the evidence is strong enough. 'Not guilty' is not 'innocent'.</a:t>
+              <a:t>Descriptive questions (version C) need no hypothesis.</a:t>
             </a:r>
           </a:p>
           <a:p>
             <a:r>
               <a:rPr lang="en-US" sz="1400" b="0" dirty="0"/>
-              <a:t>Purely descriptive questions (version C) estimate a number and need no hypothesis.</a:t>
-            </a:r>
-          </a:p>
-          <a:p>
-            <a:r>
-              <a:rPr lang="en-US" sz="1400" b="0" dirty="0"/>
-              <a:t>Timing: 3 minutes. P-values are Session 6.</a:t>
+              <a:t>Timing: 3 minutes. P-values are in Session 6.</a:t>
             </a:r>
           </a:p>
         </p:txBody>
@@ -3931,7 +3745,7 @@
           <a:p>
             <a:r>
               <a:rPr lang="en-US" sz="1400" b="0" dirty="0"/>
-              <a:t>Level 1 takes you from a clinical question to a paper. In it the trainers run the software and you read and interpret the results. Level 2 teaches statistical modelling in R. Level 3 covers advanced methods on request.</a:t>
+              <a:t>In Level 1 the trainers run the software. You read and interpret the results.</a:t>
             </a:r>
           </a:p>
           <a:p>
@@ -4018,13 +3832,13 @@
           <a:p>
             <a:r>
               <a:rPr lang="en-US" sz="1400" b="0" dirty="0"/>
-              <a:t>5 minutes writing alone, then 2 minutes for two or three people to read their primary objective.</a:t>
+              <a:t>5 minutes alone, then two or three people read their primary objective.</a:t>
             </a:r>
           </a:p>
           <a:p>
             <a:r>
               <a:rPr lang="en-US" sz="1400" b="0" dirty="0"/>
-              <a:t>Look for vague verbs, no time point, or a hypothesis about an outcome that is not in the objectives.</a:t>
+              <a:t>Watch for vague verbs, no time point, or a hypothesis about an outcome not in the objectives.</a:t>
             </a:r>
           </a:p>
           <a:p>
@@ -4111,19 +3925,19 @@
           <a:p>
             <a:r>
               <a:rPr lang="en-US" sz="1400" b="0" dirty="0"/>
-              <a:t>Check the chain: the question's O = the primary objective = the outcome in H0 and H1. Reviewers spot a break at once.</a:t>
+              <a:t>Check the chain: the question's O = the primary objective = the outcome in H0 and H1.</a:t>
             </a:r>
           </a:p>
           <a:p>
             <a:r>
               <a:rPr lang="en-US" sz="1400" b="0" dirty="0"/>
-              <a:t>Model answers: Course/Solutions/s1_solutions.md (Exercise 2).</a:t>
+              <a:t>Key: s1_solutions, Exercise 2.</a:t>
             </a:r>
           </a:p>
           <a:p>
             <a:r>
               <a:rPr lang="en-US" sz="1400" b="0" dirty="0"/>
-              <a:t>Timing: 3 minutes. Segment 1.3 ends at 2:25 (21:55).</a:t>
+              <a:t>Timing: 3 minutes. 1.3 ends at 21:55.</a:t>
             </a:r>
           </a:p>
         </p:txBody>
@@ -4204,13 +4018,7 @@
           <a:p>
             <a:r>
               <a:rPr lang="en-US" sz="1400" b="0" dirty="0"/>
-              <a:t>Proposal builder 1 (2:25-2:55, 21:55-22:25). Everyone writes their own proposal.</a:t>
-            </a:r>
-          </a:p>
-          <a:p>
-            <a:r>
-              <a:rPr lang="en-US" sz="1400" b="0" dirty="0"/>
-              <a:t>Move straight to the next slide.</a:t>
+              <a:t>Proposal builder 1 runs 21:55-22:25. Move straight to the next slide.</a:t>
             </a:r>
           </a:p>
         </p:txBody>
@@ -4291,31 +4099,25 @@
           <a:p>
             <a:r>
               <a:rPr lang="en-US" sz="1400" b="0" dirty="0"/>
-              <a:t>Minutes 0-8: share Course/Templates/Research_Proposal_Template.docx and fill Part 1 for version A, thinking aloud.</a:t>
+              <a:t>Minutes 0-8: share Research_Proposal_Template.docx and fill Part 1 for version A, thinking aloud.</a:t>
             </a:r>
           </a:p>
           <a:p>
             <a:r>
               <a:rPr lang="en-US" sz="1400" b="0" dirty="0"/>
-              <a:t>Minutes 8-25: everyone drafts alone. Cameras may go off. Answer questions in the chat.</a:t>
+              <a:t>Minutes 8-25: everyone drafts alone. Answer questions in the chat. No topic yet? Use the welcome chat, or version A or C for now.</a:t>
             </a:r>
           </a:p>
           <a:p>
             <a:r>
               <a:rPr lang="en-US" sz="1400" b="0" dirty="0"/>
-              <a:t>No topic yet? Look back at the questions in the welcome chat, or use version A or C for now.</a:t>
+              <a:t>Minutes 25-30: two volunteers read their question and aim.</a:t>
             </a:r>
           </a:p>
           <a:p>
             <a:r>
               <a:rPr lang="en-US" sz="1400" b="0" dirty="0"/>
-              <a:t>Minutes 25-30: two volunteers read their question and aim. Others suggest one improvement each.</a:t>
-            </a:r>
-          </a:p>
-          <a:p>
-            <a:r>
-              <a:rPr lang="en-US" sz="1400" b="0" dirty="0"/>
-              <a:t>Timing: 30 minutes. Wrap-up starts at 2:55 (22:25).</a:t>
+              <a:t>Timing: 30 minutes. Wrap-up at 22:25.</a:t>
             </a:r>
           </a:p>
         </p:txBody>
@@ -4396,13 +4198,7 @@
           <a:p>
             <a:r>
               <a:rPr lang="en-US" sz="1400" b="0" dirty="0"/>
-              <a:t>Wrap-up (2:55-3:00, 22:25-22:30). Read the six key words quickly. They are in the course glossary (EN-VN).</a:t>
-            </a:r>
-          </a:p>
-          <a:p>
-            <a:r>
-              <a:rPr lang="en-US" sz="1400" b="0" dirty="0"/>
-              <a:t>Timing: 1 minute.</a:t>
+              <a:t>Read the key words quickly. Timing: 1 minute.</a:t>
             </a:r>
           </a:p>
         </p:txBody>
@@ -4483,12 +4279,6 @@
           <a:p>
             <a:r>
               <a:rPr lang="en-US" sz="1400" b="0" dirty="0"/>
-              <a:t>Next Saturday (Session 2) we search PubMed live, manage references in Zotero and read a paper in 15 minutes.</a:t>
-            </a:r>
-          </a:p>
-          <a:p>
-            <a:r>
-              <a:rPr lang="en-US" sz="1400" b="0" dirty="0"/>
               <a:t>Timing: 1 minute.</a:t>
             </a:r>
           </a:p>
@@ -4570,13 +4360,13 @@
           <a:p>
             <a:r>
               <a:rPr lang="en-US" sz="1400" b="0" dirty="0"/>
-              <a:t>Not marked. Answers: Q1 Feasible: mortality needs well over a thousand patients. Q2 e.g. 'To estimate the proportion of adults with septic shock in our ICU who have a positive fluid balance on day 3'.</a:t>
+              <a:t>Answers: Q1 Feasible, mortality needs well over a thousand patients. Q2 e.g. 'To estimate the proportion of adults with septic shock in our ICU who have a positive fluid balance on day 3'.</a:t>
             </a:r>
           </a:p>
           <a:p>
             <a:r>
               <a:rPr lang="en-US" sz="1400" b="0" dirty="0"/>
-              <a:t>Save the chat and read the answers during the week. If many still use vague verbs, start Session 2 with one minute on objectives.</a:t>
+              <a:t>Save the chat. If many still use vague verbs, start Session 2 with one minute on objectives.</a:t>
             </a:r>
           </a:p>
           <a:p>
@@ -4663,19 +4453,19 @@
           <a:p>
             <a:r>
               <a:rPr lang="en-US" sz="1400" b="0" dirty="0"/>
-              <a:t>About 45 minutes during the week. The synonyms speed up next Saturday's search, because PubMed works in English.</a:t>
+              <a:t>About 45 minutes of work. PubMed works in English, so the synonyms speed up the search.</a:t>
             </a:r>
           </a:p>
           <a:p>
             <a:r>
               <a:rPr lang="en-US" sz="1400" b="0" dirty="0"/>
-              <a:t>Zotero is needed in Session 2: Zotero desktop, the browser Connector and the Word plug-in (zotero.org/download). Anyone with problems emails the trainers before Friday.</a:t>
+              <a:t>Anyone with Zotero problems emails the trainers before Friday.</a:t>
             </a:r>
           </a:p>
           <a:p>
             <a:r>
               <a:rPr lang="en-US" sz="1400" b="0" dirty="0"/>
-              <a:t>Close on time. Timing: 1 minute.</a:t>
+              <a:t>Timing: 1 minute. Close on time.</a:t>
             </a:r>
           </a:p>
         </p:txBody>
@@ -4756,7 +4546,7 @@
           <a:p>
             <a:r>
               <a:rPr lang="en-US" sz="1400" b="0" dirty="0"/>
-              <a:t>Extra slides (Session 1). Optional: use them if the class is fast, or point participants to them for self-study.</a:t>
+              <a:t>Optional. Use if time allows, or for self-study.</a:t>
             </a:r>
           </a:p>
         </p:txBody>
@@ -4837,19 +4627,7 @@
           <a:p>
             <a:r>
               <a:rPr lang="en-US" sz="1400" b="0" dirty="0"/>
-              <a:t>Extra, for when someone asks whether their project needs ethics approval.</a:t>
-            </a:r>
-          </a:p>
-          <a:p>
-            <a:r>
-              <a:rPr lang="en-US" sz="1400" b="0" dirty="0"/>
-              <a:t>Audit compares practice with an agreed standard. Quality improvement (QI) changes a local process in small Plan-Do-Study-Act cycles. If a project randomises, adds a new risk or collects data beyond routine care, it is research.</a:t>
-            </a:r>
-          </a:p>
-          <a:p>
-            <a:r>
-              <a:rPr lang="en-US" sz="1400" b="0" dirty="0"/>
-              <a:t>Rules differ between institutions: check the local policy. Ethics approval is Session 7.</a:t>
+              <a:t>Use if someone asks whether their project needs ethics approval. If it randomises, adds risk or collects data beyond routine care, it is research. Check the local policy.</a:t>
             </a:r>
           </a:p>
           <a:p>
@@ -4936,25 +4714,19 @@
           <a:p>
             <a:r>
               <a:rPr lang="en-US" sz="1400" b="0" dirty="0"/>
-              <a:t>Proposal: built one part at a time in class, submitted in Session 8. A few volunteers also present theirs (6 minutes each).</a:t>
+              <a:t>Proposal: about 5 volunteers present in Session 8 (6 minutes each). Everyone submits the proposal and 6 slides by email. Details: Proposal_Brief, sent by email before Session 1.</a:t>
             </a:r>
           </a:p>
           <a:p>
             <a:r>
               <a:rPr lang="en-US" sz="1400" b="0" dirty="0"/>
-              <a:t>Manuscript: FLUID-ICU is a course study of 620 ICU patients with sepsis, with five questions (Q1 to Q5). Each person chooses one, receives its tables and figures, and writes the paper. After Session 8 each person reviews one colleague's draft.</a:t>
+              <a:t>Results section: at the end of Session 6 each person chooses one FLUID-ICU question (Q1 to Q5) and writes its Results from the results pack. After Session 8 each person reviews one colleague's draft.</a:t>
             </a:r>
           </a:p>
           <a:p>
             <a:r>
               <a:rPr lang="en-US" sz="1400" b="0" dirty="0"/>
-              <a:t>Both are written in English. Vietnamese is accepted if English is impossible.</a:t>
-            </a:r>
-          </a:p>
-          <a:p>
-            <a:r>
-              <a:rPr lang="en-US" sz="1400" b="0" dirty="0"/>
-              <a:t>Briefs: Course/Assignment/proposal_brief and manuscript_brief.</a:t>
+              <a:t>Write in English. Vietnamese is accepted if English is impossible.</a:t>
             </a:r>
           </a:p>
           <a:p>
@@ -5041,19 +4813,13 @@
           <a:p>
             <a:r>
               <a:rPr lang="en-US" sz="1400" b="0" dirty="0"/>
-              <a:t>Backup slide for 'Three more examples: PICO, PECO and P + O' (reviewer request).</a:t>
+              <a:t>Backup for 'Three more examples'. People write one question per row in the chat, then show this slide.</a:t>
             </a:r>
           </a:p>
           <a:p>
             <a:r>
               <a:rPr lang="en-US" sz="1400" b="0" dirty="0"/>
-              <a:t>Use it as a short exercise: participants write one question per row in the chat, or you call on two or three people (microphone on). Then show this slide.</a:t>
-            </a:r>
-          </a:p>
-          <a:p>
-            <a:r>
-              <a:rPr lang="en-US" sz="1400" b="0" dirty="0"/>
-              <a:t>Point out: the treatment question says 'reduce' because the checklist is assigned. The PECO question says 'associated with' because obesity is not assigned. The 'how common' question has no comparison.</a:t>
+              <a:t>Point: 'reduce' for the assigned checklist, 'associated with' for obesity, no comparison for 'how common'.</a:t>
             </a:r>
           </a:p>
           <a:p>
@@ -5140,13 +4906,7 @@
           <a:p>
             <a:r>
               <a:rPr lang="en-US" sz="1400" b="0" dirty="0"/>
-              <a:t>Extra. Diagnosis: the new test is I, the reference standard is C, the outcome is accuracy (Session 4).</a:t>
-            </a:r>
-          </a:p>
-          <a:p>
-            <a:r>
-              <a:rPr lang="en-US" sz="1400" b="0" dirty="0"/>
-              <a:t>Prognosis: PECO plus a time frame. Qualitative questions often use SPIDER (Cooke and colleagues, 2012).</a:t>
+              <a:t>Diagnosis: new test = I, reference standard = C, outcome = accuracy. Qualitative questions often use SPIDER (Cooke 2012).</a:t>
             </a:r>
           </a:p>
           <a:p>
@@ -5233,7 +4993,7 @@
           <a:p>
             <a:r>
               <a:rPr lang="en-US" sz="1400" b="0" dirty="0"/>
-              <a:t>Extra. Answers: 1 Feasible (huge and long). 2 Ethical (withholding antibiotics causes harm). 3 Novel (already measured every month). 4 Relevant (no plausible effect on practice).</a:t>
+              <a:t>Answers: 1 Feasible. 2 Ethical. 3 Novel. 4 Relevant.</a:t>
             </a:r>
           </a:p>
           <a:p>
@@ -5320,7 +5080,7 @@
           <a:p>
             <a:r>
               <a:rPr lang="en-US" sz="1400" b="0" dirty="0"/>
-              <a:t>Extra. This is a PECO (observational) question: nurses cannot easily be randomised to night shifts.</a:t>
+              <a:t>A PECO question: nurses cannot easily be randomised to night shifts.</a:t>
             </a:r>
           </a:p>
           <a:p>
@@ -5407,7 +5167,7 @@
           <a:p>
             <a:r>
               <a:rPr lang="en-US" sz="1400" b="0" dirty="0"/>
-              <a:t>Copyright slide. Leave it on screen while participants leave the meeting.</a:t>
+              <a:t>Leave on screen while people leave the meeting.</a:t>
             </a:r>
           </a:p>
         </p:txBody>
@@ -5488,13 +5248,7 @@
           <a:p>
             <a:r>
               <a:rPr lang="en-US" sz="1400" b="0" dirty="0"/>
-              <a:t>One card per two-week block. The aim is understanding and interpretation, not calculation.</a:t>
-            </a:r>
-          </a:p>
-          <a:p>
-            <a:r>
-              <a:rPr lang="en-US" sz="1400" b="0" dirty="0"/>
-              <a:t>Ask: 'Which card worries you most? Answer in the chat.' Usually: analyse. Reassure: we go slowly and check understanding often.</a:t>
+              <a:t>Ask: 'Which card worries you most? Answer in the chat.' Usually analysis. Reassure: we go slowly and check often.</a:t>
             </a:r>
           </a:p>
           <a:p>
@@ -5581,13 +5335,7 @@
           <a:p>
             <a:r>
               <a:rPr lang="en-US" sz="1400" b="0" dirty="0"/>
-              <a:t>The same rhythm every Saturday: recap, two teaching blocks with checks and short tasks, a 15-minute break, then time to build your proposal or paper.</a:t>
-            </a:r>
-          </a:p>
-          <a:p>
-            <a:r>
-              <a:rPr lang="en-US" sz="1400" b="0" dirty="0"/>
-              <a:t>Each session ends with extra slides that we use only if there is time. You can read them at home.</a:t>
+              <a:t>The same rhythm every Saturday. Extra slides at the end are used only if there is time.</a:t>
             </a:r>
           </a:p>
           <a:p>
@@ -5674,13 +5422,13 @@
           <a:p>
             <a:r>
               <a:rPr lang="en-US" sz="1400" b="0" dirty="0"/>
-              <a:t>In each proposal-builder slot the trainer first fills in the part for the running example on a shared screen. Then you write the same part for your own question.</a:t>
+              <a:t>In each proposal builder the trainer first fills in the part for the running example on screen. Then everyone writes the same part for their own question.</a:t>
             </a:r>
           </a:p>
           <a:p>
             <a:r>
               <a:rPr lang="en-US" sz="1400" b="0" dirty="0"/>
-              <a:t>Template: Course/Templates/Research_Proposal_Template.docx (sent by email before Session 1).</a:t>
+              <a:t>Template: Research_Proposal_Template.docx (EN) or Research_Proposal_Template_VN.docx (VN), emailed with the proposal brief before Session 1.</a:t>
             </a:r>
           </a:p>
           <a:p>
@@ -5767,19 +5515,13 @@
           <a:p>
             <a:r>
               <a:rPr lang="en-US" sz="1400" b="0" dirty="0"/>
-              <a:t>About 30 doctors and nurses join from home. We work as one class: no groups.</a:t>
+              <a:t>Give 3 minutes for typing. Then call on 4 or 5 people and point out shared themes (fluids, sedation, infection, mobilisation, medication safety).</a:t>
             </a:r>
           </a:p>
           <a:p>
             <a:r>
               <a:rPr lang="en-US" sz="1400" b="0" dirty="0"/>
-              <a:t>Give 3 minutes for typing. Then call on 4-5 people to say their question, and point out shared themes (fluids, sedation, infection, mobilisation, medication safety).</a:t>
-            </a:r>
-          </a:p>
-          <a:p>
-            <a:r>
-              <a:rPr lang="en-US" sz="1400" b="0" dirty="0"/>
-              <a:t>The questions stay in the chat. In Proposal builder 1 people can scroll back to them.</a:t>
+              <a:t>The questions stay in the chat for Proposal builder 1.</a:t>
             </a:r>
           </a:p>
           <a:p>
@@ -29830,7 +29572,7 @@
                 <a:latin typeface="Arial"/>
                 <a:cs typeface="Arial"/>
               </a:rPr>
-              <a:t>manuscript</a:t>
+              <a:t>Results section</a:t>
             </a:r>
           </a:p>
         </p:txBody>
@@ -38052,7 +37794,7 @@
                 <a:latin typeface="Arial"/>
                 <a:cs typeface="Arial"/>
               </a:rPr>
-              <a:t>Primary: to compare cumulative fluid balance at day 5 between groups</a:t>
+              <a:t>Primary: to compare cumulative fluid balance (ml/kg) at day 5 between groups</a:t>
             </a:r>
           </a:p>
           <a:p>
@@ -38073,7 +37815,7 @@
                 <a:latin typeface="Arial"/>
                 <a:cs typeface="Arial"/>
               </a:rPr>
-              <a:t>Secondary: to estimate the recruitment rate and protocol adherence</a:t>
+              <a:t>Secondary: to estimate recruitment rate and protocol adherence (feasibility)</a:t>
             </a:r>
           </a:p>
         </p:txBody>
@@ -38165,7 +37907,7 @@
                 <a:latin typeface="Arial"/>
                 <a:cs typeface="Arial"/>
               </a:rPr>
-              <a:t>H0: fluid balance at day 5 is the same in both groups</a:t>
+              <a:t>H0: cumulative fluid balance at day 5 is the same in both groups</a:t>
             </a:r>
           </a:p>
           <a:p>
@@ -38186,7 +37928,7 @@
                 <a:latin typeface="Arial"/>
                 <a:cs typeface="Arial"/>
               </a:rPr>
-              <a:t>H1: it differs between the groups</a:t>
+              <a:t>H1: it differs</a:t>
             </a:r>
           </a:p>
         </p:txBody>
@@ -42405,7 +42147,7 @@
                 <a:latin typeface="Arial"/>
                 <a:cs typeface="Arial"/>
               </a:rPr>
-              <a:t>Both are individual work. We guide every step in class.</a:t>
+              <a:t>Both are individual work. Each brief says what is expected and how it is assessed.</a:t>
             </a:r>
           </a:p>
         </p:txBody>
@@ -42418,7 +42160,7 @@
         </p:nvSpPr>
         <p:spPr>
           <a:xfrm>
-            <a:off x="457200" y="2203761"/>
+            <a:off x="457200" y="2001619"/>
             <a:ext cx="5538800" cy="640000"/>
           </a:xfrm>
           <a:prstGeom prst="rect">
@@ -42461,8 +42203,8 @@
         </p:nvSpPr>
         <p:spPr>
           <a:xfrm>
-            <a:off x="457200" y="2843761"/>
-            <a:ext cx="5538800" cy="1318716"/>
+            <a:off x="457200" y="2641619"/>
+            <a:ext cx="5538800" cy="1925141"/>
           </a:xfrm>
           <a:prstGeom prst="rect">
             <a:avLst/>
@@ -42518,7 +42260,7 @@
                 <a:latin typeface="Arial"/>
                 <a:cs typeface="Arial"/>
               </a:rPr>
-              <a:t>Built one part at a time, Sessions 1 to 7</a:t>
+              <a:t>Built part by part in Sessions 1 to 7</a:t>
             </a:r>
           </a:p>
           <a:p>
@@ -42539,80 +42281,9 @@
                 <a:latin typeface="Arial"/>
                 <a:cs typeface="Arial"/>
               </a:rPr>
-              <a:t>Submitted in Session 8</a:t>
-            </a:r>
-          </a:p>
-        </p:txBody>
-      </p:sp>
-      <p:sp>
-        <p:nvSpPr>
-          <p:cNvPr id="72" name="CardHead"/>
-          <p:cNvSpPr/>
-          <p:nvPr/>
-        </p:nvSpPr>
-        <p:spPr>
-          <a:xfrm>
-            <a:off x="6196000" y="2203761"/>
-            <a:ext cx="5538800" cy="640000"/>
-          </a:xfrm>
-          <a:prstGeom prst="rect">
-            <a:avLst/>
-          </a:prstGeom>
-          <a:solidFill>
-            <a:srgbClr val="0B376C"/>
-          </a:solidFill>
-          <a:ln>
-            <a:noFill/>
-          </a:ln>
-        </p:spPr>
-        <p:txBody>
-          <a:bodyPr wrap="square" lIns="91440" tIns="45720" rIns="91440" bIns="45720" rtlCol="0" anchor="ctr">
-            <a:normAutofit/>
-          </a:bodyPr>
-          <a:lstStyle/>
-          <a:p>
-            <a:pPr marL="0" indent="0" algn="ctr">
-              <a:buNone/>
-            </a:pPr>
-            <a:r>
-              <a:rPr lang="en-US" sz="1900" b="1" dirty="0">
-                <a:solidFill>
-                  <a:srgbClr val="FFFFFF"/>
-                </a:solidFill>
-                <a:latin typeface="Arial"/>
-                <a:cs typeface="Arial"/>
-              </a:rPr>
-              <a:t>A draft manuscript</a:t>
-            </a:r>
-          </a:p>
-        </p:txBody>
-      </p:sp>
-      <p:sp>
-        <p:nvSpPr>
-          <p:cNvPr id="73" name="CardBody"/>
-          <p:cNvSpPr/>
-          <p:nvPr/>
-        </p:nvSpPr>
-        <p:spPr>
-          <a:xfrm>
-            <a:off x="6196000" y="2843761"/>
-            <a:ext cx="5538800" cy="1318716"/>
-          </a:xfrm>
-          <a:prstGeom prst="rect">
-            <a:avLst/>
-          </a:prstGeom>
-          <a:solidFill>
-            <a:srgbClr val="EAF2F5"/>
-          </a:solidFill>
-          <a:ln>
-            <a:noFill/>
-          </a:ln>
-        </p:spPr>
-        <p:txBody>
-          <a:bodyPr wrap="square" lIns="137160" tIns="91440" rIns="137160" bIns="91440" rtlCol="0" anchor="ctr">
-            <a:normAutofit/>
-          </a:bodyPr>
-          <a:lstStyle/>
+              <a:t>Submitted in Session 8 (about 5 volunteers present)</a:t>
+            </a:r>
+          </a:p>
           <a:p>
             <a:pPr marL="0" indent="0" algn="ctr">
               <a:lnSpc>
@@ -42631,9 +42302,80 @@
                 <a:latin typeface="Arial"/>
                 <a:cs typeface="Arial"/>
               </a:rPr>
-              <a:t>Based on the course study, FLUID-ICU</a:t>
-            </a:r>
-          </a:p>
+              <a:t>Proposal brief: sent before Session 1</a:t>
+            </a:r>
+          </a:p>
+        </p:txBody>
+      </p:sp>
+      <p:sp>
+        <p:nvSpPr>
+          <p:cNvPr id="72" name="CardHead"/>
+          <p:cNvSpPr/>
+          <p:nvPr/>
+        </p:nvSpPr>
+        <p:spPr>
+          <a:xfrm>
+            <a:off x="6196000" y="2001619"/>
+            <a:ext cx="5538800" cy="640000"/>
+          </a:xfrm>
+          <a:prstGeom prst="rect">
+            <a:avLst/>
+          </a:prstGeom>
+          <a:solidFill>
+            <a:srgbClr val="0B376C"/>
+          </a:solidFill>
+          <a:ln>
+            <a:noFill/>
+          </a:ln>
+        </p:spPr>
+        <p:txBody>
+          <a:bodyPr wrap="square" lIns="91440" tIns="45720" rIns="91440" bIns="45720" rtlCol="0" anchor="ctr">
+            <a:normAutofit/>
+          </a:bodyPr>
+          <a:lstStyle/>
+          <a:p>
+            <a:pPr marL="0" indent="0" algn="ctr">
+              <a:buNone/>
+            </a:pPr>
+            <a:r>
+              <a:rPr lang="en-US" sz="1900" b="1" dirty="0">
+                <a:solidFill>
+                  <a:srgbClr val="FFFFFF"/>
+                </a:solidFill>
+                <a:latin typeface="Arial"/>
+                <a:cs typeface="Arial"/>
+              </a:rPr>
+              <a:t>A Results section, ready to submit</a:t>
+            </a:r>
+          </a:p>
+        </p:txBody>
+      </p:sp>
+      <p:sp>
+        <p:nvSpPr>
+          <p:cNvPr id="73" name="CardBody"/>
+          <p:cNvSpPr/>
+          <p:nvPr/>
+        </p:nvSpPr>
+        <p:spPr>
+          <a:xfrm>
+            <a:off x="6196000" y="2641619"/>
+            <a:ext cx="5538800" cy="1925141"/>
+          </a:xfrm>
+          <a:prstGeom prst="rect">
+            <a:avLst/>
+          </a:prstGeom>
+          <a:solidFill>
+            <a:srgbClr val="EAF2F5"/>
+          </a:solidFill>
+          <a:ln>
+            <a:noFill/>
+          </a:ln>
+        </p:spPr>
+        <p:txBody>
+          <a:bodyPr wrap="square" lIns="137160" tIns="91440" rIns="137160" bIns="91440" rtlCol="0" anchor="ctr">
+            <a:normAutofit/>
+          </a:bodyPr>
+          <a:lstStyle/>
           <a:p>
             <a:pPr marL="0" indent="0" algn="ctr">
               <a:lnSpc>
@@ -42652,7 +42394,7 @@
                 <a:latin typeface="Arial"/>
                 <a:cs typeface="Arial"/>
               </a:rPr>
-              <a:t>We give you the results. You write the paper</a:t>
+              <a:t>For one FLUID-ICU question</a:t>
             </a:r>
           </a:p>
           <a:p>
@@ -42673,7 +42415,28 @@
                 <a:latin typeface="Arial"/>
                 <a:cs typeface="Arial"/>
               </a:rPr>
-              <a:t>Then you review one colleague's draft</a:t>
+              <a:t>Methods, Introduction, Discussion and Abstract are optional</a:t>
+            </a:r>
+          </a:p>
+          <a:p>
+            <a:pPr marL="0" indent="0" algn="ctr">
+              <a:lnSpc>
+                <a:spcPct val="104000"/>
+              </a:lnSpc>
+              <a:spcBef>
+                <a:spcPts val="400"/>
+              </a:spcBef>
+              <a:buNone/>
+            </a:pPr>
+            <a:r>
+              <a:rPr lang="en-US" sz="1750" dirty="0">
+                <a:solidFill>
+                  <a:srgbClr val="000000"/>
+                </a:solidFill>
+                <a:latin typeface="Arial"/>
+                <a:cs typeface="Arial"/>
+              </a:rPr>
+              <a:t>Manuscript brief: shared in Session 6</a:t>
             </a:r>
           </a:p>
         </p:txBody>
@@ -46761,7 +46524,7 @@
                 <a:latin typeface="Arial"/>
                 <a:cs typeface="Arial"/>
               </a:rPr>
-              <a:t>Build your proposal or paper</a:t>
+              <a:t>Build your proposal or Results</a:t>
             </a:r>
           </a:p>
         </p:txBody>

</xml_diff>